<commit_message>
style(ppt): increase font sizes to 10-12pt and apply elegant SIH light theme to all cards and boxes
</commit_message>
<xml_diff>
--- a/SIH26163_ARGUS_Idea_PPT_Color.pptx
+++ b/SIH26163_ARGUS_Idea_PPT_Color.pptx
@@ -1477,7 +1477,7 @@
             <a:avLst/>
           </a:prstGeom>
           <a:solidFill>
-            <a:srgbClr val="0F172A"/>
+            <a:srgbClr val="1E3A8A"/>
           </a:solidFill>
           <a:ln w="12700">
             <a:solidFill>
@@ -1604,11 +1604,11 @@
             <a:avLst/>
           </a:prstGeom>
           <a:solidFill>
-            <a:srgbClr val="1E3A8A"/>
+            <a:srgbClr val="EFF6FF"/>
           </a:solidFill>
           <a:ln w="12700">
             <a:solidFill>
-              <a:srgbClr val="1B5FAE"/>
+              <a:srgbClr val="BFDBFE"/>
             </a:solidFill>
             <a:prstDash val="solid"/>
           </a:ln>
@@ -1642,7 +1642,7 @@
               <a:buNone/>
             </a:pPr>
             <a:r>
-              <a:rPr sz="1100" b="1">
+              <a:rPr sz="1200" b="1">
                 <a:solidFill>
                   <a:srgbClr val="0F172A"/>
                 </a:solidFill>
@@ -1669,11 +1669,11 @@
             <a:avLst/>
           </a:prstGeom>
           <a:solidFill>
-            <a:srgbClr val="1E3A8A"/>
+            <a:srgbClr val="EFF6FF"/>
           </a:solidFill>
           <a:ln w="12700">
             <a:solidFill>
-              <a:srgbClr val="1B5FAE"/>
+              <a:srgbClr val="BFDBFE"/>
             </a:solidFill>
             <a:prstDash val="solid"/>
           </a:ln>
@@ -1707,9 +1707,9 @@
               <a:buNone/>
             </a:pPr>
             <a:r>
-              <a:rPr sz="1100" b="0">
-                <a:solidFill>
-                  <a:srgbClr val="1E293B"/>
+              <a:rPr sz="1150" b="0">
+                <a:solidFill>
+                  <a:srgbClr val="0F172A"/>
                 </a:solidFill>
                 <a:latin typeface="Calibri"/>
               </a:rPr>
@@ -1734,11 +1734,11 @@
             <a:avLst/>
           </a:prstGeom>
           <a:solidFill>
-            <a:srgbClr val="1E3A8A"/>
+            <a:srgbClr val="EFF6FF"/>
           </a:solidFill>
           <a:ln w="12700">
             <a:solidFill>
-              <a:srgbClr val="1B5FAE"/>
+              <a:srgbClr val="BFDBFE"/>
             </a:solidFill>
             <a:prstDash val="solid"/>
           </a:ln>
@@ -1772,9 +1772,9 @@
               <a:buNone/>
             </a:pPr>
             <a:r>
-              <a:rPr sz="1100" b="0">
-                <a:solidFill>
-                  <a:srgbClr val="1E293B"/>
+              <a:rPr sz="1150" b="0">
+                <a:solidFill>
+                  <a:srgbClr val="0F172A"/>
                 </a:solidFill>
                 <a:latin typeface="Calibri"/>
               </a:rPr>
@@ -1799,11 +1799,11 @@
             <a:avLst/>
           </a:prstGeom>
           <a:solidFill>
-            <a:srgbClr val="1E3A8A"/>
+            <a:srgbClr val="EFF6FF"/>
           </a:solidFill>
           <a:ln w="12700">
             <a:solidFill>
-              <a:srgbClr val="1B5FAE"/>
+              <a:srgbClr val="BFDBFE"/>
             </a:solidFill>
             <a:prstDash val="solid"/>
           </a:ln>
@@ -1837,9 +1837,9 @@
               <a:buNone/>
             </a:pPr>
             <a:r>
-              <a:rPr sz="1100" b="0">
-                <a:solidFill>
-                  <a:srgbClr val="1E293B"/>
+              <a:rPr sz="1150" b="0">
+                <a:solidFill>
+                  <a:srgbClr val="0F172A"/>
                 </a:solidFill>
                 <a:latin typeface="Calibri"/>
               </a:rPr>
@@ -1864,11 +1864,11 @@
             <a:avLst/>
           </a:prstGeom>
           <a:solidFill>
-            <a:srgbClr val="1E3A8A"/>
+            <a:srgbClr val="EFF6FF"/>
           </a:solidFill>
           <a:ln w="12700">
             <a:solidFill>
-              <a:srgbClr val="1B5FAE"/>
+              <a:srgbClr val="BFDBFE"/>
             </a:solidFill>
             <a:prstDash val="solid"/>
           </a:ln>
@@ -1902,9 +1902,9 @@
               <a:buNone/>
             </a:pPr>
             <a:r>
-              <a:rPr sz="1100" b="0">
-                <a:solidFill>
-                  <a:srgbClr val="1E293B"/>
+              <a:rPr sz="1150" b="0">
+                <a:solidFill>
+                  <a:srgbClr val="0F172A"/>
                 </a:solidFill>
                 <a:latin typeface="Calibri"/>
               </a:rPr>
@@ -1953,11 +1953,11 @@
             <a:avLst/>
           </a:prstGeom>
           <a:solidFill>
-            <a:srgbClr val="0F172A"/>
-          </a:solidFill>
-          <a:ln w="12700">
-            <a:solidFill>
-              <a:srgbClr val="0E2A4A"/>
+            <a:srgbClr val="EFF6FF"/>
+          </a:solidFill>
+          <a:ln w="19050">
+            <a:solidFill>
+              <a:srgbClr val="1E3A8A"/>
             </a:solidFill>
             <a:prstDash val="solid"/>
           </a:ln>
@@ -1981,7 +1981,7 @@
           <a:ln/>
         </p:spPr>
         <p:txBody>
-          <a:bodyPr wrap="square" lIns="45720" tIns="36576" rIns="45720" bIns="36576" rtlCol="0" anchor="ctr"/>
+          <a:bodyPr wrap="square" lIns="45720" tIns="27432" rIns="45720" bIns="27432" rtlCol="0" anchor="ctr"/>
           <a:lstStyle/>
           <a:p>
             <a:pPr indent="0" marL="0" algn="l">
@@ -1993,20 +1993,20 @@
             <a:r>
               <a:rPr b="1" sz="1300">
                 <a:solidFill>
-                  <a:srgbClr val="FFFFFF"/>
-                </a:solidFill>
-                <a:latin typeface="Calibri"/>
-              </a:rPr>
-              <a:t>Idea:  ARGUS — Automated Risk &amp; Vulnerability Unified Scanner</a:t>
+                  <a:srgbClr val="0F172A"/>
+                </a:solidFill>
+                <a:latin typeface="Calibri"/>
+              </a:rPr>
+              <a:t>Idea Title:  ARGUS — Automated Risk &amp; Vulnerability Unified Scanner</a:t>
             </a:r>
             <a:endParaRPr lang="en-US" sz="1650" dirty="0"/>
           </a:p>
           <a:p>
             <a:pPr algn="l"/>
             <a:r>
-              <a:rPr b="0" sz="950">
-                <a:solidFill>
-                  <a:srgbClr val="CBD5E1"/>
+              <a:rPr b="0" sz="1050">
+                <a:solidFill>
+                  <a:srgbClr val="1E3A8A"/>
                 </a:solidFill>
                 <a:latin typeface="Calibri"/>
               </a:rPr>
@@ -2189,11 +2189,11 @@
             <a:avLst/>
           </a:prstGeom>
           <a:solidFill>
-            <a:srgbClr val="1E3A8A"/>
+            <a:srgbClr val="EFF6FF"/>
           </a:solidFill>
           <a:ln w="12700">
             <a:solidFill>
-              <a:srgbClr val="1B5FAE"/>
+              <a:srgbClr val="BFDBFE"/>
             </a:solidFill>
             <a:prstDash val="solid"/>
           </a:ln>
@@ -2302,7 +2302,7 @@
               <a:buNone/>
             </a:pPr>
             <a:r>
-              <a:rPr sz="1100" b="1">
+              <a:rPr sz="1200" b="1">
                 <a:solidFill>
                   <a:srgbClr val="0F172A"/>
                 </a:solidFill>
@@ -2339,9 +2339,9 @@
               <a:buNone/>
             </a:pPr>
             <a:r>
-              <a:rPr sz="850" b="0">
-                <a:solidFill>
-                  <a:srgbClr val="1E293B"/>
+              <a:rPr sz="1000" b="0">
+                <a:solidFill>
+                  <a:srgbClr val="0F172A"/>
                 </a:solidFill>
                 <a:latin typeface="Calibri"/>
               </a:rPr>
@@ -2376,7 +2376,7 @@
               <a:buNone/>
             </a:pPr>
             <a:r>
-              <a:rPr sz="1000" b="1">
+              <a:rPr sz="1100" b="1">
                 <a:solidFill>
                   <a:srgbClr val="0F172A"/>
                 </a:solidFill>
@@ -2405,11 +2405,11 @@
             </a:avLst>
           </a:prstGeom>
           <a:solidFill>
-            <a:srgbClr val="FFFFFF"/>
-          </a:solidFill>
-          <a:ln w="19050">
-            <a:solidFill>
-              <a:srgbClr val="000000"/>
+            <a:srgbClr val="F8FAFC"/>
+          </a:solidFill>
+          <a:ln w="12700">
+            <a:solidFill>
+              <a:srgbClr val="E2E8F0"/>
             </a:solidFill>
             <a:prstDash val="solid"/>
           </a:ln>
@@ -2433,7 +2433,7 @@
           <a:ln/>
         </p:spPr>
         <p:txBody>
-          <a:bodyPr wrap="square" lIns="45720" tIns="36576" rIns="45720" bIns="36576" rtlCol="0" anchor="t"/>
+          <a:bodyPr wrap="square" lIns="45720" tIns="27432" rIns="45720" bIns="27432" rtlCol="0" anchor="t"/>
           <a:lstStyle/>
           <a:p>
             <a:pPr marL="177800" indent="-177800" algn="l">
@@ -2444,9 +2444,9 @@
               <a:buChar char="•"/>
             </a:pPr>
             <a:r>
-              <a:rPr b="0" sz="750">
-                <a:solidFill>
-                  <a:srgbClr val="1E293B"/>
+              <a:rPr b="0" sz="1000">
+                <a:solidFill>
+                  <a:srgbClr val="0F172A"/>
                 </a:solidFill>
                 <a:latin typeface="Calibri"/>
               </a:rPr>
@@ -2457,9 +2457,9 @@
           <a:p>
             <a:pPr algn="l"/>
             <a:r>
-              <a:rPr b="0" sz="750">
-                <a:solidFill>
-                  <a:srgbClr val="1E293B"/>
+              <a:rPr b="0" sz="1000">
+                <a:solidFill>
+                  <a:srgbClr val="0F172A"/>
                 </a:solidFill>
                 <a:latin typeface="Calibri"/>
               </a:rPr>
@@ -2469,21 +2469,21 @@
           <a:p>
             <a:pPr algn="l"/>
             <a:r>
-              <a:rPr b="0" sz="750">
-                <a:solidFill>
-                  <a:srgbClr val="1E293B"/>
-                </a:solidFill>
-                <a:latin typeface="Calibri"/>
-              </a:rPr>
-              <a:t>3. Input Validation: 357 Trusted Types DOM sinks + Cloudflare DoH SSRF window.</a:t>
+              <a:rPr b="0" sz="1000">
+                <a:solidFill>
+                  <a:srgbClr val="0F172A"/>
+                </a:solidFill>
+                <a:latin typeface="Calibri"/>
+              </a:rPr>
+              <a:t>3. Input Validation: 357 Trusted Types DOM sinks + Cloudflare DoH SSRF rebinding window.</a:t>
             </a:r>
           </a:p>
           <a:p>
             <a:pPr algn="l"/>
             <a:r>
-              <a:rPr b="0" sz="750">
-                <a:solidFill>
-                  <a:srgbClr val="1E293B"/>
+              <a:rPr b="0" sz="1000">
+                <a:solidFill>
+                  <a:srgbClr val="0F172A"/>
                 </a:solidFill>
                 <a:latin typeface="Calibri"/>
               </a:rPr>
@@ -2493,33 +2493,33 @@
           <a:p>
             <a:pPr algn="l"/>
             <a:r>
-              <a:rPr b="0" sz="750">
-                <a:solidFill>
-                  <a:srgbClr val="1E293B"/>
-                </a:solidFill>
-                <a:latin typeface="Calibri"/>
-              </a:rPr>
-              <a:t>5. Client Controls: CSP script-src 'self' enforced; unescaped DOM writes in widgets.</a:t>
+              <a:rPr b="0" sz="1000">
+                <a:solidFill>
+                  <a:srgbClr val="0F172A"/>
+                </a:solidFill>
+                <a:latin typeface="Calibri"/>
+              </a:rPr>
+              <a:t>5. Client Controls: CSP script-src 'self' enforced; unescaped DOM writes in dashboard widgets.</a:t>
             </a:r>
           </a:p>
           <a:p>
             <a:pPr algn="l"/>
             <a:r>
-              <a:rPr b="0" sz="750">
-                <a:solidFill>
-                  <a:srgbClr val="1E293B"/>
-                </a:solidFill>
-                <a:latin typeface="Calibri"/>
-              </a:rPr>
-              <a:t>6. Secure Comms: Strict HTTPS/HSTS; Tauri IPC protected via CSPRNG LOCAL_API_TOKEN.</a:t>
+              <a:rPr b="0" sz="1000">
+                <a:solidFill>
+                  <a:srgbClr val="0F172A"/>
+                </a:solidFill>
+                <a:latin typeface="Calibri"/>
+              </a:rPr>
+              <a:t>6. Secure Comms: Strict HTTPS/HSTS; Tauri desktop IPC protected via CSPRNG token.</a:t>
             </a:r>
           </a:p>
           <a:p>
             <a:pPr algn="l"/>
             <a:r>
-              <a:rPr b="0" sz="750">
-                <a:solidFill>
-                  <a:srgbClr val="1E293B"/>
+              <a:rPr b="0" sz="1000">
+                <a:solidFill>
+                  <a:srgbClr val="0F172A"/>
                 </a:solidFill>
                 <a:latin typeface="Calibri"/>
               </a:rPr>
@@ -2584,11 +2584,11 @@
             </a:avLst>
           </a:prstGeom>
           <a:solidFill>
-            <a:srgbClr val="0F172A"/>
+            <a:srgbClr val="EFF6FF"/>
           </a:solidFill>
           <a:ln w="12700">
             <a:solidFill>
-              <a:srgbClr val="1B5FAE"/>
+              <a:srgbClr val="BFDBFE"/>
             </a:solidFill>
             <a:prstDash val="solid"/>
           </a:ln>
@@ -2668,9 +2668,9 @@
               <a:buNone/>
             </a:pPr>
             <a:r>
-              <a:rPr sz="900" b="1">
-                <a:solidFill>
-                  <a:srgbClr val="FFFFFF"/>
+              <a:rPr sz="1100" b="1">
+                <a:solidFill>
+                  <a:srgbClr val="1E3A8A"/>
                 </a:solidFill>
                 <a:latin typeface="Calibri"/>
               </a:rPr>
@@ -2705,13 +2705,13 @@
               <a:buNone/>
             </a:pPr>
             <a:r>
-              <a:rPr sz="750" b="0">
-                <a:solidFill>
-                  <a:srgbClr val="FFFFFF"/>
-                </a:solidFill>
-                <a:latin typeface="Calibri"/>
-              </a:rPr>
-              <a:t>SAST (Semgrep) + SCA (npm) + AST route parser (166 endpoints)</a:t>
+              <a:rPr sz="1000" b="0">
+                <a:solidFill>
+                  <a:srgbClr val="0F172A"/>
+                </a:solidFill>
+                <a:latin typeface="Calibri"/>
+              </a:rPr>
+              <a:t>SAST (Semgrep) + SCA (npm) + AST route parser (166 routes)</a:t>
             </a:r>
             <a:endParaRPr lang="en-US" sz="880" dirty="0"/>
           </a:p>
@@ -2758,11 +2758,11 @@
             </a:avLst>
           </a:prstGeom>
           <a:solidFill>
-            <a:srgbClr val="1E293B"/>
+            <a:srgbClr val="EFF6FF"/>
           </a:solidFill>
           <a:ln w="12700">
             <a:solidFill>
-              <a:srgbClr val="E8792A"/>
+              <a:srgbClr val="BFDBFE"/>
             </a:solidFill>
             <a:prstDash val="solid"/>
           </a:ln>
@@ -2842,9 +2842,9 @@
               <a:buNone/>
             </a:pPr>
             <a:r>
-              <a:rPr sz="900" b="1">
-                <a:solidFill>
-                  <a:srgbClr val="FFFFFF"/>
+              <a:rPr sz="1100" b="1">
+                <a:solidFill>
+                  <a:srgbClr val="1E3A8A"/>
                 </a:solidFill>
                 <a:latin typeface="Calibri"/>
               </a:rPr>
@@ -2879,9 +2879,9 @@
               <a:buNone/>
             </a:pPr>
             <a:r>
-              <a:rPr sz="750" b="0">
-                <a:solidFill>
-                  <a:srgbClr val="FFFFFF"/>
+              <a:rPr sz="1000" b="0">
+                <a:solidFill>
+                  <a:srgbClr val="0F172A"/>
                 </a:solidFill>
                 <a:latin typeface="Calibri"/>
               </a:rPr>
@@ -2932,11 +2932,11 @@
             </a:avLst>
           </a:prstGeom>
           <a:solidFill>
-            <a:srgbClr val="334155"/>
+            <a:srgbClr val="EFF6FF"/>
           </a:solidFill>
           <a:ln w="12700">
             <a:solidFill>
-              <a:srgbClr val="139488"/>
+              <a:srgbClr val="BFDBFE"/>
             </a:solidFill>
             <a:prstDash val="solid"/>
           </a:ln>
@@ -3016,9 +3016,9 @@
               <a:buNone/>
             </a:pPr>
             <a:r>
-              <a:rPr sz="900" b="1">
-                <a:solidFill>
-                  <a:srgbClr val="FFFFFF"/>
+              <a:rPr sz="1100" b="1">
+                <a:solidFill>
+                  <a:srgbClr val="1E3A8A"/>
                 </a:solidFill>
                 <a:latin typeface="Calibri"/>
               </a:rPr>
@@ -3053,9 +3053,9 @@
               <a:buNone/>
             </a:pPr>
             <a:r>
-              <a:rPr sz="750" b="0">
-                <a:solidFill>
-                  <a:srgbClr val="FFFFFF"/>
+              <a:rPr sz="1000" b="0">
+                <a:solidFill>
+                  <a:srgbClr val="0F172A"/>
                 </a:solidFill>
                 <a:latin typeface="Calibri"/>
               </a:rPr>
@@ -3106,11 +3106,11 @@
             </a:avLst>
           </a:prstGeom>
           <a:solidFill>
-            <a:srgbClr val="1E3A8A"/>
+            <a:srgbClr val="EFF6FF"/>
           </a:solidFill>
           <a:ln w="12700">
             <a:solidFill>
-              <a:srgbClr val="0E2A4A"/>
+              <a:srgbClr val="BFDBFE"/>
             </a:solidFill>
             <a:prstDash val="solid"/>
           </a:ln>
@@ -3131,11 +3131,11 @@
             <a:avLst/>
           </a:prstGeom>
           <a:solidFill>
-            <a:srgbClr val="FFFFFF"/>
+            <a:srgbClr val="F8FAFC"/>
           </a:solidFill>
           <a:ln w="12700">
             <a:solidFill>
-              <a:srgbClr val="FFFFFF"/>
+              <a:srgbClr val="E2E8F0"/>
             </a:solidFill>
             <a:prstDash val="solid"/>
           </a:ln>
@@ -3179,8 +3179,14 @@
           <a:prstGeom prst="rect">
             <a:avLst/>
           </a:prstGeom>
-          <a:noFill/>
-          <a:ln/>
+          <a:solidFill>
+            <a:srgbClr val="F8FAFC"/>
+          </a:solidFill>
+          <a:ln w="12700">
+            <a:solidFill>
+              <a:srgbClr val="E2E8F0"/>
+            </a:solidFill>
+          </a:ln>
         </p:spPr>
         <p:txBody>
           <a:bodyPr wrap="square" lIns="36576" tIns="18288" rIns="36576" bIns="18288" rtlCol="0" anchor="ctr"/>
@@ -3190,9 +3196,9 @@
               <a:buNone/>
             </a:pPr>
             <a:r>
-              <a:rPr sz="900" b="1">
-                <a:solidFill>
-                  <a:srgbClr val="FFFFFF"/>
+              <a:rPr sz="1100" b="1">
+                <a:solidFill>
+                  <a:srgbClr val="1E3A8A"/>
                 </a:solidFill>
                 <a:latin typeface="Calibri"/>
               </a:rPr>
@@ -3227,9 +3233,9 @@
               <a:buNone/>
             </a:pPr>
             <a:r>
-              <a:rPr sz="750" b="0">
-                <a:solidFill>
-                  <a:srgbClr val="FFFFFF"/>
+              <a:rPr sz="1000" b="0">
+                <a:solidFill>
+                  <a:srgbClr val="0F172A"/>
                 </a:solidFill>
                 <a:latin typeface="Calibri"/>
               </a:rPr>
@@ -3253,8 +3259,14 @@
           <a:prstGeom prst="rect">
             <a:avLst/>
           </a:prstGeom>
-          <a:noFill/>
-          <a:ln/>
+          <a:solidFill>
+            <a:srgbClr val="F8FAFC"/>
+          </a:solidFill>
+          <a:ln w="12700">
+            <a:solidFill>
+              <a:srgbClr val="E2E8F0"/>
+            </a:solidFill>
+          </a:ln>
         </p:spPr>
         <p:txBody>
           <a:bodyPr wrap="square" lIns="36576" tIns="18288" rIns="36576" bIns="18288" rtlCol="0" anchor="ctr"/>
@@ -3264,7 +3276,7 @@
               <a:buNone/>
             </a:pPr>
             <a:r>
-              <a:rPr sz="1000" b="1">
+              <a:rPr sz="1100" b="1">
                 <a:solidFill>
                   <a:srgbClr val="0F172A"/>
                 </a:solidFill>
@@ -3317,8 +3329,14 @@
           <a:prstGeom prst="rect">
             <a:avLst/>
           </a:prstGeom>
-          <a:noFill/>
-          <a:ln/>
+          <a:solidFill>
+            <a:srgbClr val="F8FAFC"/>
+          </a:solidFill>
+          <a:ln w="12700">
+            <a:solidFill>
+              <a:srgbClr val="E2E8F0"/>
+            </a:solidFill>
+          </a:ln>
         </p:spPr>
         <p:txBody>
           <a:bodyPr wrap="square" lIns="36576" tIns="18288" rIns="36576" bIns="18288" rtlCol="0" anchor="ctr"/>
@@ -3328,13 +3346,13 @@
               <a:buNone/>
             </a:pPr>
             <a:r>
-              <a:rPr sz="750" b="0">
-                <a:solidFill>
-                  <a:srgbClr val="1E293B"/>
-                </a:solidFill>
-                <a:latin typeface="Calibri"/>
-              </a:rPr>
-              <a:t>• Two-Signal Confirmation: Drops unverified scanner noise before PoC stage, cutting 80% triage time.</a:t>
+              <a:rPr sz="1000" b="0">
+                <a:solidFill>
+                  <a:srgbClr val="0F172A"/>
+                </a:solidFill>
+                <a:latin typeface="Calibri"/>
+              </a:rPr>
+              <a:t>• Two-Signal Confirmation: Drops unverified scanner noise, cutting 80% triage time.</a:t>
             </a:r>
             <a:endParaRPr lang="en-US" sz="920" dirty="0"/>
           </a:p>
@@ -3392,13 +3410,13 @@
               <a:buNone/>
             </a:pPr>
             <a:r>
-              <a:rPr sz="750" b="0">
-                <a:solidFill>
-                  <a:srgbClr val="1E293B"/>
-                </a:solidFill>
-                <a:latin typeface="Calibri"/>
-              </a:rPr>
-              <a:t>• Attack-Surface Graph: Correlates 166 Vercel Edge routes across 5 trust boundaries into actionable topology.</a:t>
+              <a:rPr sz="1000" b="0">
+                <a:solidFill>
+                  <a:srgbClr val="0F172A"/>
+                </a:solidFill>
+                <a:latin typeface="Calibri"/>
+              </a:rPr>
+              <a:t>• Attack-Surface Graph: Correlates 166 Vercel Edge routes across 5 trust boundaries.</a:t>
             </a:r>
             <a:endParaRPr lang="en-US" sz="920" dirty="0"/>
           </a:p>
@@ -3445,8 +3463,14 @@
           <a:prstGeom prst="rect">
             <a:avLst/>
           </a:prstGeom>
-          <a:noFill/>
-          <a:ln/>
+          <a:solidFill>
+            <a:srgbClr val="EFF6FF"/>
+          </a:solidFill>
+          <a:ln w="12700">
+            <a:solidFill>
+              <a:srgbClr val="BFDBFE"/>
+            </a:solidFill>
+          </a:ln>
         </p:spPr>
         <p:txBody>
           <a:bodyPr wrap="square" lIns="36576" tIns="18288" rIns="36576" bIns="18288" rtlCol="0" anchor="ctr"/>
@@ -3456,13 +3480,13 @@
               <a:buNone/>
             </a:pPr>
             <a:r>
-              <a:rPr sz="750" b="0">
-                <a:solidFill>
-                  <a:srgbClr val="1E293B"/>
-                </a:solidFill>
-                <a:latin typeface="Calibri"/>
-              </a:rPr>
-              <a:t>• Algorithmic Scoring: Deterministic FIRST CVSS v3.1 base score and attack vector generation per flaw.</a:t>
+              <a:rPr sz="1000" b="0">
+                <a:solidFill>
+                  <a:srgbClr val="0F172A"/>
+                </a:solidFill>
+                <a:latin typeface="Calibri"/>
+              </a:rPr>
+              <a:t>• Algorithmic Scoring: Deterministic FIRST CVSS v3.1 base score and attack vector per flaw.</a:t>
             </a:r>
             <a:endParaRPr lang="en-US" sz="920" dirty="0"/>
           </a:p>
@@ -3485,7 +3509,7 @@
             </a:avLst>
           </a:prstGeom>
           <a:solidFill>
-            <a:srgbClr val="FFFFFF"/>
+            <a:srgbClr val="F8FAFC"/>
           </a:solidFill>
           <a:ln w="19050">
             <a:solidFill>
@@ -3520,13 +3544,13 @@
               <a:buNone/>
             </a:pPr>
             <a:r>
-              <a:rPr sz="750" b="0">
-                <a:solidFill>
-                  <a:srgbClr val="1E293B"/>
-                </a:solidFill>
-                <a:latin typeface="Calibri"/>
-              </a:rPr>
-              <a:t>• OWASP LLM Suite: Evaluates prompt injection, multilingual evasion, and context leakage on AI feeds.</a:t>
+              <a:rPr sz="1000" b="0">
+                <a:solidFill>
+                  <a:srgbClr val="0F172A"/>
+                </a:solidFill>
+                <a:latin typeface="Calibri"/>
+              </a:rPr>
+              <a:t>• OWASP LLM Suite: Evaluates prompt injection, multilingual evasion on AI summaries.</a:t>
             </a:r>
             <a:endParaRPr lang="en-US" sz="920" dirty="0"/>
           </a:p>
@@ -3557,7 +3581,7 @@
               <a:buNone/>
             </a:pPr>
             <a:r>
-              <a:rPr sz="1000" b="1">
+              <a:rPr sz="1150" b="1">
                 <a:solidFill>
                   <a:srgbClr val="0F172A"/>
                 </a:solidFill>
@@ -3583,8 +3607,14 @@
           <a:prstGeom prst="rect">
             <a:avLst/>
           </a:prstGeom>
-          <a:noFill/>
-          <a:ln/>
+          <a:solidFill>
+            <a:srgbClr val="EFF6FF"/>
+          </a:solidFill>
+          <a:ln w="12700">
+            <a:solidFill>
+              <a:srgbClr val="BFDBFE"/>
+            </a:solidFill>
+          </a:ln>
         </p:spPr>
         <p:txBody>
           <a:bodyPr wrap="square" lIns="36576" tIns="18288" rIns="36576" bIns="18288" rtlCol="0" anchor="ctr"/>
@@ -3594,9 +3624,9 @@
               <a:buNone/>
             </a:pPr>
             <a:r>
-              <a:rPr sz="750" b="1">
-                <a:solidFill>
-                  <a:srgbClr val="1E293B"/>
+              <a:rPr sz="1000" b="1">
+                <a:solidFill>
+                  <a:srgbClr val="0F172A"/>
                 </a:solidFill>
                 <a:latin typeface="Calibri"/>
               </a:rPr>
@@ -3621,7 +3651,7 @@
             <a:avLst/>
           </a:prstGeom>
           <a:solidFill>
-            <a:srgbClr val="E7EAEE"/>
+            <a:srgbClr val="F8FAFC"/>
           </a:solidFill>
           <a:ln w="12700">
             <a:solidFill>
@@ -3681,9 +3711,9 @@
               <a:buNone/>
             </a:pPr>
             <a:r>
-              <a:rPr sz="750" b="1">
-                <a:solidFill>
-                  <a:srgbClr val="B91C1C"/>
+              <a:rPr sz="1000" b="1">
+                <a:solidFill>
+                  <a:srgbClr val="EA580C"/>
                 </a:solidFill>
                 <a:latin typeface="Calibri"/>
               </a:rPr>
@@ -3707,8 +3737,14 @@
           <a:prstGeom prst="rect">
             <a:avLst/>
           </a:prstGeom>
-          <a:noFill/>
-          <a:ln/>
+          <a:solidFill>
+            <a:srgbClr val="EFF6FF"/>
+          </a:solidFill>
+          <a:ln w="12700">
+            <a:solidFill>
+              <a:srgbClr val="BFDBFE"/>
+            </a:solidFill>
+          </a:ln>
         </p:spPr>
         <p:txBody>
           <a:bodyPr wrap="square" lIns="36576" tIns="18288" rIns="36576" bIns="18288" rtlCol="0" anchor="ctr"/>
@@ -3718,9 +3754,9 @@
               <a:buNone/>
             </a:pPr>
             <a:r>
-              <a:rPr sz="750" b="1">
-                <a:solidFill>
-                  <a:srgbClr val="1E293B"/>
+              <a:rPr sz="1000" b="1">
+                <a:solidFill>
+                  <a:srgbClr val="0F172A"/>
                 </a:solidFill>
                 <a:latin typeface="Calibri"/>
               </a:rPr>
@@ -3745,7 +3781,7 @@
             <a:avLst/>
           </a:prstGeom>
           <a:solidFill>
-            <a:srgbClr val="E7EAEE"/>
+            <a:srgbClr val="F8FAFC"/>
           </a:solidFill>
           <a:ln w="12700">
             <a:solidFill>
@@ -3805,7 +3841,7 @@
               <a:buNone/>
             </a:pPr>
             <a:r>
-              <a:rPr sz="750" b="1">
+              <a:rPr sz="1000" b="1">
                 <a:solidFill>
                   <a:srgbClr val="1E3A8A"/>
                 </a:solidFill>
@@ -3831,8 +3867,14 @@
           <a:prstGeom prst="rect">
             <a:avLst/>
           </a:prstGeom>
-          <a:noFill/>
-          <a:ln/>
+          <a:solidFill>
+            <a:srgbClr val="EFF6FF"/>
+          </a:solidFill>
+          <a:ln w="12700">
+            <a:solidFill>
+              <a:srgbClr val="BFDBFE"/>
+            </a:solidFill>
+          </a:ln>
         </p:spPr>
         <p:txBody>
           <a:bodyPr wrap="square" lIns="36576" tIns="18288" rIns="36576" bIns="18288" rtlCol="0" anchor="ctr"/>
@@ -3842,9 +3884,9 @@
               <a:buNone/>
             </a:pPr>
             <a:r>
-              <a:rPr sz="750" b="1">
-                <a:solidFill>
-                  <a:srgbClr val="1E293B"/>
+              <a:rPr sz="1000" b="1">
+                <a:solidFill>
+                  <a:srgbClr val="0F172A"/>
                 </a:solidFill>
                 <a:latin typeface="Calibri"/>
               </a:rPr>
@@ -3869,7 +3911,7 @@
             <a:avLst/>
           </a:prstGeom>
           <a:solidFill>
-            <a:srgbClr val="E7EAEE"/>
+            <a:srgbClr val="F8FAFC"/>
           </a:solidFill>
           <a:ln w="12700">
             <a:solidFill>
@@ -3929,7 +3971,7 @@
               <a:buNone/>
             </a:pPr>
             <a:r>
-              <a:rPr sz="750" b="1">
+              <a:rPr sz="1000" b="1">
                 <a:solidFill>
                   <a:srgbClr val="1E3A8A"/>
                 </a:solidFill>
@@ -3966,9 +4008,9 @@
               <a:buNone/>
             </a:pPr>
             <a:r>
-              <a:rPr sz="750" b="1">
-                <a:solidFill>
-                  <a:srgbClr val="1E293B"/>
+              <a:rPr sz="1000" b="1">
+                <a:solidFill>
+                  <a:srgbClr val="0F172A"/>
                 </a:solidFill>
                 <a:latin typeface="Calibri"/>
               </a:rPr>
@@ -4053,9 +4095,9 @@
               <a:buNone/>
             </a:pPr>
             <a:r>
-              <a:rPr sz="750" b="1">
-                <a:solidFill>
-                  <a:srgbClr val="334155"/>
+              <a:rPr sz="1000" b="1">
+                <a:solidFill>
+                  <a:srgbClr val="1E3A8A"/>
                 </a:solidFill>
                 <a:latin typeface="Calibri"/>
               </a:rPr>
@@ -4239,11 +4281,11 @@
             <a:avLst/>
           </a:prstGeom>
           <a:solidFill>
-            <a:srgbClr val="1E3A8A"/>
+            <a:srgbClr val="EFF6FF"/>
           </a:solidFill>
           <a:ln w="12700">
             <a:solidFill>
-              <a:srgbClr val="1B5FAE"/>
+              <a:srgbClr val="BFDBFE"/>
             </a:solidFill>
             <a:prstDash val="solid"/>
           </a:ln>
@@ -4383,11 +4425,11 @@
             </a:avLst>
           </a:prstGeom>
           <a:solidFill>
-            <a:srgbClr val="0F172A"/>
+            <a:srgbClr val="EFF6FF"/>
           </a:solidFill>
           <a:ln w="12700">
             <a:solidFill>
-              <a:srgbClr val="1B5FAE"/>
+              <a:srgbClr val="BFDBFE"/>
             </a:solidFill>
             <a:prstDash val="solid"/>
           </a:ln>
@@ -4467,9 +4509,9 @@
               <a:buNone/>
             </a:pPr>
             <a:r>
-              <a:rPr sz="950" b="1">
-                <a:solidFill>
-                  <a:srgbClr val="FFFFFF"/>
+              <a:rPr sz="1150" b="1">
+                <a:solidFill>
+                  <a:srgbClr val="0F172A"/>
                 </a:solidFill>
                 <a:latin typeface="Calibri"/>
               </a:rPr>
@@ -4504,9 +4546,9 @@
               <a:buNone/>
             </a:pPr>
             <a:r>
-              <a:rPr sz="750" b="0">
-                <a:solidFill>
-                  <a:srgbClr val="FFFFFF"/>
+              <a:rPr sz="1000" b="0">
+                <a:solidFill>
+                  <a:srgbClr val="0F172A"/>
                 </a:solidFill>
                 <a:latin typeface="Calibri"/>
               </a:rPr>
@@ -4516,9 +4558,9 @@
           </a:p>
           <a:p>
             <a:r>
-              <a:rPr sz="750" b="0">
-                <a:solidFill>
-                  <a:srgbClr val="FFFFFF"/>
+              <a:rPr sz="1000" b="0">
+                <a:solidFill>
+                  <a:srgbClr val="0F172A"/>
                 </a:solidFill>
                 <a:latin typeface="Calibri"/>
               </a:rPr>
@@ -4527,9 +4569,9 @@
           </a:p>
           <a:p>
             <a:r>
-              <a:rPr sz="750" b="0">
-                <a:solidFill>
-                  <a:srgbClr val="FFFFFF"/>
+              <a:rPr sz="1000" b="0">
+                <a:solidFill>
+                  <a:srgbClr val="0F172A"/>
                 </a:solidFill>
                 <a:latin typeface="Calibri"/>
               </a:rPr>
@@ -4538,9 +4580,9 @@
           </a:p>
           <a:p>
             <a:r>
-              <a:rPr sz="750" b="0">
-                <a:solidFill>
-                  <a:srgbClr val="FFFFFF"/>
+              <a:rPr sz="1000" b="0">
+                <a:solidFill>
+                  <a:srgbClr val="0F172A"/>
                 </a:solidFill>
                 <a:latin typeface="Calibri"/>
               </a:rPr>
@@ -4590,11 +4632,11 @@
             </a:avLst>
           </a:prstGeom>
           <a:solidFill>
-            <a:srgbClr val="1E293B"/>
+            <a:srgbClr val="EFF6FF"/>
           </a:solidFill>
           <a:ln w="12700">
             <a:solidFill>
-              <a:srgbClr val="E8792A"/>
+              <a:srgbClr val="BFDBFE"/>
             </a:solidFill>
             <a:prstDash val="solid"/>
           </a:ln>
@@ -4674,9 +4716,9 @@
               <a:buNone/>
             </a:pPr>
             <a:r>
-              <a:rPr sz="950" b="1">
-                <a:solidFill>
-                  <a:srgbClr val="FFFFFF"/>
+              <a:rPr sz="1150" b="1">
+                <a:solidFill>
+                  <a:srgbClr val="0F172A"/>
                 </a:solidFill>
                 <a:latin typeface="Calibri"/>
               </a:rPr>
@@ -4711,9 +4753,9 @@
               <a:buNone/>
             </a:pPr>
             <a:r>
-              <a:rPr sz="750" b="0">
-                <a:solidFill>
-                  <a:srgbClr val="FFFFFF"/>
+              <a:rPr sz="1000" b="0">
+                <a:solidFill>
+                  <a:srgbClr val="0F172A"/>
                 </a:solidFill>
                 <a:latin typeface="Calibri"/>
               </a:rPr>
@@ -4723,9 +4765,9 @@
           </a:p>
           <a:p>
             <a:r>
-              <a:rPr sz="750" b="0">
-                <a:solidFill>
-                  <a:srgbClr val="FFFFFF"/>
+              <a:rPr sz="1000" b="0">
+                <a:solidFill>
+                  <a:srgbClr val="0F172A"/>
                 </a:solidFill>
                 <a:latin typeface="Calibri"/>
               </a:rPr>
@@ -4734,9 +4776,9 @@
           </a:p>
           <a:p>
             <a:r>
-              <a:rPr sz="750" b="0">
-                <a:solidFill>
-                  <a:srgbClr val="FFFFFF"/>
+              <a:rPr sz="1000" b="0">
+                <a:solidFill>
+                  <a:srgbClr val="0F172A"/>
                 </a:solidFill>
                 <a:latin typeface="Calibri"/>
               </a:rPr>
@@ -4745,9 +4787,9 @@
           </a:p>
           <a:p>
             <a:r>
-              <a:rPr sz="750" b="0">
-                <a:solidFill>
-                  <a:srgbClr val="FFFFFF"/>
+              <a:rPr sz="1000" b="0">
+                <a:solidFill>
+                  <a:srgbClr val="0F172A"/>
                 </a:solidFill>
                 <a:latin typeface="Calibri"/>
               </a:rPr>
@@ -4797,11 +4839,11 @@
             </a:avLst>
           </a:prstGeom>
           <a:solidFill>
-            <a:srgbClr val="1E3A8A"/>
+            <a:srgbClr val="EFF6FF"/>
           </a:solidFill>
           <a:ln w="12700">
             <a:solidFill>
-              <a:srgbClr val="0E2A4A"/>
+              <a:srgbClr val="BFDBFE"/>
             </a:solidFill>
             <a:prstDash val="solid"/>
           </a:ln>
@@ -4881,9 +4923,9 @@
               <a:buNone/>
             </a:pPr>
             <a:r>
-              <a:rPr sz="950" b="1">
-                <a:solidFill>
-                  <a:srgbClr val="FFFFFF"/>
+              <a:rPr sz="1150" b="1">
+                <a:solidFill>
+                  <a:srgbClr val="0F172A"/>
                 </a:solidFill>
                 <a:latin typeface="Calibri"/>
               </a:rPr>
@@ -4918,9 +4960,9 @@
               <a:buNone/>
             </a:pPr>
             <a:r>
-              <a:rPr sz="750" b="0">
-                <a:solidFill>
-                  <a:srgbClr val="FFFFFF"/>
+              <a:rPr sz="1000" b="0">
+                <a:solidFill>
+                  <a:srgbClr val="0F172A"/>
                 </a:solidFill>
                 <a:latin typeface="Calibri"/>
               </a:rPr>
@@ -4930,9 +4972,9 @@
           </a:p>
           <a:p>
             <a:r>
-              <a:rPr sz="750" b="0">
-                <a:solidFill>
-                  <a:srgbClr val="FFFFFF"/>
+              <a:rPr sz="1000" b="0">
+                <a:solidFill>
+                  <a:srgbClr val="0F172A"/>
                 </a:solidFill>
                 <a:latin typeface="Calibri"/>
               </a:rPr>
@@ -4941,9 +4983,9 @@
           </a:p>
           <a:p>
             <a:r>
-              <a:rPr sz="750" b="0">
-                <a:solidFill>
-                  <a:srgbClr val="FFFFFF"/>
+              <a:rPr sz="1000" b="0">
+                <a:solidFill>
+                  <a:srgbClr val="0F172A"/>
                 </a:solidFill>
                 <a:latin typeface="Calibri"/>
               </a:rPr>
@@ -4952,9 +4994,9 @@
           </a:p>
           <a:p>
             <a:r>
-              <a:rPr sz="750" b="0">
-                <a:solidFill>
-                  <a:srgbClr val="FFFFFF"/>
+              <a:rPr sz="1000" b="0">
+                <a:solidFill>
+                  <a:srgbClr val="0F172A"/>
                 </a:solidFill>
                 <a:latin typeface="Calibri"/>
               </a:rPr>
@@ -5004,11 +5046,11 @@
             </a:avLst>
           </a:prstGeom>
           <a:solidFill>
-            <a:srgbClr val="334155"/>
+            <a:srgbClr val="EFF6FF"/>
           </a:solidFill>
           <a:ln w="12700">
             <a:solidFill>
-              <a:srgbClr val="139488"/>
+              <a:srgbClr val="BFDBFE"/>
             </a:solidFill>
             <a:prstDash val="solid"/>
           </a:ln>
@@ -5088,9 +5130,9 @@
               <a:buNone/>
             </a:pPr>
             <a:r>
-              <a:rPr sz="950" b="1">
-                <a:solidFill>
-                  <a:srgbClr val="FFFFFF"/>
+              <a:rPr sz="1150" b="1">
+                <a:solidFill>
+                  <a:srgbClr val="0F172A"/>
                 </a:solidFill>
                 <a:latin typeface="Calibri"/>
               </a:rPr>
@@ -5125,9 +5167,9 @@
               <a:buNone/>
             </a:pPr>
             <a:r>
-              <a:rPr sz="750" b="0">
-                <a:solidFill>
-                  <a:srgbClr val="FFFFFF"/>
+              <a:rPr sz="1000" b="0">
+                <a:solidFill>
+                  <a:srgbClr val="0F172A"/>
                 </a:solidFill>
                 <a:latin typeface="Calibri"/>
               </a:rPr>
@@ -5137,20 +5179,20 @@
           </a:p>
           <a:p>
             <a:r>
-              <a:rPr sz="750" b="0">
-                <a:solidFill>
-                  <a:srgbClr val="FFFFFF"/>
-                </a:solidFill>
-                <a:latin typeface="Calibri"/>
-              </a:rPr>
-              <a:t>• 12-Page Executive PDF</a:t>
-            </a:r>
-          </a:p>
-          <a:p>
-            <a:r>
-              <a:rPr sz="750" b="0">
-                <a:solidFill>
-                  <a:srgbClr val="FFFFFF"/>
+              <a:rPr sz="1000" b="0">
+                <a:solidFill>
+                  <a:srgbClr val="0F172A"/>
+                </a:solidFill>
+                <a:latin typeface="Calibri"/>
+              </a:rPr>
+              <a:t>• 12-Page Executive PDF Report</a:t>
+            </a:r>
+          </a:p>
+          <a:p>
+            <a:r>
+              <a:rPr sz="1000" b="0">
+                <a:solidFill>
+                  <a:srgbClr val="0F172A"/>
                 </a:solidFill>
                 <a:latin typeface="Calibri"/>
               </a:rPr>
@@ -5159,9 +5201,9 @@
           </a:p>
           <a:p>
             <a:r>
-              <a:rPr sz="750" b="0">
-                <a:solidFill>
-                  <a:srgbClr val="FFFFFF"/>
+              <a:rPr sz="1000" b="0">
+                <a:solidFill>
+                  <a:srgbClr val="0F172A"/>
                 </a:solidFill>
                 <a:latin typeface="Calibri"/>
               </a:rPr>
@@ -5195,7 +5237,7 @@
               <a:buNone/>
             </a:pPr>
             <a:r>
-              <a:rPr sz="800" b="0">
+              <a:rPr sz="1000" b="0">
                 <a:solidFill>
                   <a:srgbClr val="475569"/>
                 </a:solidFill>
@@ -5263,11 +5305,11 @@
             </a:avLst>
           </a:prstGeom>
           <a:solidFill>
-            <a:srgbClr val="0F172A"/>
+            <a:srgbClr val="EFF6FF"/>
           </a:solidFill>
           <a:ln w="12700">
             <a:solidFill>
-              <a:srgbClr val="E8792A"/>
+              <a:srgbClr val="BFDBFE"/>
             </a:solidFill>
             <a:prstDash val="solid"/>
           </a:ln>
@@ -5298,9 +5340,9 @@
               <a:buNone/>
             </a:pPr>
             <a:r>
-              <a:rPr sz="850" b="1">
-                <a:solidFill>
-                  <a:srgbClr val="FFFFFF"/>
+              <a:rPr sz="1050" b="1">
+                <a:solidFill>
+                  <a:srgbClr val="0F172A"/>
                 </a:solidFill>
                 <a:latin typeface="Calibri"/>
               </a:rPr>
@@ -5335,9 +5377,9 @@
               <a:buNone/>
             </a:pPr>
             <a:r>
-              <a:rPr sz="750" b="0">
-                <a:solidFill>
-                  <a:srgbClr val="FFFFFF"/>
+              <a:rPr sz="1000" b="0">
+                <a:solidFill>
+                  <a:srgbClr val="0F172A"/>
                 </a:solidFill>
                 <a:latin typeface="Calibri"/>
               </a:rPr>
@@ -5348,9 +5390,9 @@
           <a:p>
             <a:pPr algn="ctr"/>
             <a:r>
-              <a:rPr sz="750" b="0">
-                <a:solidFill>
-                  <a:srgbClr val="FFFFFF"/>
+              <a:rPr sz="1000" b="0">
+                <a:solidFill>
+                  <a:srgbClr val="0F172A"/>
                 </a:solidFill>
                 <a:latin typeface="Calibri"/>
               </a:rPr>
@@ -5376,11 +5418,11 @@
             </a:avLst>
           </a:prstGeom>
           <a:solidFill>
-            <a:srgbClr val="1E293B"/>
+            <a:srgbClr val="EFF6FF"/>
           </a:solidFill>
           <a:ln w="12700">
             <a:solidFill>
-              <a:srgbClr val="1B5FAE"/>
+              <a:srgbClr val="BFDBFE"/>
             </a:solidFill>
             <a:prstDash val="solid"/>
           </a:ln>
@@ -5411,9 +5453,9 @@
               <a:buNone/>
             </a:pPr>
             <a:r>
-              <a:rPr sz="850" b="1">
-                <a:solidFill>
-                  <a:srgbClr val="FFFFFF"/>
+              <a:rPr sz="1050" b="1">
+                <a:solidFill>
+                  <a:srgbClr val="0F172A"/>
                 </a:solidFill>
                 <a:latin typeface="Calibri"/>
               </a:rPr>
@@ -5448,9 +5490,9 @@
               <a:buNone/>
             </a:pPr>
             <a:r>
-              <a:rPr sz="750" b="0">
-                <a:solidFill>
-                  <a:srgbClr val="FFFFFF"/>
+              <a:rPr sz="1000" b="0">
+                <a:solidFill>
+                  <a:srgbClr val="0F172A"/>
                 </a:solidFill>
                 <a:latin typeface="Calibri"/>
               </a:rPr>
@@ -5461,9 +5503,9 @@
           <a:p>
             <a:pPr algn="ctr"/>
             <a:r>
-              <a:rPr sz="750" b="0">
-                <a:solidFill>
-                  <a:srgbClr val="FFFFFF"/>
+              <a:rPr sz="1000" b="0">
+                <a:solidFill>
+                  <a:srgbClr val="0F172A"/>
                 </a:solidFill>
                 <a:latin typeface="Calibri"/>
               </a:rPr>
@@ -5489,11 +5531,11 @@
             </a:avLst>
           </a:prstGeom>
           <a:solidFill>
-            <a:srgbClr val="1E293B"/>
+            <a:srgbClr val="EFF6FF"/>
           </a:solidFill>
           <a:ln w="12700">
             <a:solidFill>
-              <a:srgbClr val="1B5FAE"/>
+              <a:srgbClr val="BFDBFE"/>
             </a:solidFill>
             <a:prstDash val="solid"/>
           </a:ln>
@@ -5524,9 +5566,9 @@
               <a:buNone/>
             </a:pPr>
             <a:r>
-              <a:rPr sz="850" b="1">
-                <a:solidFill>
-                  <a:srgbClr val="FFFFFF"/>
+              <a:rPr sz="1050" b="1">
+                <a:solidFill>
+                  <a:srgbClr val="0F172A"/>
                 </a:solidFill>
                 <a:latin typeface="Calibri"/>
               </a:rPr>
@@ -5561,9 +5603,9 @@
               <a:buNone/>
             </a:pPr>
             <a:r>
-              <a:rPr sz="750" b="0">
-                <a:solidFill>
-                  <a:srgbClr val="FFFFFF"/>
+              <a:rPr sz="1000" b="0">
+                <a:solidFill>
+                  <a:srgbClr val="0F172A"/>
                 </a:solidFill>
                 <a:latin typeface="Calibri"/>
               </a:rPr>
@@ -5574,9 +5616,9 @@
           <a:p>
             <a:pPr algn="ctr"/>
             <a:r>
-              <a:rPr sz="750" b="0">
-                <a:solidFill>
-                  <a:srgbClr val="FFFFFF"/>
+              <a:rPr sz="1000" b="0">
+                <a:solidFill>
+                  <a:srgbClr val="0F172A"/>
                 </a:solidFill>
                 <a:latin typeface="Calibri"/>
               </a:rPr>
@@ -5602,11 +5644,11 @@
             </a:avLst>
           </a:prstGeom>
           <a:solidFill>
-            <a:srgbClr val="1E3A8A"/>
+            <a:srgbClr val="EFF6FF"/>
           </a:solidFill>
           <a:ln w="12700">
             <a:solidFill>
-              <a:srgbClr val="0E2A4A"/>
+              <a:srgbClr val="BFDBFE"/>
             </a:solidFill>
             <a:prstDash val="solid"/>
           </a:ln>
@@ -5637,9 +5679,9 @@
               <a:buNone/>
             </a:pPr>
             <a:r>
-              <a:rPr sz="850" b="1">
-                <a:solidFill>
-                  <a:srgbClr val="FFFFFF"/>
+              <a:rPr sz="1050" b="1">
+                <a:solidFill>
+                  <a:srgbClr val="0F172A"/>
                 </a:solidFill>
                 <a:latin typeface="Calibri"/>
               </a:rPr>
@@ -5674,9 +5716,9 @@
               <a:buNone/>
             </a:pPr>
             <a:r>
-              <a:rPr sz="750" b="0">
-                <a:solidFill>
-                  <a:srgbClr val="FFFFFF"/>
+              <a:rPr sz="1000" b="0">
+                <a:solidFill>
+                  <a:srgbClr val="0F172A"/>
                 </a:solidFill>
                 <a:latin typeface="Calibri"/>
               </a:rPr>
@@ -5687,9 +5729,9 @@
           <a:p>
             <a:pPr algn="ctr"/>
             <a:r>
-              <a:rPr sz="750" b="0">
-                <a:solidFill>
-                  <a:srgbClr val="FFFFFF"/>
+              <a:rPr sz="1000" b="0">
+                <a:solidFill>
+                  <a:srgbClr val="0F172A"/>
                 </a:solidFill>
                 <a:latin typeface="Calibri"/>
               </a:rPr>
@@ -5811,11 +5853,11 @@
             </a:avLst>
           </a:prstGeom>
           <a:solidFill>
-            <a:srgbClr val="0F172A"/>
+            <a:srgbClr val="EFF6FF"/>
           </a:solidFill>
           <a:ln w="12700">
             <a:solidFill>
-              <a:srgbClr val="E8792A"/>
+              <a:srgbClr val="BFDBFE"/>
             </a:solidFill>
             <a:prstDash val="solid"/>
           </a:ln>
@@ -5846,9 +5888,9 @@
               <a:buNone/>
             </a:pPr>
             <a:r>
-              <a:rPr sz="850" b="1">
-                <a:solidFill>
-                  <a:srgbClr val="FFFFFF"/>
+              <a:rPr sz="1050" b="1">
+                <a:solidFill>
+                  <a:srgbClr val="0F172A"/>
                 </a:solidFill>
                 <a:latin typeface="Calibri"/>
               </a:rPr>
@@ -5883,9 +5925,9 @@
               <a:buNone/>
             </a:pPr>
             <a:r>
-              <a:rPr sz="750" b="0">
-                <a:solidFill>
-                  <a:srgbClr val="FFFFFF"/>
+              <a:rPr sz="1000" b="0">
+                <a:solidFill>
+                  <a:srgbClr val="0F172A"/>
                 </a:solidFill>
                 <a:latin typeface="Calibri"/>
               </a:rPr>
@@ -5896,9 +5938,9 @@
           <a:p>
             <a:pPr algn="ctr"/>
             <a:r>
-              <a:rPr sz="750" b="0">
-                <a:solidFill>
-                  <a:srgbClr val="FFFFFF"/>
+              <a:rPr sz="1000" b="0">
+                <a:solidFill>
+                  <a:srgbClr val="0F172A"/>
                 </a:solidFill>
                 <a:latin typeface="Calibri"/>
               </a:rPr>
@@ -5924,11 +5966,11 @@
             </a:avLst>
           </a:prstGeom>
           <a:solidFill>
-            <a:srgbClr val="334155"/>
+            <a:srgbClr val="EFF6FF"/>
           </a:solidFill>
           <a:ln w="12700">
             <a:solidFill>
-              <a:srgbClr val="1B5FAE"/>
+              <a:srgbClr val="BFDBFE"/>
             </a:solidFill>
             <a:prstDash val="solid"/>
           </a:ln>
@@ -5959,9 +6001,9 @@
               <a:buNone/>
             </a:pPr>
             <a:r>
-              <a:rPr sz="850" b="1">
-                <a:solidFill>
-                  <a:srgbClr val="FFFFFF"/>
+              <a:rPr sz="1050" b="1">
+                <a:solidFill>
+                  <a:srgbClr val="0F172A"/>
                 </a:solidFill>
                 <a:latin typeface="Calibri"/>
               </a:rPr>
@@ -5996,9 +6038,9 @@
               <a:buNone/>
             </a:pPr>
             <a:r>
-              <a:rPr sz="750" b="0">
-                <a:solidFill>
-                  <a:srgbClr val="FFFFFF"/>
+              <a:rPr sz="1000" b="0">
+                <a:solidFill>
+                  <a:srgbClr val="0F172A"/>
                 </a:solidFill>
                 <a:latin typeface="Calibri"/>
               </a:rPr>
@@ -6009,9 +6051,9 @@
           <a:p>
             <a:pPr algn="ctr"/>
             <a:r>
-              <a:rPr sz="750" b="0">
-                <a:solidFill>
-                  <a:srgbClr val="FFFFFF"/>
+              <a:rPr sz="1000" b="0">
+                <a:solidFill>
+                  <a:srgbClr val="0F172A"/>
                 </a:solidFill>
                 <a:latin typeface="Calibri"/>
               </a:rPr>
@@ -6037,11 +6079,11 @@
             </a:avLst>
           </a:prstGeom>
           <a:solidFill>
-            <a:srgbClr val="334155"/>
+            <a:srgbClr val="EFF6FF"/>
           </a:solidFill>
           <a:ln w="12700">
             <a:solidFill>
-              <a:srgbClr val="1B5FAE"/>
+              <a:srgbClr val="BFDBFE"/>
             </a:solidFill>
             <a:prstDash val="solid"/>
           </a:ln>
@@ -6072,9 +6114,9 @@
               <a:buNone/>
             </a:pPr>
             <a:r>
-              <a:rPr sz="850" b="1">
-                <a:solidFill>
-                  <a:srgbClr val="FFFFFF"/>
+              <a:rPr sz="1050" b="1">
+                <a:solidFill>
+                  <a:srgbClr val="0F172A"/>
                 </a:solidFill>
                 <a:latin typeface="Calibri"/>
               </a:rPr>
@@ -6109,9 +6151,9 @@
               <a:buNone/>
             </a:pPr>
             <a:r>
-              <a:rPr sz="750" b="0">
-                <a:solidFill>
-                  <a:srgbClr val="FFFFFF"/>
+              <a:rPr sz="1000" b="0">
+                <a:solidFill>
+                  <a:srgbClr val="0F172A"/>
                 </a:solidFill>
                 <a:latin typeface="Calibri"/>
               </a:rPr>
@@ -6122,9 +6164,9 @@
           <a:p>
             <a:pPr algn="ctr"/>
             <a:r>
-              <a:rPr sz="750" b="0">
-                <a:solidFill>
-                  <a:srgbClr val="FFFFFF"/>
+              <a:rPr sz="1000" b="0">
+                <a:solidFill>
+                  <a:srgbClr val="0F172A"/>
                 </a:solidFill>
                 <a:latin typeface="Calibri"/>
               </a:rPr>
@@ -6150,11 +6192,11 @@
             </a:avLst>
           </a:prstGeom>
           <a:solidFill>
-            <a:srgbClr val="1E3A8A"/>
+            <a:srgbClr val="EFF6FF"/>
           </a:solidFill>
           <a:ln w="12700">
             <a:solidFill>
-              <a:srgbClr val="139488"/>
+              <a:srgbClr val="BFDBFE"/>
             </a:solidFill>
             <a:prstDash val="solid"/>
           </a:ln>
@@ -6185,9 +6227,9 @@
               <a:buNone/>
             </a:pPr>
             <a:r>
-              <a:rPr sz="850" b="1">
-                <a:solidFill>
-                  <a:srgbClr val="FFFFFF"/>
+              <a:rPr sz="1050" b="1">
+                <a:solidFill>
+                  <a:srgbClr val="0F172A"/>
                 </a:solidFill>
                 <a:latin typeface="Calibri"/>
               </a:rPr>
@@ -6222,9 +6264,9 @@
               <a:buNone/>
             </a:pPr>
             <a:r>
-              <a:rPr sz="750" b="0">
-                <a:solidFill>
-                  <a:srgbClr val="FFFFFF"/>
+              <a:rPr sz="1000" b="0">
+                <a:solidFill>
+                  <a:srgbClr val="0F172A"/>
                 </a:solidFill>
                 <a:latin typeface="Calibri"/>
               </a:rPr>
@@ -6235,9 +6277,9 @@
           <a:p>
             <a:pPr algn="ctr"/>
             <a:r>
-              <a:rPr sz="750" b="0">
-                <a:solidFill>
-                  <a:srgbClr val="FFFFFF"/>
+              <a:rPr sz="1000" b="0">
+                <a:solidFill>
+                  <a:srgbClr val="0F172A"/>
                 </a:solidFill>
                 <a:latin typeface="Calibri"/>
               </a:rPr>
@@ -6343,9 +6385,9 @@
               <a:buNone/>
             </a:pPr>
             <a:r>
-              <a:rPr sz="700" b="1">
-                <a:solidFill>
-                  <a:srgbClr val="B91C1C"/>
+              <a:rPr sz="950" b="1">
+                <a:solidFill>
+                  <a:srgbClr val="EA580C"/>
                 </a:solidFill>
                 <a:latin typeface="Calibri"/>
               </a:rPr>
@@ -6380,9 +6422,9 @@
               <a:buNone/>
             </a:pPr>
             <a:r>
-              <a:rPr sz="700" b="1">
-                <a:solidFill>
-                  <a:srgbClr val="B91C1C"/>
+              <a:rPr sz="950" b="1">
+                <a:solidFill>
+                  <a:srgbClr val="EA580C"/>
                 </a:solidFill>
                 <a:latin typeface="Calibri"/>
               </a:rPr>
@@ -6409,11 +6451,11 @@
             </a:avLst>
           </a:prstGeom>
           <a:solidFill>
-            <a:srgbClr val="EEF2F7"/>
-          </a:solidFill>
-          <a:ln w="19050">
-            <a:solidFill>
-              <a:srgbClr val="000000"/>
+            <a:srgbClr val="F8FAFC"/>
+          </a:solidFill>
+          <a:ln w="12700">
+            <a:solidFill>
+              <a:srgbClr val="E2E8F0"/>
             </a:solidFill>
             <a:prstDash val="solid"/>
           </a:ln>
@@ -6437,7 +6479,7 @@
           <a:ln/>
         </p:spPr>
         <p:txBody>
-          <a:bodyPr wrap="square" lIns="45720" tIns="36576" rIns="45720" bIns="36576" rtlCol="0" anchor="t"/>
+          <a:bodyPr wrap="square" lIns="45720" tIns="27432" rIns="45720" bIns="27432" rtlCol="0" anchor="t"/>
           <a:lstStyle/>
           <a:p>
             <a:pPr indent="0" marL="0" algn="l">
@@ -6450,7 +6492,7 @@
               <a:buNone/>
             </a:pPr>
             <a:r>
-              <a:rPr b="1" sz="950">
+              <a:rPr b="1" sz="1100">
                 <a:solidFill>
                   <a:srgbClr val="0F172A"/>
                 </a:solidFill>
@@ -6463,9 +6505,9 @@
           <a:p>
             <a:pPr algn="l"/>
             <a:r>
-              <a:rPr b="0" sz="750">
-                <a:solidFill>
-                  <a:srgbClr val="1E293B"/>
+              <a:rPr b="0" sz="1000">
+                <a:solidFill>
+                  <a:srgbClr val="0F172A"/>
                 </a:solidFill>
                 <a:latin typeface="Calibri"/>
               </a:rPr>
@@ -6475,9 +6517,9 @@
           <a:p>
             <a:pPr algn="l"/>
             <a:r>
-              <a:rPr b="0" sz="750">
-                <a:solidFill>
-                  <a:srgbClr val="1E293B"/>
+              <a:rPr b="0" sz="1000">
+                <a:solidFill>
+                  <a:srgbClr val="0F172A"/>
                 </a:solidFill>
                 <a:latin typeface="Calibri"/>
               </a:rPr>
@@ -6487,9 +6529,9 @@
           <a:p>
             <a:pPr algn="l"/>
             <a:r>
-              <a:rPr b="0" sz="750">
-                <a:solidFill>
-                  <a:srgbClr val="1E293B"/>
+              <a:rPr b="0" sz="1000">
+                <a:solidFill>
+                  <a:srgbClr val="0F172A"/>
                 </a:solidFill>
                 <a:latin typeface="Calibri"/>
               </a:rPr>
@@ -6499,9 +6541,9 @@
           <a:p>
             <a:pPr algn="l"/>
             <a:r>
-              <a:rPr b="0" sz="750">
-                <a:solidFill>
-                  <a:srgbClr val="1E293B"/>
+              <a:rPr b="0" sz="1000">
+                <a:solidFill>
+                  <a:srgbClr val="0F172A"/>
                 </a:solidFill>
                 <a:latin typeface="Calibri"/>
               </a:rPr>
@@ -6511,9 +6553,9 @@
           <a:p>
             <a:pPr algn="l"/>
             <a:r>
-              <a:rPr b="0" sz="750">
-                <a:solidFill>
-                  <a:srgbClr val="1E293B"/>
+              <a:rPr b="0" sz="1000">
+                <a:solidFill>
+                  <a:srgbClr val="0F172A"/>
                 </a:solidFill>
                 <a:latin typeface="Calibri"/>
               </a:rPr>
@@ -6523,9 +6565,9 @@
           <a:p>
             <a:pPr algn="l"/>
             <a:r>
-              <a:rPr b="0" sz="750">
-                <a:solidFill>
-                  <a:srgbClr val="1E293B"/>
+              <a:rPr b="0" sz="1000">
+                <a:solidFill>
+                  <a:srgbClr val="0F172A"/>
                 </a:solidFill>
                 <a:latin typeface="Calibri"/>
               </a:rPr>
@@ -6535,7 +6577,7 @@
           <a:p>
             <a:pPr algn="l"/>
             <a:r>
-              <a:rPr b="0" sz="750">
+              <a:rPr b="0" sz="1000">
                 <a:solidFill>
                   <a:srgbClr val="1E3A8A"/>
                 </a:solidFill>
@@ -6720,11 +6762,11 @@
             <a:avLst/>
           </a:prstGeom>
           <a:solidFill>
-            <a:srgbClr val="1E3A8A"/>
+            <a:srgbClr val="EFF6FF"/>
           </a:solidFill>
           <a:ln w="12700">
             <a:solidFill>
-              <a:srgbClr val="1B5FAE"/>
+              <a:srgbClr val="BFDBFE"/>
             </a:solidFill>
             <a:prstDash val="solid"/>
           </a:ln>
@@ -6826,20 +6868,18 @@
           <a:ln/>
         </p:spPr>
         <p:txBody>
-          <a:bodyPr wrap="square" lIns="0" tIns="0" rIns="0" bIns="0" rtlCol="0" anchor="ctr"/>
+          <a:bodyPr wrap="square" lIns="36576" tIns="18288" rIns="36576" bIns="18288" rtlCol="0" anchor="ctr"/>
           <a:lstStyle/>
           <a:p>
             <a:pPr indent="0" marL="0">
               <a:buNone/>
             </a:pPr>
             <a:r>
-              <a:rPr lang="en-US" sz="1400" b="1" dirty="0">
-                <a:solidFill>
-                  <a:srgbClr val="000000"/>
-                </a:solidFill>
-                <a:latin typeface="Arial" pitchFamily="34" charset="0"/>
-                <a:ea typeface="Arial" pitchFamily="34" charset="-122"/>
-                <a:cs typeface="Arial" pitchFamily="34" charset="-120"/>
+              <a:rPr sz="1200" b="1">
+                <a:solidFill>
+                  <a:srgbClr val="0F172A"/>
+                </a:solidFill>
+                <a:latin typeface="Calibri"/>
               </a:rPr>
               <a:t>Feasibility :</a:t>
             </a:r>
@@ -6862,11 +6902,11 @@
             <a:avLst/>
           </a:prstGeom>
           <a:solidFill>
-            <a:srgbClr val="0F172A"/>
+            <a:srgbClr val="EFF6FF"/>
           </a:solidFill>
           <a:ln w="12700">
             <a:solidFill>
-              <a:srgbClr val="1B5FAE"/>
+              <a:srgbClr val="BFDBFE"/>
             </a:solidFill>
             <a:prstDash val="solid"/>
           </a:ln>
@@ -6924,13 +6964,13 @@
               <a:buNone/>
             </a:pPr>
             <a:r>
-              <a:rPr sz="750" b="0">
-                <a:solidFill>
-                  <a:srgbClr val="1E293B"/>
-                </a:solidFill>
-                <a:latin typeface="Calibri"/>
-              </a:rPr>
-              <a:t>Technical: Full access to AGPL-3.0 source tree; audited all 166 Vercel Edge routes, Next.js UI, and Tauri Rust IPC locally without upstream API dependencies.</a:t>
+              <a:rPr sz="1000" b="0">
+                <a:solidFill>
+                  <a:srgbClr val="0F172A"/>
+                </a:solidFill>
+                <a:latin typeface="Calibri"/>
+              </a:rPr>
+              <a:t>Technical: Full access to AGPL-3.0 source; audited 166 Vercel Edge routes and Tauri Rust IPC locally without external cloud dependencies.</a:t>
             </a:r>
             <a:endParaRPr lang="en-US" sz="1030" dirty="0"/>
           </a:p>
@@ -6951,11 +6991,11 @@
             <a:avLst/>
           </a:prstGeom>
           <a:solidFill>
-            <a:srgbClr val="0F172A"/>
+            <a:srgbClr val="EFF6FF"/>
           </a:solidFill>
           <a:ln w="12700">
             <a:solidFill>
-              <a:srgbClr val="E8792A"/>
+              <a:srgbClr val="BFDBFE"/>
             </a:solidFill>
             <a:prstDash val="solid"/>
           </a:ln>
@@ -7013,9 +7053,9 @@
               <a:buNone/>
             </a:pPr>
             <a:r>
-              <a:rPr sz="750" b="0">
-                <a:solidFill>
-                  <a:srgbClr val="1E293B"/>
+              <a:rPr sz="1000" b="0">
+                <a:solidFill>
+                  <a:srgbClr val="0F172A"/>
                 </a:solidFill>
                 <a:latin typeface="Calibri"/>
               </a:rPr>
@@ -7040,11 +7080,11 @@
             <a:avLst/>
           </a:prstGeom>
           <a:solidFill>
-            <a:srgbClr val="0F172A"/>
+            <a:srgbClr val="EFF6FF"/>
           </a:solidFill>
           <a:ln w="12700">
             <a:solidFill>
-              <a:srgbClr val="139488"/>
+              <a:srgbClr val="BFDBFE"/>
             </a:solidFill>
             <a:prstDash val="solid"/>
           </a:ln>
@@ -7102,9 +7142,9 @@
               <a:buNone/>
             </a:pPr>
             <a:r>
-              <a:rPr sz="750" b="0">
-                <a:solidFill>
-                  <a:srgbClr val="1E293B"/>
+              <a:rPr sz="1000" b="0">
+                <a:solidFill>
+                  <a:srgbClr val="0F172A"/>
                 </a:solidFill>
                 <a:latin typeface="Calibri"/>
               </a:rPr>
@@ -7132,20 +7172,18 @@
           <a:ln/>
         </p:spPr>
         <p:txBody>
-          <a:bodyPr wrap="square" lIns="0" tIns="0" rIns="0" bIns="0" rtlCol="0" anchor="ctr"/>
+          <a:bodyPr wrap="square" lIns="36576" tIns="18288" rIns="36576" bIns="18288" rtlCol="0" anchor="ctr"/>
           <a:lstStyle/>
           <a:p>
             <a:pPr indent="0" marL="0">
               <a:buNone/>
             </a:pPr>
             <a:r>
-              <a:rPr lang="en-US" sz="1400" b="1" dirty="0">
-                <a:solidFill>
-                  <a:srgbClr val="000000"/>
-                </a:solidFill>
-                <a:latin typeface="Arial" pitchFamily="34" charset="0"/>
-                <a:ea typeface="Arial" pitchFamily="34" charset="-122"/>
-                <a:cs typeface="Arial" pitchFamily="34" charset="-120"/>
+              <a:rPr sz="1200" b="1">
+                <a:solidFill>
+                  <a:srgbClr val="0F172A"/>
+                </a:solidFill>
+                <a:latin typeface="Calibri"/>
               </a:rPr>
               <a:t>Challenges :</a:t>
             </a:r>
@@ -7168,11 +7206,11 @@
             <a:avLst/>
           </a:prstGeom>
           <a:solidFill>
-            <a:srgbClr val="1E293B"/>
+            <a:srgbClr val="FFF7ED"/>
           </a:solidFill>
           <a:ln w="12700">
             <a:solidFill>
-              <a:srgbClr val="D64545"/>
+              <a:srgbClr val="EA580C"/>
             </a:solidFill>
             <a:prstDash val="solid"/>
           </a:ln>
@@ -7230,9 +7268,9 @@
               <a:buNone/>
             </a:pPr>
             <a:r>
-              <a:rPr sz="750" b="0">
-                <a:solidFill>
-                  <a:srgbClr val="1E293B"/>
+              <a:rPr sz="1000" b="0">
+                <a:solidFill>
+                  <a:srgbClr val="0F172A"/>
                 </a:solidFill>
                 <a:latin typeface="Calibri"/>
               </a:rPr>
@@ -7257,11 +7295,11 @@
             <a:avLst/>
           </a:prstGeom>
           <a:solidFill>
-            <a:srgbClr val="1E293B"/>
+            <a:srgbClr val="FFF7ED"/>
           </a:solidFill>
           <a:ln w="12700">
             <a:solidFill>
-              <a:srgbClr val="E8792A"/>
+              <a:srgbClr val="EA580C"/>
             </a:solidFill>
             <a:prstDash val="solid"/>
           </a:ln>
@@ -7319,9 +7357,9 @@
               <a:buNone/>
             </a:pPr>
             <a:r>
-              <a:rPr sz="750" b="0">
-                <a:solidFill>
-                  <a:srgbClr val="1E293B"/>
+              <a:rPr sz="1000" b="0">
+                <a:solidFill>
+                  <a:srgbClr val="0F172A"/>
                 </a:solidFill>
                 <a:latin typeface="Calibri"/>
               </a:rPr>
@@ -7346,11 +7384,11 @@
             <a:avLst/>
           </a:prstGeom>
           <a:solidFill>
-            <a:srgbClr val="1E293B"/>
+            <a:srgbClr val="FFF7ED"/>
           </a:solidFill>
           <a:ln w="12700">
             <a:solidFill>
-              <a:srgbClr val="1B5FAE"/>
+              <a:srgbClr val="EA580C"/>
             </a:solidFill>
             <a:prstDash val="solid"/>
           </a:ln>
@@ -7408,9 +7446,9 @@
               <a:buNone/>
             </a:pPr>
             <a:r>
-              <a:rPr sz="750" b="0">
-                <a:solidFill>
-                  <a:srgbClr val="1E293B"/>
+              <a:rPr sz="1000" b="0">
+                <a:solidFill>
+                  <a:srgbClr val="0F172A"/>
                 </a:solidFill>
                 <a:latin typeface="Calibri"/>
               </a:rPr>
@@ -7438,20 +7476,18 @@
           <a:ln/>
         </p:spPr>
         <p:txBody>
-          <a:bodyPr wrap="square" lIns="0" tIns="0" rIns="0" bIns="0" rtlCol="0" anchor="ctr"/>
+          <a:bodyPr wrap="square" lIns="36576" tIns="18288" rIns="36576" bIns="18288" rtlCol="0" anchor="ctr"/>
           <a:lstStyle/>
           <a:p>
             <a:pPr indent="0" marL="0">
               <a:buNone/>
             </a:pPr>
             <a:r>
-              <a:rPr lang="en-US" sz="1400" b="1" dirty="0">
-                <a:solidFill>
-                  <a:srgbClr val="000000"/>
-                </a:solidFill>
-                <a:latin typeface="Arial" pitchFamily="34" charset="0"/>
-                <a:ea typeface="Arial" pitchFamily="34" charset="-122"/>
-                <a:cs typeface="Arial" pitchFamily="34" charset="-120"/>
+              <a:rPr sz="1200" b="1">
+                <a:solidFill>
+                  <a:srgbClr val="0F172A"/>
+                </a:solidFill>
+                <a:latin typeface="Calibri"/>
               </a:rPr>
               <a:t>Viability :</a:t>
             </a:r>
@@ -7474,11 +7510,11 @@
             <a:avLst/>
           </a:prstGeom>
           <a:solidFill>
-            <a:srgbClr val="1E3A8A"/>
+            <a:srgbClr val="EFF6FF"/>
           </a:solidFill>
           <a:ln w="12700">
             <a:solidFill>
-              <a:srgbClr val="1B5FAE"/>
+              <a:srgbClr val="BFDBFE"/>
             </a:solidFill>
             <a:prstDash val="solid"/>
           </a:ln>
@@ -7536,9 +7572,9 @@
               <a:buNone/>
             </a:pPr>
             <a:r>
-              <a:rPr sz="750" b="0">
-                <a:solidFill>
-                  <a:srgbClr val="1E293B"/>
+              <a:rPr sz="1000" b="0">
+                <a:solidFill>
+                  <a:srgbClr val="0F172A"/>
                 </a:solidFill>
                 <a:latin typeface="Calibri"/>
               </a:rPr>
@@ -7563,11 +7599,11 @@
             <a:avLst/>
           </a:prstGeom>
           <a:solidFill>
-            <a:srgbClr val="1E3A8A"/>
+            <a:srgbClr val="EFF6FF"/>
           </a:solidFill>
           <a:ln w="12700">
             <a:solidFill>
-              <a:srgbClr val="139488"/>
+              <a:srgbClr val="BFDBFE"/>
             </a:solidFill>
             <a:prstDash val="solid"/>
           </a:ln>
@@ -7625,9 +7661,9 @@
               <a:buNone/>
             </a:pPr>
             <a:r>
-              <a:rPr sz="750" b="0">
-                <a:solidFill>
-                  <a:srgbClr val="1E293B"/>
+              <a:rPr sz="1000" b="0">
+                <a:solidFill>
+                  <a:srgbClr val="0F172A"/>
                 </a:solidFill>
                 <a:latin typeface="Calibri"/>
               </a:rPr>
@@ -7652,11 +7688,11 @@
             <a:avLst/>
           </a:prstGeom>
           <a:solidFill>
-            <a:srgbClr val="1E3A8A"/>
+            <a:srgbClr val="EFF6FF"/>
           </a:solidFill>
           <a:ln w="12700">
             <a:solidFill>
-              <a:srgbClr val="2E8B57"/>
+              <a:srgbClr val="BFDBFE"/>
             </a:solidFill>
             <a:prstDash val="solid"/>
           </a:ln>
@@ -7714,9 +7750,9 @@
               <a:buNone/>
             </a:pPr>
             <a:r>
-              <a:rPr sz="750" b="0">
-                <a:solidFill>
-                  <a:srgbClr val="1E293B"/>
+              <a:rPr sz="1000" b="0">
+                <a:solidFill>
+                  <a:srgbClr val="0F172A"/>
                 </a:solidFill>
                 <a:latin typeface="Calibri"/>
               </a:rPr>
@@ -7744,20 +7780,18 @@
           <a:ln/>
         </p:spPr>
         <p:txBody>
-          <a:bodyPr wrap="square" lIns="0" tIns="0" rIns="0" bIns="0" rtlCol="0" anchor="ctr"/>
+          <a:bodyPr wrap="square" lIns="36576" tIns="18288" rIns="36576" bIns="18288" rtlCol="0" anchor="ctr"/>
           <a:lstStyle/>
           <a:p>
             <a:pPr indent="0" marL="0">
               <a:buNone/>
             </a:pPr>
             <a:r>
-              <a:rPr lang="en-US" sz="1400" b="1" dirty="0">
-                <a:solidFill>
-                  <a:srgbClr val="000000"/>
-                </a:solidFill>
-                <a:latin typeface="Arial" pitchFamily="34" charset="0"/>
-                <a:ea typeface="Arial" pitchFamily="34" charset="-122"/>
-                <a:cs typeface="Arial" pitchFamily="34" charset="-120"/>
+              <a:rPr sz="1200" b="1">
+                <a:solidFill>
+                  <a:srgbClr val="0F172A"/>
+                </a:solidFill>
+                <a:latin typeface="Calibri"/>
               </a:rPr>
               <a:t>Use Cases :</a:t>
             </a:r>
@@ -7780,11 +7814,11 @@
             <a:avLst/>
           </a:prstGeom>
           <a:solidFill>
-            <a:srgbClr val="334155"/>
+            <a:srgbClr val="F8FAFC"/>
           </a:solidFill>
           <a:ln w="12700">
             <a:solidFill>
-              <a:srgbClr val="2E8B57"/>
+              <a:srgbClr val="E2E8F0"/>
             </a:solidFill>
             <a:prstDash val="solid"/>
           </a:ln>
@@ -7839,9 +7873,9 @@
               <a:buNone/>
             </a:pPr>
             <a:r>
-              <a:rPr sz="750" b="0">
-                <a:solidFill>
-                  <a:srgbClr val="1E293B"/>
+              <a:rPr sz="1000" b="0">
+                <a:solidFill>
+                  <a:srgbClr val="0F172A"/>
                 </a:solidFill>
                 <a:latin typeface="Calibri"/>
               </a:rPr>
@@ -7866,11 +7900,11 @@
             <a:avLst/>
           </a:prstGeom>
           <a:solidFill>
-            <a:srgbClr val="334155"/>
+            <a:srgbClr val="F8FAFC"/>
           </a:solidFill>
           <a:ln w="12700">
             <a:solidFill>
-              <a:srgbClr val="2E8B57"/>
+              <a:srgbClr val="E2E8F0"/>
             </a:solidFill>
             <a:prstDash val="solid"/>
           </a:ln>
@@ -7925,9 +7959,9 @@
               <a:buNone/>
             </a:pPr>
             <a:r>
-              <a:rPr sz="750" b="0">
-                <a:solidFill>
-                  <a:srgbClr val="1E293B"/>
+              <a:rPr sz="1000" b="0">
+                <a:solidFill>
+                  <a:srgbClr val="0F172A"/>
                 </a:solidFill>
                 <a:latin typeface="Calibri"/>
               </a:rPr>
@@ -7952,11 +7986,11 @@
             <a:avLst/>
           </a:prstGeom>
           <a:solidFill>
-            <a:srgbClr val="334155"/>
+            <a:srgbClr val="F8FAFC"/>
           </a:solidFill>
           <a:ln w="12700">
             <a:solidFill>
-              <a:srgbClr val="2E8B57"/>
+              <a:srgbClr val="E2E8F0"/>
             </a:solidFill>
             <a:prstDash val="solid"/>
           </a:ln>
@@ -8011,9 +8045,9 @@
               <a:buNone/>
             </a:pPr>
             <a:r>
-              <a:rPr sz="750" b="0">
-                <a:solidFill>
-                  <a:srgbClr val="1E293B"/>
+              <a:rPr sz="1000" b="0">
+                <a:solidFill>
+                  <a:srgbClr val="0F172A"/>
                 </a:solidFill>
                 <a:latin typeface="Calibri"/>
               </a:rPr>
@@ -8041,22 +8075,20 @@
           <a:ln/>
         </p:spPr>
         <p:txBody>
-          <a:bodyPr wrap="square" lIns="0" tIns="0" rIns="0" bIns="0" rtlCol="0" anchor="ctr"/>
+          <a:bodyPr wrap="square" lIns="36576" tIns="18288" rIns="36576" bIns="18288" rtlCol="0" anchor="ctr"/>
           <a:lstStyle/>
           <a:p>
             <a:pPr indent="0" marL="0">
               <a:buNone/>
             </a:pPr>
             <a:r>
-              <a:rPr lang="en-US" sz="1400" b="1" dirty="0">
-                <a:solidFill>
-                  <a:srgbClr val="000000"/>
-                </a:solidFill>
-                <a:latin typeface="Arial" pitchFamily="34" charset="0"/>
-                <a:ea typeface="Arial" pitchFamily="34" charset="-122"/>
-                <a:cs typeface="Arial" pitchFamily="34" charset="-120"/>
-              </a:rPr>
-              <a:t>Build Roadmap</a:t>
+              <a:rPr sz="1200" b="1">
+                <a:solidFill>
+                  <a:srgbClr val="0F172A"/>
+                </a:solidFill>
+                <a:latin typeface="Calibri"/>
+              </a:rPr>
+              <a:t>Build Roadmap :</a:t>
             </a:r>
             <a:endParaRPr lang="en-US" sz="1400" dirty="0"/>
           </a:p>
@@ -8077,11 +8109,11 @@
             <a:avLst/>
           </a:prstGeom>
           <a:solidFill>
-            <a:srgbClr val="0F172A"/>
+            <a:srgbClr val="EFF6FF"/>
           </a:solidFill>
           <a:ln w="12700">
             <a:solidFill>
-              <a:srgbClr val="FFFFFF"/>
+              <a:srgbClr val="BFDBFE"/>
             </a:solidFill>
             <a:prstDash val="solid"/>
           </a:ln>
@@ -8112,9 +8144,9 @@
               <a:buNone/>
             </a:pPr>
             <a:r>
-              <a:rPr sz="800" b="1">
-                <a:solidFill>
-                  <a:srgbClr val="FFFFFF"/>
+              <a:rPr sz="1050" b="1">
+                <a:solidFill>
+                  <a:srgbClr val="0F172A"/>
                 </a:solidFill>
                 <a:latin typeface="Calibri"/>
               </a:rPr>
@@ -8139,11 +8171,11 @@
             <a:avLst/>
           </a:prstGeom>
           <a:solidFill>
-            <a:srgbClr val="1E293B"/>
+            <a:srgbClr val="EFF6FF"/>
           </a:solidFill>
           <a:ln w="12700">
             <a:solidFill>
-              <a:srgbClr val="FFFFFF"/>
+              <a:srgbClr val="BFDBFE"/>
             </a:solidFill>
             <a:prstDash val="solid"/>
           </a:ln>
@@ -8174,9 +8206,9 @@
               <a:buNone/>
             </a:pPr>
             <a:r>
-              <a:rPr sz="800" b="1">
-                <a:solidFill>
-                  <a:srgbClr val="FFFFFF"/>
+              <a:rPr sz="1050" b="1">
+                <a:solidFill>
+                  <a:srgbClr val="0F172A"/>
                 </a:solidFill>
                 <a:latin typeface="Calibri"/>
               </a:rPr>
@@ -8201,11 +8233,11 @@
             <a:avLst/>
           </a:prstGeom>
           <a:solidFill>
-            <a:srgbClr val="1E3A8A"/>
+            <a:srgbClr val="EFF6FF"/>
           </a:solidFill>
           <a:ln w="12700">
             <a:solidFill>
-              <a:srgbClr val="FFFFFF"/>
+              <a:srgbClr val="BFDBFE"/>
             </a:solidFill>
             <a:prstDash val="solid"/>
           </a:ln>
@@ -8236,9 +8268,9 @@
               <a:buNone/>
             </a:pPr>
             <a:r>
-              <a:rPr sz="800" b="1">
-                <a:solidFill>
-                  <a:srgbClr val="FFFFFF"/>
+              <a:rPr sz="1050" b="1">
+                <a:solidFill>
+                  <a:srgbClr val="0F172A"/>
                 </a:solidFill>
                 <a:latin typeface="Calibri"/>
               </a:rPr>
@@ -8263,11 +8295,11 @@
             <a:avLst/>
           </a:prstGeom>
           <a:solidFill>
-            <a:srgbClr val="334155"/>
+            <a:srgbClr val="EFF6FF"/>
           </a:solidFill>
           <a:ln w="12700">
             <a:solidFill>
-              <a:srgbClr val="FFFFFF"/>
+              <a:srgbClr val="BFDBFE"/>
             </a:solidFill>
             <a:prstDash val="solid"/>
           </a:ln>
@@ -8298,9 +8330,9 @@
               <a:buNone/>
             </a:pPr>
             <a:r>
-              <a:rPr sz="800" b="1">
-                <a:solidFill>
-                  <a:srgbClr val="FFFFFF"/>
+              <a:rPr sz="1050" b="1">
+                <a:solidFill>
+                  <a:srgbClr val="0F172A"/>
                 </a:solidFill>
                 <a:latin typeface="Calibri"/>
               </a:rPr>
@@ -8325,11 +8357,11 @@
             <a:avLst/>
           </a:prstGeom>
           <a:solidFill>
-            <a:srgbClr val="0F172A"/>
+            <a:srgbClr val="EFF6FF"/>
           </a:solidFill>
           <a:ln w="12700">
             <a:solidFill>
-              <a:srgbClr val="FFFFFF"/>
+              <a:srgbClr val="BFDBFE"/>
             </a:solidFill>
             <a:prstDash val="solid"/>
           </a:ln>
@@ -8360,9 +8392,9 @@
               <a:buNone/>
             </a:pPr>
             <a:r>
-              <a:rPr sz="800" b="1">
-                <a:solidFill>
-                  <a:srgbClr val="FFFFFF"/>
+              <a:rPr sz="1050" b="1">
+                <a:solidFill>
+                  <a:srgbClr val="0F172A"/>
                 </a:solidFill>
                 <a:latin typeface="Calibri"/>
               </a:rPr>
@@ -8546,11 +8578,11 @@
             <a:avLst/>
           </a:prstGeom>
           <a:solidFill>
-            <a:srgbClr val="1E3A8A"/>
+            <a:srgbClr val="EFF6FF"/>
           </a:solidFill>
           <a:ln w="12700">
             <a:solidFill>
-              <a:srgbClr val="1B5FAE"/>
+              <a:srgbClr val="BFDBFE"/>
             </a:solidFill>
             <a:prstDash val="solid"/>
           </a:ln>
@@ -8613,22 +8645,20 @@
           <a:ln/>
         </p:spPr>
         <p:txBody>
-          <a:bodyPr wrap="square" lIns="0" tIns="0" rIns="0" bIns="0" rtlCol="0" anchor="ctr"/>
+          <a:bodyPr wrap="square" lIns="36576" tIns="18288" rIns="36576" bIns="18288" rtlCol="0" anchor="ctr"/>
           <a:lstStyle/>
           <a:p>
             <a:pPr algn="r" indent="0" marL="0">
               <a:buNone/>
             </a:pPr>
             <a:r>
-              <a:rPr lang="en-US" sz="1200" b="1" dirty="0">
-                <a:solidFill>
-                  <a:srgbClr val="FFFFFF"/>
-                </a:solidFill>
-                <a:latin typeface="Calibri" pitchFamily="34" charset="0"/>
-                <a:ea typeface="Calibri" pitchFamily="34" charset="-122"/>
-                <a:cs typeface="Calibri" pitchFamily="34" charset="-120"/>
-              </a:rPr>
-              <a:t>5</a:t>
+              <a:rPr sz="1200" b="1">
+                <a:solidFill>
+                  <a:srgbClr val="0F172A"/>
+                </a:solidFill>
+                <a:latin typeface="Calibri"/>
+              </a:rPr>
+              <a:t>Who Benefits :</a:t>
             </a:r>
             <a:endParaRPr lang="en-US" sz="1200" dirty="0"/>
           </a:p>
@@ -8688,11 +8718,11 @@
             <a:avLst/>
           </a:prstGeom>
           <a:solidFill>
-            <a:srgbClr val="0F172A"/>
+            <a:srgbClr val="EFF6FF"/>
           </a:solidFill>
           <a:ln w="12700">
             <a:solidFill>
-              <a:srgbClr val="0E2A4A"/>
+              <a:srgbClr val="BFDBFE"/>
             </a:solidFill>
             <a:prstDash val="solid"/>
           </a:ln>
@@ -8750,9 +8780,9 @@
               <a:buNone/>
             </a:pPr>
             <a:r>
-              <a:rPr sz="750" b="0">
-                <a:solidFill>
-                  <a:srgbClr val="1E293B"/>
+              <a:rPr sz="1000" b="0">
+                <a:solidFill>
+                  <a:srgbClr val="0F172A"/>
                 </a:solidFill>
                 <a:latin typeface="Calibri"/>
               </a:rPr>
@@ -8777,11 +8807,11 @@
             <a:avLst/>
           </a:prstGeom>
           <a:solidFill>
-            <a:srgbClr val="0F172A"/>
+            <a:srgbClr val="EFF6FF"/>
           </a:solidFill>
           <a:ln w="12700">
             <a:solidFill>
-              <a:srgbClr val="1B5FAE"/>
+              <a:srgbClr val="BFDBFE"/>
             </a:solidFill>
             <a:prstDash val="solid"/>
           </a:ln>
@@ -8839,9 +8869,9 @@
               <a:buNone/>
             </a:pPr>
             <a:r>
-              <a:rPr sz="750" b="0">
-                <a:solidFill>
-                  <a:srgbClr val="1E293B"/>
+              <a:rPr sz="1000" b="0">
+                <a:solidFill>
+                  <a:srgbClr val="0F172A"/>
                 </a:solidFill>
                 <a:latin typeface="Calibri"/>
               </a:rPr>
@@ -8866,11 +8896,11 @@
             <a:avLst/>
           </a:prstGeom>
           <a:solidFill>
-            <a:srgbClr val="0F172A"/>
+            <a:srgbClr val="EFF6FF"/>
           </a:solidFill>
           <a:ln w="12700">
             <a:solidFill>
-              <a:srgbClr val="E8792A"/>
+              <a:srgbClr val="BFDBFE"/>
             </a:solidFill>
             <a:prstDash val="solid"/>
           </a:ln>
@@ -8928,9 +8958,9 @@
               <a:buNone/>
             </a:pPr>
             <a:r>
-              <a:rPr sz="750" b="0">
-                <a:solidFill>
-                  <a:srgbClr val="1E293B"/>
+              <a:rPr sz="1000" b="0">
+                <a:solidFill>
+                  <a:srgbClr val="0F172A"/>
                 </a:solidFill>
                 <a:latin typeface="Calibri"/>
               </a:rPr>
@@ -8955,11 +8985,11 @@
             <a:avLst/>
           </a:prstGeom>
           <a:solidFill>
-            <a:srgbClr val="0F172A"/>
+            <a:srgbClr val="EFF6FF"/>
           </a:solidFill>
           <a:ln w="12700">
             <a:solidFill>
-              <a:srgbClr val="2E8B57"/>
+              <a:srgbClr val="BFDBFE"/>
             </a:solidFill>
             <a:prstDash val="solid"/>
           </a:ln>
@@ -9017,9 +9047,9 @@
               <a:buNone/>
             </a:pPr>
             <a:r>
-              <a:rPr sz="750" b="0">
-                <a:solidFill>
-                  <a:srgbClr val="1E293B"/>
+              <a:rPr sz="1000" b="0">
+                <a:solidFill>
+                  <a:srgbClr val="0F172A"/>
                 </a:solidFill>
                 <a:latin typeface="Calibri"/>
               </a:rPr>
@@ -9047,20 +9077,18 @@
           <a:ln/>
         </p:spPr>
         <p:txBody>
-          <a:bodyPr wrap="square" lIns="0" tIns="0" rIns="0" bIns="0" rtlCol="0" anchor="ctr"/>
+          <a:bodyPr wrap="square" lIns="36576" tIns="18288" rIns="36576" bIns="18288" rtlCol="0" anchor="ctr"/>
           <a:lstStyle/>
           <a:p>
             <a:pPr indent="0" marL="0">
               <a:buNone/>
             </a:pPr>
             <a:r>
-              <a:rPr lang="en-US" sz="1400" b="1" dirty="0">
-                <a:solidFill>
-                  <a:srgbClr val="000000"/>
-                </a:solidFill>
-                <a:latin typeface="Arial" pitchFamily="34" charset="0"/>
-                <a:ea typeface="Arial" pitchFamily="34" charset="-122"/>
-                <a:cs typeface="Arial" pitchFamily="34" charset="-120"/>
+              <a:rPr sz="1200" b="1">
+                <a:solidFill>
+                  <a:srgbClr val="0F172A"/>
+                </a:solidFill>
+                <a:latin typeface="Calibri"/>
               </a:rPr>
               <a:t>Benefits :</a:t>
             </a:r>
@@ -9083,11 +9111,11 @@
             <a:avLst/>
           </a:prstGeom>
           <a:solidFill>
-            <a:srgbClr val="1E293B"/>
+            <a:srgbClr val="F8FAFC"/>
           </a:solidFill>
           <a:ln w="12700">
             <a:solidFill>
-              <a:srgbClr val="139488"/>
+              <a:srgbClr val="E2E8F0"/>
             </a:solidFill>
             <a:prstDash val="solid"/>
           </a:ln>
@@ -9145,9 +9173,9 @@
               <a:buNone/>
             </a:pPr>
             <a:r>
-              <a:rPr sz="750" b="0">
-                <a:solidFill>
-                  <a:srgbClr val="1E293B"/>
+              <a:rPr sz="1000" b="0">
+                <a:solidFill>
+                  <a:srgbClr val="0F172A"/>
                 </a:solidFill>
                 <a:latin typeface="Calibri"/>
               </a:rPr>
@@ -9172,11 +9200,11 @@
             <a:avLst/>
           </a:prstGeom>
           <a:solidFill>
-            <a:srgbClr val="1E293B"/>
+            <a:srgbClr val="F8FAFC"/>
           </a:solidFill>
           <a:ln w="12700">
             <a:solidFill>
-              <a:srgbClr val="2E8B57"/>
+              <a:srgbClr val="E2E8F0"/>
             </a:solidFill>
             <a:prstDash val="solid"/>
           </a:ln>
@@ -9234,9 +9262,9 @@
               <a:buNone/>
             </a:pPr>
             <a:r>
-              <a:rPr sz="750" b="0">
-                <a:solidFill>
-                  <a:srgbClr val="1E293B"/>
+              <a:rPr sz="1000" b="0">
+                <a:solidFill>
+                  <a:srgbClr val="0F172A"/>
                 </a:solidFill>
                 <a:latin typeface="Calibri"/>
               </a:rPr>
@@ -9264,20 +9292,18 @@
           <a:ln/>
         </p:spPr>
         <p:txBody>
-          <a:bodyPr wrap="square" lIns="0" tIns="0" rIns="0" bIns="0" rtlCol="0" anchor="ctr"/>
+          <a:bodyPr wrap="square" lIns="36576" tIns="18288" rIns="36576" bIns="18288" rtlCol="0" anchor="ctr"/>
           <a:lstStyle/>
           <a:p>
             <a:pPr indent="0" marL="0">
               <a:buNone/>
             </a:pPr>
             <a:r>
-              <a:rPr lang="en-US" sz="1400" b="1" dirty="0">
-                <a:solidFill>
-                  <a:srgbClr val="000000"/>
-                </a:solidFill>
-                <a:latin typeface="Arial" pitchFamily="34" charset="0"/>
-                <a:ea typeface="Arial" pitchFamily="34" charset="-122"/>
-                <a:cs typeface="Arial" pitchFamily="34" charset="-120"/>
+              <a:rPr sz="1200" b="1">
+                <a:solidFill>
+                  <a:srgbClr val="0F172A"/>
+                </a:solidFill>
+                <a:latin typeface="Calibri"/>
               </a:rPr>
               <a:t>Scalability Path :</a:t>
             </a:r>
@@ -9302,11 +9328,11 @@
             </a:avLst>
           </a:prstGeom>
           <a:solidFill>
-            <a:srgbClr val="0F172A"/>
+            <a:srgbClr val="EFF6FF"/>
           </a:solidFill>
           <a:ln w="12700">
             <a:solidFill>
-              <a:srgbClr val="1B5FAE"/>
+              <a:srgbClr val="BFDBFE"/>
             </a:solidFill>
             <a:prstDash val="solid"/>
           </a:ln>
@@ -9337,9 +9363,9 @@
               <a:buNone/>
             </a:pPr>
             <a:r>
-              <a:rPr sz="900" b="1">
-                <a:solidFill>
-                  <a:srgbClr val="FFFFFF"/>
+              <a:rPr sz="1100" b="1">
+                <a:solidFill>
+                  <a:srgbClr val="1E3A8A"/>
                 </a:solidFill>
                 <a:latin typeface="Calibri"/>
               </a:rPr>
@@ -9374,9 +9400,9 @@
               <a:buNone/>
             </a:pPr>
             <a:r>
-              <a:rPr sz="850" b="1">
-                <a:solidFill>
-                  <a:srgbClr val="FFFFFF"/>
+              <a:rPr sz="1050" b="1">
+                <a:solidFill>
+                  <a:srgbClr val="0F172A"/>
                 </a:solidFill>
                 <a:latin typeface="Calibri"/>
               </a:rPr>
@@ -9411,9 +9437,9 @@
               <a:buNone/>
             </a:pPr>
             <a:r>
-              <a:rPr sz="750" b="0">
-                <a:solidFill>
-                  <a:srgbClr val="E2E8F0"/>
+              <a:rPr sz="1000" b="0">
+                <a:solidFill>
+                  <a:srgbClr val="0F172A"/>
                 </a:solidFill>
                 <a:latin typeface="Calibri"/>
               </a:rPr>
@@ -9464,11 +9490,11 @@
             </a:avLst>
           </a:prstGeom>
           <a:solidFill>
-            <a:srgbClr val="1E293B"/>
+            <a:srgbClr val="F8FAFC"/>
           </a:solidFill>
           <a:ln w="12700">
             <a:solidFill>
-              <a:srgbClr val="E8792A"/>
+              <a:srgbClr val="E2E8F0"/>
             </a:solidFill>
             <a:prstDash val="solid"/>
           </a:ln>
@@ -9499,9 +9525,9 @@
               <a:buNone/>
             </a:pPr>
             <a:r>
-              <a:rPr sz="900" b="1">
-                <a:solidFill>
-                  <a:srgbClr val="FFFFFF"/>
+              <a:rPr sz="1100" b="1">
+                <a:solidFill>
+                  <a:srgbClr val="1E3A8A"/>
                 </a:solidFill>
                 <a:latin typeface="Calibri"/>
               </a:rPr>
@@ -9536,9 +9562,9 @@
               <a:buNone/>
             </a:pPr>
             <a:r>
-              <a:rPr sz="850" b="1">
-                <a:solidFill>
-                  <a:srgbClr val="FFFFFF"/>
+              <a:rPr sz="1050" b="1">
+                <a:solidFill>
+                  <a:srgbClr val="0F172A"/>
                 </a:solidFill>
                 <a:latin typeface="Calibri"/>
               </a:rPr>
@@ -9573,9 +9599,9 @@
               <a:buNone/>
             </a:pPr>
             <a:r>
-              <a:rPr sz="750" b="0">
-                <a:solidFill>
-                  <a:srgbClr val="E2E8F0"/>
+              <a:rPr sz="1000" b="0">
+                <a:solidFill>
+                  <a:srgbClr val="0F172A"/>
                 </a:solidFill>
                 <a:latin typeface="Calibri"/>
               </a:rPr>
@@ -9626,11 +9652,11 @@
             </a:avLst>
           </a:prstGeom>
           <a:solidFill>
-            <a:srgbClr val="1E3A8A"/>
+            <a:srgbClr val="EFF6FF"/>
           </a:solidFill>
           <a:ln w="12700">
             <a:solidFill>
-              <a:srgbClr val="0E2A4A"/>
+              <a:srgbClr val="BFDBFE"/>
             </a:solidFill>
             <a:prstDash val="solid"/>
           </a:ln>
@@ -9661,9 +9687,9 @@
               <a:buNone/>
             </a:pPr>
             <a:r>
-              <a:rPr sz="900" b="1">
-                <a:solidFill>
-                  <a:srgbClr val="FFFFFF"/>
+              <a:rPr sz="1100" b="1">
+                <a:solidFill>
+                  <a:srgbClr val="1E3A8A"/>
                 </a:solidFill>
                 <a:latin typeface="Calibri"/>
               </a:rPr>
@@ -9698,9 +9724,9 @@
               <a:buNone/>
             </a:pPr>
             <a:r>
-              <a:rPr sz="850" b="1">
-                <a:solidFill>
-                  <a:srgbClr val="FFFFFF"/>
+              <a:rPr sz="1050" b="1">
+                <a:solidFill>
+                  <a:srgbClr val="0F172A"/>
                 </a:solidFill>
                 <a:latin typeface="Calibri"/>
               </a:rPr>
@@ -9735,9 +9761,9 @@
               <a:buNone/>
             </a:pPr>
             <a:r>
-              <a:rPr sz="750" b="0">
-                <a:solidFill>
-                  <a:srgbClr val="E2E8F0"/>
+              <a:rPr sz="1000" b="0">
+                <a:solidFill>
+                  <a:srgbClr val="0F172A"/>
                 </a:solidFill>
                 <a:latin typeface="Calibri"/>
               </a:rPr>
@@ -9765,20 +9791,18 @@
           <a:ln/>
         </p:spPr>
         <p:txBody>
-          <a:bodyPr wrap="square" lIns="0" tIns="0" rIns="0" bIns="0" rtlCol="0" anchor="ctr"/>
+          <a:bodyPr wrap="square" lIns="36576" tIns="18288" rIns="36576" bIns="18288" rtlCol="0" anchor="ctr"/>
           <a:lstStyle/>
           <a:p>
             <a:pPr indent="0" marL="0">
               <a:buNone/>
             </a:pPr>
             <a:r>
-              <a:rPr lang="en-US" sz="1400" b="1" dirty="0">
-                <a:solidFill>
-                  <a:srgbClr val="000000"/>
-                </a:solidFill>
-                <a:latin typeface="Arial" pitchFamily="34" charset="0"/>
-                <a:ea typeface="Arial" pitchFamily="34" charset="-122"/>
-                <a:cs typeface="Arial" pitchFamily="34" charset="-120"/>
+              <a:rPr sz="1200" b="1">
+                <a:solidFill>
+                  <a:srgbClr val="0F172A"/>
+                </a:solidFill>
+                <a:latin typeface="Calibri"/>
               </a:rPr>
               <a:t>Deliverable per Vulnerability (8 required fields) :</a:t>
             </a:r>
@@ -9801,11 +9825,11 @@
             <a:avLst/>
           </a:prstGeom>
           <a:solidFill>
-            <a:srgbClr val="0F172A"/>
+            <a:srgbClr val="EFF6FF"/>
           </a:solidFill>
           <a:ln w="12700">
             <a:solidFill>
-              <a:srgbClr val="1B5FAE"/>
+              <a:srgbClr val="BFDBFE"/>
             </a:solidFill>
             <a:prstDash val="solid"/>
           </a:ln>
@@ -9829,20 +9853,18 @@
           <a:ln/>
         </p:spPr>
         <p:txBody>
-          <a:bodyPr wrap="square" lIns="0" tIns="0" rIns="0" bIns="0" rtlCol="0" anchor="ctr"/>
+          <a:bodyPr wrap="square" lIns="36576" tIns="18288" rIns="36576" bIns="18288" rtlCol="0" anchor="ctr"/>
           <a:lstStyle/>
           <a:p>
             <a:pPr algn="ctr" indent="0" marL="0">
               <a:buNone/>
             </a:pPr>
             <a:r>
-              <a:rPr lang="en-US" sz="1300" b="1" dirty="0">
-                <a:solidFill>
-                  <a:srgbClr val="FFFFFF"/>
-                </a:solidFill>
-                <a:latin typeface="Calibri" pitchFamily="34" charset="0"/>
-                <a:ea typeface="Calibri" pitchFamily="34" charset="-122"/>
-                <a:cs typeface="Calibri" pitchFamily="34" charset="-120"/>
+              <a:rPr sz="1200" b="1">
+                <a:solidFill>
+                  <a:srgbClr val="0F172A"/>
+                </a:solidFill>
+                <a:latin typeface="Calibri"/>
               </a:rPr>
               <a:t>1</a:t>
             </a:r>
@@ -9875,9 +9897,9 @@
               <a:buNone/>
             </a:pPr>
             <a:r>
-              <a:rPr sz="750" b="1">
-                <a:solidFill>
-                  <a:srgbClr val="1E293B"/>
+              <a:rPr sz="1000" b="1">
+                <a:solidFill>
+                  <a:srgbClr val="0F172A"/>
                 </a:solidFill>
                 <a:latin typeface="Calibri"/>
               </a:rPr>
@@ -9902,11 +9924,11 @@
             <a:avLst/>
           </a:prstGeom>
           <a:solidFill>
-            <a:srgbClr val="0F172A"/>
+            <a:srgbClr val="EFF6FF"/>
           </a:solidFill>
           <a:ln w="12700">
             <a:solidFill>
-              <a:srgbClr val="E8792A"/>
+              <a:srgbClr val="BFDBFE"/>
             </a:solidFill>
             <a:prstDash val="solid"/>
           </a:ln>
@@ -9930,20 +9952,18 @@
           <a:ln/>
         </p:spPr>
         <p:txBody>
-          <a:bodyPr wrap="square" lIns="0" tIns="0" rIns="0" bIns="0" rtlCol="0" anchor="ctr"/>
+          <a:bodyPr wrap="square" lIns="36576" tIns="18288" rIns="36576" bIns="18288" rtlCol="0" anchor="ctr"/>
           <a:lstStyle/>
           <a:p>
             <a:pPr algn="ctr" indent="0" marL="0">
               <a:buNone/>
             </a:pPr>
             <a:r>
-              <a:rPr lang="en-US" sz="1300" b="1" dirty="0">
-                <a:solidFill>
-                  <a:srgbClr val="FFFFFF"/>
-                </a:solidFill>
-                <a:latin typeface="Calibri" pitchFamily="34" charset="0"/>
-                <a:ea typeface="Calibri" pitchFamily="34" charset="-122"/>
-                <a:cs typeface="Calibri" pitchFamily="34" charset="-120"/>
+              <a:rPr sz="1200" b="1">
+                <a:solidFill>
+                  <a:srgbClr val="0F172A"/>
+                </a:solidFill>
+                <a:latin typeface="Calibri"/>
               </a:rPr>
               <a:t>2</a:t>
             </a:r>
@@ -9976,9 +9996,9 @@
               <a:buNone/>
             </a:pPr>
             <a:r>
-              <a:rPr sz="750" b="1">
-                <a:solidFill>
-                  <a:srgbClr val="1E293B"/>
+              <a:rPr sz="1000" b="1">
+                <a:solidFill>
+                  <a:srgbClr val="0F172A"/>
                 </a:solidFill>
                 <a:latin typeface="Calibri"/>
               </a:rPr>
@@ -10003,11 +10023,11 @@
             <a:avLst/>
           </a:prstGeom>
           <a:solidFill>
-            <a:srgbClr val="0F172A"/>
+            <a:srgbClr val="EFF6FF"/>
           </a:solidFill>
           <a:ln w="12700">
             <a:solidFill>
-              <a:srgbClr val="139488"/>
+              <a:srgbClr val="BFDBFE"/>
             </a:solidFill>
             <a:prstDash val="solid"/>
           </a:ln>
@@ -10031,20 +10051,18 @@
           <a:ln/>
         </p:spPr>
         <p:txBody>
-          <a:bodyPr wrap="square" lIns="0" tIns="0" rIns="0" bIns="0" rtlCol="0" anchor="ctr"/>
+          <a:bodyPr wrap="square" lIns="36576" tIns="18288" rIns="36576" bIns="18288" rtlCol="0" anchor="ctr"/>
           <a:lstStyle/>
           <a:p>
             <a:pPr algn="ctr" indent="0" marL="0">
               <a:buNone/>
             </a:pPr>
             <a:r>
-              <a:rPr lang="en-US" sz="1300" b="1" dirty="0">
-                <a:solidFill>
-                  <a:srgbClr val="FFFFFF"/>
-                </a:solidFill>
-                <a:latin typeface="Calibri" pitchFamily="34" charset="0"/>
-                <a:ea typeface="Calibri" pitchFamily="34" charset="-122"/>
-                <a:cs typeface="Calibri" pitchFamily="34" charset="-120"/>
+              <a:rPr sz="1200" b="1">
+                <a:solidFill>
+                  <a:srgbClr val="0F172A"/>
+                </a:solidFill>
+                <a:latin typeface="Calibri"/>
               </a:rPr>
               <a:t>3</a:t>
             </a:r>
@@ -10077,9 +10095,9 @@
               <a:buNone/>
             </a:pPr>
             <a:r>
-              <a:rPr sz="750" b="1">
-                <a:solidFill>
-                  <a:srgbClr val="1E293B"/>
+              <a:rPr sz="1000" b="1">
+                <a:solidFill>
+                  <a:srgbClr val="0F172A"/>
                 </a:solidFill>
                 <a:latin typeface="Calibri"/>
               </a:rPr>
@@ -10104,11 +10122,11 @@
             <a:avLst/>
           </a:prstGeom>
           <a:solidFill>
-            <a:srgbClr val="0F172A"/>
+            <a:srgbClr val="EFF6FF"/>
           </a:solidFill>
           <a:ln w="12700">
             <a:solidFill>
-              <a:srgbClr val="D64545"/>
+              <a:srgbClr val="BFDBFE"/>
             </a:solidFill>
             <a:prstDash val="solid"/>
           </a:ln>
@@ -10132,20 +10150,18 @@
           <a:ln/>
         </p:spPr>
         <p:txBody>
-          <a:bodyPr wrap="square" lIns="0" tIns="0" rIns="0" bIns="0" rtlCol="0" anchor="ctr"/>
+          <a:bodyPr wrap="square" lIns="36576" tIns="18288" rIns="36576" bIns="18288" rtlCol="0" anchor="ctr"/>
           <a:lstStyle/>
           <a:p>
             <a:pPr algn="ctr" indent="0" marL="0">
               <a:buNone/>
             </a:pPr>
             <a:r>
-              <a:rPr lang="en-US" sz="1300" b="1" dirty="0">
-                <a:solidFill>
-                  <a:srgbClr val="FFFFFF"/>
-                </a:solidFill>
-                <a:latin typeface="Calibri" pitchFamily="34" charset="0"/>
-                <a:ea typeface="Calibri" pitchFamily="34" charset="-122"/>
-                <a:cs typeface="Calibri" pitchFamily="34" charset="-120"/>
+              <a:rPr sz="1200" b="1">
+                <a:solidFill>
+                  <a:srgbClr val="0F172A"/>
+                </a:solidFill>
+                <a:latin typeface="Calibri"/>
               </a:rPr>
               <a:t>4</a:t>
             </a:r>
@@ -10178,9 +10194,9 @@
               <a:buNone/>
             </a:pPr>
             <a:r>
-              <a:rPr sz="750" b="1">
-                <a:solidFill>
-                  <a:srgbClr val="1E293B"/>
+              <a:rPr sz="1000" b="1">
+                <a:solidFill>
+                  <a:srgbClr val="0F172A"/>
                 </a:solidFill>
                 <a:latin typeface="Calibri"/>
               </a:rPr>
@@ -10205,11 +10221,11 @@
             <a:avLst/>
           </a:prstGeom>
           <a:solidFill>
-            <a:srgbClr val="0F172A"/>
+            <a:srgbClr val="EFF6FF"/>
           </a:solidFill>
           <a:ln w="12700">
             <a:solidFill>
-              <a:srgbClr val="1B5FAE"/>
+              <a:srgbClr val="BFDBFE"/>
             </a:solidFill>
             <a:prstDash val="solid"/>
           </a:ln>
@@ -10233,20 +10249,18 @@
           <a:ln/>
         </p:spPr>
         <p:txBody>
-          <a:bodyPr wrap="square" lIns="0" tIns="0" rIns="0" bIns="0" rtlCol="0" anchor="ctr"/>
+          <a:bodyPr wrap="square" lIns="36576" tIns="18288" rIns="36576" bIns="18288" rtlCol="0" anchor="ctr"/>
           <a:lstStyle/>
           <a:p>
             <a:pPr algn="ctr" indent="0" marL="0">
               <a:buNone/>
             </a:pPr>
             <a:r>
-              <a:rPr lang="en-US" sz="1300" b="1" dirty="0">
-                <a:solidFill>
-                  <a:srgbClr val="FFFFFF"/>
-                </a:solidFill>
-                <a:latin typeface="Calibri" pitchFamily="34" charset="0"/>
-                <a:ea typeface="Calibri" pitchFamily="34" charset="-122"/>
-                <a:cs typeface="Calibri" pitchFamily="34" charset="-120"/>
+              <a:rPr sz="1200" b="1">
+                <a:solidFill>
+                  <a:srgbClr val="0F172A"/>
+                </a:solidFill>
+                <a:latin typeface="Calibri"/>
               </a:rPr>
               <a:t>5</a:t>
             </a:r>
@@ -10279,9 +10293,9 @@
               <a:buNone/>
             </a:pPr>
             <a:r>
-              <a:rPr sz="750" b="1">
-                <a:solidFill>
-                  <a:srgbClr val="1E293B"/>
+              <a:rPr sz="1000" b="1">
+                <a:solidFill>
+                  <a:srgbClr val="0F172A"/>
                 </a:solidFill>
                 <a:latin typeface="Calibri"/>
               </a:rPr>
@@ -10306,11 +10320,11 @@
             <a:avLst/>
           </a:prstGeom>
           <a:solidFill>
-            <a:srgbClr val="0F172A"/>
+            <a:srgbClr val="EFF6FF"/>
           </a:solidFill>
           <a:ln w="12700">
             <a:solidFill>
-              <a:srgbClr val="E8792A"/>
+              <a:srgbClr val="BFDBFE"/>
             </a:solidFill>
             <a:prstDash val="solid"/>
           </a:ln>
@@ -10334,20 +10348,18 @@
           <a:ln/>
         </p:spPr>
         <p:txBody>
-          <a:bodyPr wrap="square" lIns="0" tIns="0" rIns="0" bIns="0" rtlCol="0" anchor="ctr"/>
+          <a:bodyPr wrap="square" lIns="36576" tIns="18288" rIns="36576" bIns="18288" rtlCol="0" anchor="ctr"/>
           <a:lstStyle/>
           <a:p>
             <a:pPr algn="ctr" indent="0" marL="0">
               <a:buNone/>
             </a:pPr>
             <a:r>
-              <a:rPr lang="en-US" sz="1300" b="1" dirty="0">
-                <a:solidFill>
-                  <a:srgbClr val="FFFFFF"/>
-                </a:solidFill>
-                <a:latin typeface="Calibri" pitchFamily="34" charset="0"/>
-                <a:ea typeface="Calibri" pitchFamily="34" charset="-122"/>
-                <a:cs typeface="Calibri" pitchFamily="34" charset="-120"/>
+              <a:rPr sz="1200" b="1">
+                <a:solidFill>
+                  <a:srgbClr val="0F172A"/>
+                </a:solidFill>
+                <a:latin typeface="Calibri"/>
               </a:rPr>
               <a:t>6</a:t>
             </a:r>
@@ -10380,9 +10392,9 @@
               <a:buNone/>
             </a:pPr>
             <a:r>
-              <a:rPr sz="750" b="1">
-                <a:solidFill>
-                  <a:srgbClr val="1E293B"/>
+              <a:rPr sz="1000" b="1">
+                <a:solidFill>
+                  <a:srgbClr val="0F172A"/>
                 </a:solidFill>
                 <a:latin typeface="Calibri"/>
               </a:rPr>
@@ -10407,11 +10419,11 @@
             <a:avLst/>
           </a:prstGeom>
           <a:solidFill>
-            <a:srgbClr val="0F172A"/>
+            <a:srgbClr val="EFF6FF"/>
           </a:solidFill>
           <a:ln w="12700">
             <a:solidFill>
-              <a:srgbClr val="139488"/>
+              <a:srgbClr val="BFDBFE"/>
             </a:solidFill>
             <a:prstDash val="solid"/>
           </a:ln>
@@ -10435,20 +10447,18 @@
           <a:ln/>
         </p:spPr>
         <p:txBody>
-          <a:bodyPr wrap="square" lIns="0" tIns="0" rIns="0" bIns="0" rtlCol="0" anchor="ctr"/>
+          <a:bodyPr wrap="square" lIns="36576" tIns="18288" rIns="36576" bIns="18288" rtlCol="0" anchor="ctr"/>
           <a:lstStyle/>
           <a:p>
             <a:pPr algn="ctr" indent="0" marL="0">
               <a:buNone/>
             </a:pPr>
             <a:r>
-              <a:rPr lang="en-US" sz="1300" b="1" dirty="0">
-                <a:solidFill>
-                  <a:srgbClr val="FFFFFF"/>
-                </a:solidFill>
-                <a:latin typeface="Calibri" pitchFamily="34" charset="0"/>
-                <a:ea typeface="Calibri" pitchFamily="34" charset="-122"/>
-                <a:cs typeface="Calibri" pitchFamily="34" charset="-120"/>
+              <a:rPr sz="1200" b="1">
+                <a:solidFill>
+                  <a:srgbClr val="0F172A"/>
+                </a:solidFill>
+                <a:latin typeface="Calibri"/>
               </a:rPr>
               <a:t>7</a:t>
             </a:r>
@@ -10481,9 +10491,9 @@
               <a:buNone/>
             </a:pPr>
             <a:r>
-              <a:rPr sz="750" b="1">
-                <a:solidFill>
-                  <a:srgbClr val="1E293B"/>
+              <a:rPr sz="1000" b="1">
+                <a:solidFill>
+                  <a:srgbClr val="0F172A"/>
                 </a:solidFill>
                 <a:latin typeface="Calibri"/>
               </a:rPr>
@@ -10508,11 +10518,11 @@
             <a:avLst/>
           </a:prstGeom>
           <a:solidFill>
-            <a:srgbClr val="0F172A"/>
+            <a:srgbClr val="EFF6FF"/>
           </a:solidFill>
           <a:ln w="12700">
             <a:solidFill>
-              <a:srgbClr val="0E2A4A"/>
+              <a:srgbClr val="BFDBFE"/>
             </a:solidFill>
             <a:prstDash val="solid"/>
           </a:ln>
@@ -10536,20 +10546,18 @@
           <a:ln/>
         </p:spPr>
         <p:txBody>
-          <a:bodyPr wrap="square" lIns="0" tIns="0" rIns="0" bIns="0" rtlCol="0" anchor="ctr"/>
+          <a:bodyPr wrap="square" lIns="36576" tIns="18288" rIns="36576" bIns="18288" rtlCol="0" anchor="ctr"/>
           <a:lstStyle/>
           <a:p>
             <a:pPr algn="ctr" indent="0" marL="0">
               <a:buNone/>
             </a:pPr>
             <a:r>
-              <a:rPr lang="en-US" sz="1300" b="1" dirty="0">
-                <a:solidFill>
-                  <a:srgbClr val="FFFFFF"/>
-                </a:solidFill>
-                <a:latin typeface="Calibri" pitchFamily="34" charset="0"/>
-                <a:ea typeface="Calibri" pitchFamily="34" charset="-122"/>
-                <a:cs typeface="Calibri" pitchFamily="34" charset="-120"/>
+              <a:rPr sz="1200" b="1">
+                <a:solidFill>
+                  <a:srgbClr val="0F172A"/>
+                </a:solidFill>
+                <a:latin typeface="Calibri"/>
               </a:rPr>
               <a:t>8</a:t>
             </a:r>
@@ -10582,9 +10590,9 @@
               <a:buNone/>
             </a:pPr>
             <a:r>
-              <a:rPr sz="750" b="1">
-                <a:solidFill>
-                  <a:srgbClr val="1E293B"/>
+              <a:rPr sz="1000" b="1">
+                <a:solidFill>
+                  <a:srgbClr val="0F172A"/>
                 </a:solidFill>
                 <a:latin typeface="Calibri"/>
               </a:rPr>
@@ -10768,11 +10776,11 @@
             <a:avLst/>
           </a:prstGeom>
           <a:solidFill>
-            <a:srgbClr val="1E3A8A"/>
+            <a:srgbClr val="EFF6FF"/>
           </a:solidFill>
           <a:ln w="12700">
             <a:solidFill>
-              <a:srgbClr val="1B5FAE"/>
+              <a:srgbClr val="BFDBFE"/>
             </a:solidFill>
             <a:prstDash val="solid"/>
           </a:ln>
@@ -10871,11 +10879,11 @@
             <a:avLst/>
           </a:prstGeom>
           <a:solidFill>
-            <a:srgbClr val="0F172A"/>
+            <a:srgbClr val="EFF6FF"/>
           </a:solidFill>
           <a:ln w="12700">
             <a:solidFill>
-              <a:srgbClr val="1B5FAE"/>
+              <a:srgbClr val="BFDBFE"/>
             </a:solidFill>
             <a:prstDash val="solid"/>
           </a:ln>
@@ -10899,20 +10907,18 @@
           <a:ln/>
         </p:spPr>
         <p:txBody>
-          <a:bodyPr wrap="square" lIns="0" tIns="0" rIns="0" bIns="0" rtlCol="0" anchor="ctr"/>
+          <a:bodyPr wrap="square" lIns="36576" tIns="18288" rIns="36576" bIns="18288" rtlCol="0" anchor="ctr"/>
           <a:lstStyle/>
           <a:p>
             <a:pPr algn="ctr" indent="0" marL="0">
               <a:buNone/>
             </a:pPr>
             <a:r>
-              <a:rPr lang="en-US" sz="1300" b="1" dirty="0">
-                <a:solidFill>
-                  <a:srgbClr val="FFFFFF"/>
-                </a:solidFill>
-                <a:latin typeface="Calibri" pitchFamily="34" charset="0"/>
-                <a:ea typeface="Calibri" pitchFamily="34" charset="-122"/>
-                <a:cs typeface="Calibri" pitchFamily="34" charset="-120"/>
+              <a:rPr sz="1200" b="1">
+                <a:solidFill>
+                  <a:srgbClr val="0F172A"/>
+                </a:solidFill>
+                <a:latin typeface="Calibri"/>
               </a:rPr>
               <a:t>1</a:t>
             </a:r>
@@ -10945,9 +10951,9 @@
               <a:buNone/>
             </a:pPr>
             <a:r>
-              <a:rPr sz="750" b="1">
-                <a:solidFill>
-                  <a:srgbClr val="1E293B"/>
+              <a:rPr sz="1000" b="1">
+                <a:solidFill>
+                  <a:srgbClr val="0F172A"/>
                 </a:solidFill>
                 <a:latin typeface="Calibri"/>
               </a:rPr>
@@ -10982,7 +10988,7 @@
               <a:buNone/>
             </a:pPr>
             <a:r>
-              <a:rPr sz="700" b="0">
+              <a:rPr sz="1000" b="0">
                 <a:solidFill>
                   <a:srgbClr val="475569"/>
                 </a:solidFill>
@@ -11032,11 +11038,11 @@
             <a:avLst/>
           </a:prstGeom>
           <a:solidFill>
-            <a:srgbClr val="0F172A"/>
+            <a:srgbClr val="EFF6FF"/>
           </a:solidFill>
           <a:ln w="12700">
             <a:solidFill>
-              <a:srgbClr val="E8792A"/>
+              <a:srgbClr val="BFDBFE"/>
             </a:solidFill>
             <a:prstDash val="solid"/>
           </a:ln>
@@ -11060,20 +11066,18 @@
           <a:ln/>
         </p:spPr>
         <p:txBody>
-          <a:bodyPr wrap="square" lIns="0" tIns="0" rIns="0" bIns="0" rtlCol="0" anchor="ctr"/>
+          <a:bodyPr wrap="square" lIns="36576" tIns="18288" rIns="36576" bIns="18288" rtlCol="0" anchor="ctr"/>
           <a:lstStyle/>
           <a:p>
             <a:pPr algn="ctr" indent="0" marL="0">
               <a:buNone/>
             </a:pPr>
             <a:r>
-              <a:rPr lang="en-US" sz="1300" b="1" dirty="0">
-                <a:solidFill>
-                  <a:srgbClr val="FFFFFF"/>
-                </a:solidFill>
-                <a:latin typeface="Calibri" pitchFamily="34" charset="0"/>
-                <a:ea typeface="Calibri" pitchFamily="34" charset="-122"/>
-                <a:cs typeface="Calibri" pitchFamily="34" charset="-120"/>
+              <a:rPr sz="1200" b="1">
+                <a:solidFill>
+                  <a:srgbClr val="0F172A"/>
+                </a:solidFill>
+                <a:latin typeface="Calibri"/>
               </a:rPr>
               <a:t>2</a:t>
             </a:r>
@@ -11106,9 +11110,9 @@
               <a:buNone/>
             </a:pPr>
             <a:r>
-              <a:rPr sz="750" b="1">
-                <a:solidFill>
-                  <a:srgbClr val="1E293B"/>
+              <a:rPr sz="1000" b="1">
+                <a:solidFill>
+                  <a:srgbClr val="0F172A"/>
                 </a:solidFill>
                 <a:latin typeface="Calibri"/>
               </a:rPr>
@@ -11143,7 +11147,7 @@
               <a:buNone/>
             </a:pPr>
             <a:r>
-              <a:rPr sz="700" b="0">
+              <a:rPr sz="1000" b="0">
                 <a:solidFill>
                   <a:srgbClr val="475569"/>
                 </a:solidFill>
@@ -11193,11 +11197,11 @@
             <a:avLst/>
           </a:prstGeom>
           <a:solidFill>
-            <a:srgbClr val="0F172A"/>
+            <a:srgbClr val="EFF6FF"/>
           </a:solidFill>
           <a:ln w="12700">
             <a:solidFill>
-              <a:srgbClr val="139488"/>
+              <a:srgbClr val="BFDBFE"/>
             </a:solidFill>
             <a:prstDash val="solid"/>
           </a:ln>
@@ -11221,20 +11225,18 @@
           <a:ln/>
         </p:spPr>
         <p:txBody>
-          <a:bodyPr wrap="square" lIns="0" tIns="0" rIns="0" bIns="0" rtlCol="0" anchor="ctr"/>
+          <a:bodyPr wrap="square" lIns="36576" tIns="18288" rIns="36576" bIns="18288" rtlCol="0" anchor="ctr"/>
           <a:lstStyle/>
           <a:p>
             <a:pPr algn="ctr" indent="0" marL="0">
               <a:buNone/>
             </a:pPr>
             <a:r>
-              <a:rPr lang="en-US" sz="1300" b="1" dirty="0">
-                <a:solidFill>
-                  <a:srgbClr val="FFFFFF"/>
-                </a:solidFill>
-                <a:latin typeface="Calibri" pitchFamily="34" charset="0"/>
-                <a:ea typeface="Calibri" pitchFamily="34" charset="-122"/>
-                <a:cs typeface="Calibri" pitchFamily="34" charset="-120"/>
+              <a:rPr sz="1200" b="1">
+                <a:solidFill>
+                  <a:srgbClr val="0F172A"/>
+                </a:solidFill>
+                <a:latin typeface="Calibri"/>
               </a:rPr>
               <a:t>3</a:t>
             </a:r>
@@ -11267,9 +11269,9 @@
               <a:buNone/>
             </a:pPr>
             <a:r>
-              <a:rPr sz="750" b="1">
-                <a:solidFill>
-                  <a:srgbClr val="1E293B"/>
+              <a:rPr sz="1000" b="1">
+                <a:solidFill>
+                  <a:srgbClr val="0F172A"/>
                 </a:solidFill>
                 <a:latin typeface="Calibri"/>
               </a:rPr>
@@ -11304,7 +11306,7 @@
               <a:buNone/>
             </a:pPr>
             <a:r>
-              <a:rPr sz="700" b="0">
+              <a:rPr sz="1000" b="0">
                 <a:solidFill>
                   <a:srgbClr val="475569"/>
                 </a:solidFill>
@@ -11354,11 +11356,11 @@
             <a:avLst/>
           </a:prstGeom>
           <a:solidFill>
-            <a:srgbClr val="0F172A"/>
+            <a:srgbClr val="EFF6FF"/>
           </a:solidFill>
           <a:ln w="12700">
             <a:solidFill>
-              <a:srgbClr val="1B5FAE"/>
+              <a:srgbClr val="BFDBFE"/>
             </a:solidFill>
             <a:prstDash val="solid"/>
           </a:ln>
@@ -11382,20 +11384,18 @@
           <a:ln/>
         </p:spPr>
         <p:txBody>
-          <a:bodyPr wrap="square" lIns="0" tIns="0" rIns="0" bIns="0" rtlCol="0" anchor="ctr"/>
+          <a:bodyPr wrap="square" lIns="36576" tIns="18288" rIns="36576" bIns="18288" rtlCol="0" anchor="ctr"/>
           <a:lstStyle/>
           <a:p>
             <a:pPr algn="ctr" indent="0" marL="0">
               <a:buNone/>
             </a:pPr>
             <a:r>
-              <a:rPr lang="en-US" sz="1300" b="1" dirty="0">
-                <a:solidFill>
-                  <a:srgbClr val="FFFFFF"/>
-                </a:solidFill>
-                <a:latin typeface="Calibri" pitchFamily="34" charset="0"/>
-                <a:ea typeface="Calibri" pitchFamily="34" charset="-122"/>
-                <a:cs typeface="Calibri" pitchFamily="34" charset="-120"/>
+              <a:rPr sz="1200" b="1">
+                <a:solidFill>
+                  <a:srgbClr val="0F172A"/>
+                </a:solidFill>
+                <a:latin typeface="Calibri"/>
               </a:rPr>
               <a:t>4</a:t>
             </a:r>
@@ -11428,9 +11428,9 @@
               <a:buNone/>
             </a:pPr>
             <a:r>
-              <a:rPr sz="750" b="1">
-                <a:solidFill>
-                  <a:srgbClr val="1E293B"/>
+              <a:rPr sz="1000" b="1">
+                <a:solidFill>
+                  <a:srgbClr val="0F172A"/>
                 </a:solidFill>
                 <a:latin typeface="Calibri"/>
               </a:rPr>
@@ -11465,7 +11465,7 @@
               <a:buNone/>
             </a:pPr>
             <a:r>
-              <a:rPr sz="700" b="0">
+              <a:rPr sz="1000" b="0">
                 <a:solidFill>
                   <a:srgbClr val="475569"/>
                 </a:solidFill>
@@ -11515,11 +11515,11 @@
             <a:avLst/>
           </a:prstGeom>
           <a:solidFill>
-            <a:srgbClr val="0F172A"/>
+            <a:srgbClr val="EFF6FF"/>
           </a:solidFill>
           <a:ln w="12700">
             <a:solidFill>
-              <a:srgbClr val="E8792A"/>
+              <a:srgbClr val="BFDBFE"/>
             </a:solidFill>
             <a:prstDash val="solid"/>
           </a:ln>
@@ -11543,20 +11543,18 @@
           <a:ln/>
         </p:spPr>
         <p:txBody>
-          <a:bodyPr wrap="square" lIns="0" tIns="0" rIns="0" bIns="0" rtlCol="0" anchor="ctr"/>
+          <a:bodyPr wrap="square" lIns="36576" tIns="18288" rIns="36576" bIns="18288" rtlCol="0" anchor="ctr"/>
           <a:lstStyle/>
           <a:p>
             <a:pPr algn="ctr" indent="0" marL="0">
               <a:buNone/>
             </a:pPr>
             <a:r>
-              <a:rPr lang="en-US" sz="1300" b="1" dirty="0">
-                <a:solidFill>
-                  <a:srgbClr val="FFFFFF"/>
-                </a:solidFill>
-                <a:latin typeface="Calibri" pitchFamily="34" charset="0"/>
-                <a:ea typeface="Calibri" pitchFamily="34" charset="-122"/>
-                <a:cs typeface="Calibri" pitchFamily="34" charset="-120"/>
+              <a:rPr sz="1200" b="1">
+                <a:solidFill>
+                  <a:srgbClr val="0F172A"/>
+                </a:solidFill>
+                <a:latin typeface="Calibri"/>
               </a:rPr>
               <a:t>5</a:t>
             </a:r>
@@ -11589,9 +11587,9 @@
               <a:buNone/>
             </a:pPr>
             <a:r>
-              <a:rPr sz="750" b="1">
-                <a:solidFill>
-                  <a:srgbClr val="1E293B"/>
+              <a:rPr sz="1000" b="1">
+                <a:solidFill>
+                  <a:srgbClr val="0F172A"/>
                 </a:solidFill>
                 <a:latin typeface="Calibri"/>
               </a:rPr>
@@ -11626,7 +11624,7 @@
               <a:buNone/>
             </a:pPr>
             <a:r>
-              <a:rPr sz="700" b="0">
+              <a:rPr sz="1000" b="0">
                 <a:solidFill>
                   <a:srgbClr val="475569"/>
                 </a:solidFill>
@@ -11676,11 +11674,11 @@
             <a:avLst/>
           </a:prstGeom>
           <a:solidFill>
-            <a:srgbClr val="0F172A"/>
+            <a:srgbClr val="EFF6FF"/>
           </a:solidFill>
           <a:ln w="12700">
             <a:solidFill>
-              <a:srgbClr val="0E2A4A"/>
+              <a:srgbClr val="BFDBFE"/>
             </a:solidFill>
             <a:prstDash val="solid"/>
           </a:ln>
@@ -11704,20 +11702,18 @@
           <a:ln/>
         </p:spPr>
         <p:txBody>
-          <a:bodyPr wrap="square" lIns="0" tIns="0" rIns="0" bIns="0" rtlCol="0" anchor="ctr"/>
+          <a:bodyPr wrap="square" lIns="36576" tIns="18288" rIns="36576" bIns="18288" rtlCol="0" anchor="ctr"/>
           <a:lstStyle/>
           <a:p>
             <a:pPr algn="ctr" indent="0" marL="0">
               <a:buNone/>
             </a:pPr>
             <a:r>
-              <a:rPr lang="en-US" sz="1300" b="1" dirty="0">
-                <a:solidFill>
-                  <a:srgbClr val="FFFFFF"/>
-                </a:solidFill>
-                <a:latin typeface="Calibri" pitchFamily="34" charset="0"/>
-                <a:ea typeface="Calibri" pitchFamily="34" charset="-122"/>
-                <a:cs typeface="Calibri" pitchFamily="34" charset="-120"/>
+              <a:rPr sz="1200" b="1">
+                <a:solidFill>
+                  <a:srgbClr val="0F172A"/>
+                </a:solidFill>
+                <a:latin typeface="Calibri"/>
               </a:rPr>
               <a:t>6</a:t>
             </a:r>
@@ -11750,9 +11746,9 @@
               <a:buNone/>
             </a:pPr>
             <a:r>
-              <a:rPr sz="750" b="1">
-                <a:solidFill>
-                  <a:srgbClr val="1E293B"/>
+              <a:rPr sz="1000" b="1">
+                <a:solidFill>
+                  <a:srgbClr val="0F172A"/>
                 </a:solidFill>
                 <a:latin typeface="Calibri"/>
               </a:rPr>
@@ -11787,7 +11783,7 @@
               <a:buNone/>
             </a:pPr>
             <a:r>
-              <a:rPr sz="700" b="0">
+              <a:rPr sz="1000" b="0">
                 <a:solidFill>
                   <a:srgbClr val="475569"/>
                 </a:solidFill>
@@ -11837,11 +11833,11 @@
             <a:avLst/>
           </a:prstGeom>
           <a:solidFill>
-            <a:srgbClr val="0F172A"/>
+            <a:srgbClr val="EFF6FF"/>
           </a:solidFill>
           <a:ln w="12700">
             <a:solidFill>
-              <a:srgbClr val="139488"/>
+              <a:srgbClr val="BFDBFE"/>
             </a:solidFill>
             <a:prstDash val="solid"/>
           </a:ln>
@@ -11865,20 +11861,18 @@
           <a:ln/>
         </p:spPr>
         <p:txBody>
-          <a:bodyPr wrap="square" lIns="0" tIns="0" rIns="0" bIns="0" rtlCol="0" anchor="ctr"/>
+          <a:bodyPr wrap="square" lIns="36576" tIns="18288" rIns="36576" bIns="18288" rtlCol="0" anchor="ctr"/>
           <a:lstStyle/>
           <a:p>
             <a:pPr algn="ctr" indent="0" marL="0">
               <a:buNone/>
             </a:pPr>
             <a:r>
-              <a:rPr lang="en-US" sz="1300" b="1" dirty="0">
-                <a:solidFill>
-                  <a:srgbClr val="FFFFFF"/>
-                </a:solidFill>
-                <a:latin typeface="Calibri" pitchFamily="34" charset="0"/>
-                <a:ea typeface="Calibri" pitchFamily="34" charset="-122"/>
-                <a:cs typeface="Calibri" pitchFamily="34" charset="-120"/>
+              <a:rPr sz="1200" b="1">
+                <a:solidFill>
+                  <a:srgbClr val="0F172A"/>
+                </a:solidFill>
+                <a:latin typeface="Calibri"/>
               </a:rPr>
               <a:t>7</a:t>
             </a:r>
@@ -11911,9 +11905,9 @@
               <a:buNone/>
             </a:pPr>
             <a:r>
-              <a:rPr sz="750" b="1">
-                <a:solidFill>
-                  <a:srgbClr val="1E293B"/>
+              <a:rPr sz="1000" b="1">
+                <a:solidFill>
+                  <a:srgbClr val="0F172A"/>
                 </a:solidFill>
                 <a:latin typeface="Calibri"/>
               </a:rPr>
@@ -11948,7 +11942,7 @@
               <a:buNone/>
             </a:pPr>
             <a:r>
-              <a:rPr sz="700" b="0">
+              <a:rPr sz="1000" b="0">
                 <a:solidFill>
                   <a:srgbClr val="475569"/>
                 </a:solidFill>
@@ -11998,11 +11992,11 @@
             <a:avLst/>
           </a:prstGeom>
           <a:solidFill>
-            <a:srgbClr val="0F172A"/>
+            <a:srgbClr val="EFF6FF"/>
           </a:solidFill>
           <a:ln w="12700">
             <a:solidFill>
-              <a:srgbClr val="1B5FAE"/>
+              <a:srgbClr val="BFDBFE"/>
             </a:solidFill>
             <a:prstDash val="solid"/>
           </a:ln>
@@ -12026,20 +12020,18 @@
           <a:ln/>
         </p:spPr>
         <p:txBody>
-          <a:bodyPr wrap="square" lIns="0" tIns="0" rIns="0" bIns="0" rtlCol="0" anchor="ctr"/>
+          <a:bodyPr wrap="square" lIns="36576" tIns="18288" rIns="36576" bIns="18288" rtlCol="0" anchor="ctr"/>
           <a:lstStyle/>
           <a:p>
             <a:pPr algn="ctr" indent="0" marL="0">
               <a:buNone/>
             </a:pPr>
             <a:r>
-              <a:rPr lang="en-US" sz="1300" b="1" dirty="0">
-                <a:solidFill>
-                  <a:srgbClr val="FFFFFF"/>
-                </a:solidFill>
-                <a:latin typeface="Calibri" pitchFamily="34" charset="0"/>
-                <a:ea typeface="Calibri" pitchFamily="34" charset="-122"/>
-                <a:cs typeface="Calibri" pitchFamily="34" charset="-120"/>
+              <a:rPr sz="1200" b="1">
+                <a:solidFill>
+                  <a:srgbClr val="0F172A"/>
+                </a:solidFill>
+                <a:latin typeface="Calibri"/>
               </a:rPr>
               <a:t>8</a:t>
             </a:r>
@@ -12072,9 +12064,9 @@
               <a:buNone/>
             </a:pPr>
             <a:r>
-              <a:rPr sz="750" b="1">
-                <a:solidFill>
-                  <a:srgbClr val="1E293B"/>
+              <a:rPr sz="1000" b="1">
+                <a:solidFill>
+                  <a:srgbClr val="0F172A"/>
                 </a:solidFill>
                 <a:latin typeface="Calibri"/>
               </a:rPr>
@@ -12109,7 +12101,7 @@
               <a:buNone/>
             </a:pPr>
             <a:r>
-              <a:rPr sz="700" b="0">
+              <a:rPr sz="1000" b="0">
                 <a:solidFill>
                   <a:srgbClr val="475569"/>
                 </a:solidFill>
@@ -12161,11 +12153,11 @@
             </a:avLst>
           </a:prstGeom>
           <a:solidFill>
-            <a:srgbClr val="0F172A"/>
-          </a:solidFill>
-          <a:ln w="12700">
-            <a:solidFill>
-              <a:srgbClr val="0E2A4A"/>
+            <a:srgbClr val="EFF6FF"/>
+          </a:solidFill>
+          <a:ln w="19050">
+            <a:solidFill>
+              <a:srgbClr val="1E3A8A"/>
             </a:solidFill>
             <a:prstDash val="solid"/>
           </a:ln>
@@ -12199,9 +12191,9 @@
               <a:buNone/>
             </a:pPr>
             <a:r>
-              <a:rPr sz="750" b="0">
-                <a:solidFill>
-                  <a:srgbClr val="FFFFFF"/>
+              <a:rPr sz="1000" b="0">
+                <a:solidFill>
+                  <a:srgbClr val="0F172A"/>
                 </a:solidFill>
                 <a:latin typeface="Calibri"/>
               </a:rPr>

</xml_diff>

<commit_message>
fix(ppt): resolve text collisions on slide 2, align card borders, fix slide 3 overflow, and redesign feasibility page with professional flowchart and explanation cards
</commit_message>
<xml_diff>
--- a/SIH26163_ARGUS_Idea_PPT_Color.pptx
+++ b/SIH26163_ARGUS_Idea_PPT_Color.pptx
@@ -851,34 +851,44 @@
           <a:lstStyle/>
           <a:p>
             <a:r>
-              <a:t>[2:45 - 3:30 | 45s Pitch - Slide 4: Feasibility, Risk Management &amp; Roadmap]</a:t>
-            </a:r>
-          </a:p>
-          <a:p>
-            <a:r>
-              <a:t>On Slide 4, we evaluate Feasibility and Risk Management. ARGUS achieves high operational viability because it runs entirely on open-source, scriptable components against local, self-hosted source code.</a:t>
+              <a:t>[2:45 - 3:30 | 45s Pitch - Slide 4: Feasibility Flowchart &amp; Viability Analysis]</a:t>
+            </a:r>
+          </a:p>
+          <a:p>
+            <a:r>
+              <a:t>On Slide 4, we demonstrate our Feasibility and Operational Viability through an engineered execution flowchart on the left and a detailed capability assessment on the right.</a:t>
             </a:r>
           </a:p>
           <a:p/>
           <a:p>
             <a:r>
-              <a:t>Our risk register directly tackles the most challenging failure modes in automated AppSec:</a:t>
-            </a:r>
-          </a:p>
-          <a:p>
-            <a:r>
-              <a:t>1. To prevent scanner alert fatigue, our correlation engine requires two agreeing signals before promoting any anomaly to PoC stage.</a:t>
-            </a:r>
-          </a:p>
-          <a:p>
-            <a:r>
-              <a:t>2. To evaluate the fail-open rate limiting and indirect prompt injection vulnerabilities safely without incurring cloud costs or service disruption, we deployed local mock testbeds.</a:t>
+              <a:t>As traced in our 5-step flowchart, ARGUS achieves 100% feasibility because all 166 endpoints and 5 trust boundaries run locally within an isolated AGPL-3.0 sandbox—zero external cloud subscriptions or network dependencies are required.</a:t>
             </a:r>
           </a:p>
           <a:p/>
           <a:p>
             <a:r>
-              <a:t>Our 5-phase roadmap took us from AST-based endpoint enumeration through multi-engine scanning, correlation, safe PoC verification, and executive reporting. The entire audit is 100% automated and reproducible with a single CLI command.</a:t>
+              <a:t>On the right, we address the core viability pillars:</a:t>
+            </a:r>
+          </a:p>
+          <a:p>
+            <a:r>
+              <a:t>1. Technical Feasibility: White-box AST extraction directly uncovers edge route signatures.</a:t>
+            </a:r>
+          </a:p>
+          <a:p>
+            <a:r>
+              <a:t>2. Economic Viability: Built with 100% open-source software (Semgrep, Python, Playwright), achieving complete automation at zero license cost.</a:t>
+            </a:r>
+          </a:p>
+          <a:p>
+            <a:r>
+              <a:t>3. Risk Mitigation: Our Two-Signal confirmation gate discards scanner noise before PoC development, and non-destructive mock testbeds protect upstream APIs.</a:t>
+            </a:r>
+          </a:p>
+          <a:p>
+            <a:r>
+              <a:t>4. Strategic Scalability: Built for NTRO to audit sovereign OSINT and government web assets simply by updating target YAML profiles.</a:t>
             </a:r>
           </a:p>
         </p:txBody>
@@ -3135,7 +3145,7 @@
           </a:solidFill>
           <a:ln w="12700">
             <a:solidFill>
-              <a:srgbClr val="E2E8F0"/>
+              <a:srgbClr val="BFDBFE"/>
             </a:solidFill>
             <a:prstDash val="solid"/>
           </a:ln>
@@ -3184,7 +3194,7 @@
           </a:solidFill>
           <a:ln w="12700">
             <a:solidFill>
-              <a:srgbClr val="E2E8F0"/>
+              <a:srgbClr val="BFDBFE"/>
             </a:solidFill>
           </a:ln>
         </p:spPr>
@@ -3264,7 +3274,7 @@
           </a:solidFill>
           <a:ln w="12700">
             <a:solidFill>
-              <a:srgbClr val="E2E8F0"/>
+              <a:srgbClr val="BFDBFE"/>
             </a:solidFill>
           </a:ln>
         </p:spPr>
@@ -3334,7 +3344,7 @@
           </a:solidFill>
           <a:ln w="12700">
             <a:solidFill>
-              <a:srgbClr val="E2E8F0"/>
+              <a:srgbClr val="BFDBFE"/>
             </a:solidFill>
           </a:ln>
         </p:spPr>
@@ -3564,8 +3574,8 @@
         </p:nvSpPr>
         <p:spPr>
           <a:xfrm>
-            <a:off x="457200" y="5349240"/>
-            <a:ext cx="9144000" cy="292608"/>
+            <a:off x="457200" y="4645152"/>
+            <a:ext cx="11274552" cy="274320"/>
           </a:xfrm>
           <a:prstGeom prst="rect">
             <a:avLst/>
@@ -3593,520 +3603,504 @@
           </a:p>
         </p:txBody>
       </p:sp>
-      <p:sp>
-        <p:nvSpPr>
-          <p:cNvPr id="48" name="Text 41"/>
-          <p:cNvSpPr txBox="1"/>
-          <p:nvPr/>
-        </p:nvSpPr>
-        <p:spPr>
-          <a:xfrm>
-            <a:off x="457200" y="5669280"/>
-            <a:ext cx="2148840" cy="169164"/>
-          </a:xfrm>
-          <a:prstGeom prst="rect">
-            <a:avLst/>
-          </a:prstGeom>
-          <a:solidFill>
-            <a:srgbClr val="EFF6FF"/>
-          </a:solidFill>
-          <a:ln w="12700">
-            <a:solidFill>
-              <a:srgbClr val="BFDBFE"/>
-            </a:solidFill>
-          </a:ln>
-        </p:spPr>
-        <p:txBody>
-          <a:bodyPr wrap="square" lIns="36576" tIns="18288" rIns="36576" bIns="18288" rtlCol="0" anchor="ctr"/>
-          <a:lstStyle/>
-          <a:p>
-            <a:pPr indent="0" marL="0">
-              <a:buNone/>
-            </a:pPr>
-            <a:r>
-              <a:rPr sz="1000" b="1">
-                <a:solidFill>
-                  <a:srgbClr val="0F172A"/>
-                </a:solidFill>
-                <a:latin typeface="Calibri"/>
-              </a:rPr>
-              <a:t>Unmetered Resource DoS via Fail-Open Rate Limiter in api/_rate-limit.js (Redis timeout -&gt; 'degraded')</a:t>
-            </a:r>
-            <a:endParaRPr lang="en-US" sz="900" dirty="0"/>
-          </a:p>
-        </p:txBody>
-      </p:sp>
-      <p:sp>
-        <p:nvSpPr>
-          <p:cNvPr id="49" name="Shape 42"/>
-          <p:cNvSpPr/>
-          <p:nvPr/>
-        </p:nvSpPr>
-        <p:spPr>
-          <a:xfrm>
-            <a:off x="2651760" y="5719572"/>
-            <a:ext cx="5212080" cy="59436"/>
-          </a:xfrm>
-          <a:prstGeom prst="rect">
-            <a:avLst/>
-          </a:prstGeom>
-          <a:solidFill>
-            <a:srgbClr val="F8FAFC"/>
-          </a:solidFill>
-          <a:ln w="12700">
-            <a:solidFill>
-              <a:srgbClr val="E7EAEE"/>
-            </a:solidFill>
-            <a:prstDash val="solid"/>
-          </a:ln>
-        </p:spPr>
-      </p:sp>
-      <p:sp>
-        <p:nvSpPr>
-          <p:cNvPr id="50" name="Shape 43"/>
-          <p:cNvSpPr/>
-          <p:nvPr/>
-        </p:nvSpPr>
-        <p:spPr>
-          <a:xfrm>
-            <a:off x="2651760" y="5719572"/>
-            <a:ext cx="4690872" cy="59436"/>
-          </a:xfrm>
-          <a:prstGeom prst="rect">
-            <a:avLst/>
-          </a:prstGeom>
-          <a:solidFill>
-            <a:srgbClr val="B91C1C"/>
-          </a:solidFill>
-          <a:ln w="12700">
-            <a:solidFill>
-              <a:srgbClr val="D64545"/>
-            </a:solidFill>
-            <a:prstDash val="solid"/>
-          </a:ln>
-        </p:spPr>
-      </p:sp>
-      <p:sp>
-        <p:nvSpPr>
-          <p:cNvPr id="51" name="Text 44"/>
-          <p:cNvSpPr txBox="1"/>
-          <p:nvPr/>
-        </p:nvSpPr>
-        <p:spPr>
-          <a:xfrm>
-            <a:off x="7909560" y="5669280"/>
-            <a:ext cx="822960" cy="169164"/>
-          </a:xfrm>
-          <a:prstGeom prst="rect">
-            <a:avLst/>
-          </a:prstGeom>
-          <a:noFill/>
-          <a:ln/>
-        </p:spPr>
-        <p:txBody>
-          <a:bodyPr wrap="square" lIns="36576" tIns="18288" rIns="36576" bIns="18288" rtlCol="0" anchor="ctr"/>
-          <a:lstStyle/>
-          <a:p>
-            <a:pPr indent="0" marL="0">
-              <a:buNone/>
-            </a:pPr>
-            <a:r>
-              <a:rPr sz="1000" b="1">
-                <a:solidFill>
-                  <a:srgbClr val="EA580C"/>
-                </a:solidFill>
-                <a:latin typeface="Calibri"/>
-              </a:rPr>
-              <a:t>CVSS 7.5 (High) · Confirmed PoC</a:t>
-            </a:r>
-            <a:endParaRPr lang="en-US" sz="850" dirty="0"/>
-          </a:p>
-        </p:txBody>
-      </p:sp>
-      <p:sp>
-        <p:nvSpPr>
-          <p:cNvPr id="52" name="Text 45"/>
-          <p:cNvSpPr txBox="1"/>
-          <p:nvPr/>
-        </p:nvSpPr>
-        <p:spPr>
-          <a:xfrm>
-            <a:off x="457200" y="5856732"/>
-            <a:ext cx="2148840" cy="169164"/>
-          </a:xfrm>
-          <a:prstGeom prst="rect">
-            <a:avLst/>
-          </a:prstGeom>
-          <a:solidFill>
-            <a:srgbClr val="EFF6FF"/>
-          </a:solidFill>
-          <a:ln w="12700">
-            <a:solidFill>
-              <a:srgbClr val="BFDBFE"/>
-            </a:solidFill>
-          </a:ln>
-        </p:spPr>
-        <p:txBody>
-          <a:bodyPr wrap="square" lIns="36576" tIns="18288" rIns="36576" bIns="18288" rtlCol="0" anchor="ctr"/>
-          <a:lstStyle/>
-          <a:p>
-            <a:pPr indent="0" marL="0">
-              <a:buNone/>
-            </a:pPr>
-            <a:r>
-              <a:rPr sz="1000" b="1">
-                <a:solidFill>
-                  <a:srgbClr val="0F172A"/>
-                </a:solidFill>
-                <a:latin typeface="Calibri"/>
-              </a:rPr>
-              <a:t>DOM XSS via 357 Bypassed Trusted Types in src/utils/dom-utils.ts ('legacy migration' bypass)</a:t>
-            </a:r>
-            <a:endParaRPr lang="en-US" sz="900" dirty="0"/>
-          </a:p>
-        </p:txBody>
-      </p:sp>
-      <p:sp>
-        <p:nvSpPr>
-          <p:cNvPr id="53" name="Shape 46"/>
-          <p:cNvSpPr/>
-          <p:nvPr/>
-        </p:nvSpPr>
-        <p:spPr>
-          <a:xfrm>
-            <a:off x="2651760" y="5907024"/>
-            <a:ext cx="5212080" cy="59436"/>
-          </a:xfrm>
-          <a:prstGeom prst="rect">
-            <a:avLst/>
-          </a:prstGeom>
-          <a:solidFill>
-            <a:srgbClr val="F8FAFC"/>
-          </a:solidFill>
-          <a:ln w="12700">
-            <a:solidFill>
-              <a:srgbClr val="E7EAEE"/>
-            </a:solidFill>
-            <a:prstDash val="solid"/>
-          </a:ln>
-        </p:spPr>
-      </p:sp>
-      <p:sp>
-        <p:nvSpPr>
-          <p:cNvPr id="54" name="Shape 47"/>
-          <p:cNvSpPr/>
-          <p:nvPr/>
-        </p:nvSpPr>
-        <p:spPr>
-          <a:xfrm>
-            <a:off x="2651760" y="5907024"/>
-            <a:ext cx="4065422" cy="59436"/>
-          </a:xfrm>
-          <a:prstGeom prst="rect">
-            <a:avLst/>
-          </a:prstGeom>
-          <a:solidFill>
-            <a:srgbClr val="1E3A8A"/>
-          </a:solidFill>
-          <a:ln w="12700">
-            <a:solidFill>
-              <a:srgbClr val="E8792A"/>
-            </a:solidFill>
-            <a:prstDash val="solid"/>
-          </a:ln>
-        </p:spPr>
-      </p:sp>
-      <p:sp>
-        <p:nvSpPr>
-          <p:cNvPr id="55" name="Text 48"/>
-          <p:cNvSpPr txBox="1"/>
-          <p:nvPr/>
-        </p:nvSpPr>
-        <p:spPr>
-          <a:xfrm>
-            <a:off x="7909560" y="5856732"/>
-            <a:ext cx="822960" cy="169164"/>
-          </a:xfrm>
-          <a:prstGeom prst="rect">
-            <a:avLst/>
-          </a:prstGeom>
-          <a:noFill/>
-          <a:ln/>
-        </p:spPr>
-        <p:txBody>
-          <a:bodyPr wrap="square" lIns="36576" tIns="18288" rIns="36576" bIns="18288" rtlCol="0" anchor="ctr"/>
-          <a:lstStyle/>
-          <a:p>
-            <a:pPr indent="0" marL="0">
-              <a:buNone/>
-            </a:pPr>
-            <a:r>
-              <a:rPr sz="1000" b="1">
-                <a:solidFill>
-                  <a:srgbClr val="1E3A8A"/>
-                </a:solidFill>
-                <a:latin typeface="Calibri"/>
-              </a:rPr>
-              <a:t>CVSS 6.1 (Med) · Confirmed PoC</a:t>
-            </a:r>
-            <a:endParaRPr lang="en-US" sz="850" dirty="0"/>
-          </a:p>
-        </p:txBody>
-      </p:sp>
-      <p:sp>
-        <p:nvSpPr>
-          <p:cNvPr id="56" name="Text 49"/>
-          <p:cNvSpPr txBox="1"/>
-          <p:nvPr/>
-        </p:nvSpPr>
-        <p:spPr>
-          <a:xfrm>
-            <a:off x="457200" y="6044184"/>
-            <a:ext cx="2148840" cy="169164"/>
-          </a:xfrm>
-          <a:prstGeom prst="rect">
-            <a:avLst/>
-          </a:prstGeom>
-          <a:solidFill>
-            <a:srgbClr val="EFF6FF"/>
-          </a:solidFill>
-          <a:ln w="12700">
-            <a:solidFill>
-              <a:srgbClr val="BFDBFE"/>
-            </a:solidFill>
-          </a:ln>
-        </p:spPr>
-        <p:txBody>
-          <a:bodyPr wrap="square" lIns="36576" tIns="18288" rIns="36576" bIns="18288" rtlCol="0" anchor="ctr"/>
-          <a:lstStyle/>
-          <a:p>
-            <a:pPr indent="0" marL="0">
-              <a:buNone/>
-            </a:pPr>
-            <a:r>
-              <a:rPr sz="1000" b="1">
-                <a:solidFill>
-                  <a:srgbClr val="0F172A"/>
-                </a:solidFill>
-                <a:latin typeface="Calibri"/>
-              </a:rPr>
-              <a:t>Indirect Prompt Injection Blocklist Bypass in server/_shared/llm-sanitize.js (RSS feed evasion)</a:t>
-            </a:r>
-            <a:endParaRPr lang="en-US" sz="900" dirty="0"/>
-          </a:p>
-        </p:txBody>
-      </p:sp>
-      <p:sp>
-        <p:nvSpPr>
-          <p:cNvPr id="57" name="Shape 50"/>
-          <p:cNvSpPr/>
-          <p:nvPr/>
-        </p:nvSpPr>
-        <p:spPr>
-          <a:xfrm>
-            <a:off x="2651760" y="6094476"/>
-            <a:ext cx="5212080" cy="59436"/>
-          </a:xfrm>
-          <a:prstGeom prst="rect">
-            <a:avLst/>
-          </a:prstGeom>
-          <a:solidFill>
-            <a:srgbClr val="F8FAFC"/>
-          </a:solidFill>
-          <a:ln w="12700">
-            <a:solidFill>
-              <a:srgbClr val="E7EAEE"/>
-            </a:solidFill>
-            <a:prstDash val="solid"/>
-          </a:ln>
-        </p:spPr>
-      </p:sp>
-      <p:sp>
-        <p:nvSpPr>
-          <p:cNvPr id="58" name="Shape 51"/>
-          <p:cNvSpPr/>
-          <p:nvPr/>
-        </p:nvSpPr>
-        <p:spPr>
-          <a:xfrm>
-            <a:off x="2651760" y="6094476"/>
-            <a:ext cx="2866644" cy="59436"/>
-          </a:xfrm>
-          <a:prstGeom prst="rect">
-            <a:avLst/>
-          </a:prstGeom>
-          <a:solidFill>
-            <a:srgbClr val="1E3A8A"/>
-          </a:solidFill>
-          <a:ln w="12700">
-            <a:solidFill>
-              <a:srgbClr val="E8B923"/>
-            </a:solidFill>
-            <a:prstDash val="solid"/>
-          </a:ln>
-        </p:spPr>
-      </p:sp>
-      <p:sp>
-        <p:nvSpPr>
-          <p:cNvPr id="59" name="Text 52"/>
-          <p:cNvSpPr txBox="1"/>
-          <p:nvPr/>
-        </p:nvSpPr>
-        <p:spPr>
-          <a:xfrm>
-            <a:off x="7909560" y="6044184"/>
-            <a:ext cx="822960" cy="169164"/>
-          </a:xfrm>
-          <a:prstGeom prst="rect">
-            <a:avLst/>
-          </a:prstGeom>
-          <a:noFill/>
-          <a:ln/>
-        </p:spPr>
-        <p:txBody>
-          <a:bodyPr wrap="square" lIns="36576" tIns="18288" rIns="36576" bIns="18288" rtlCol="0" anchor="ctr"/>
-          <a:lstStyle/>
-          <a:p>
-            <a:pPr indent="0" marL="0">
-              <a:buNone/>
-            </a:pPr>
-            <a:r>
-              <a:rPr sz="1000" b="1">
-                <a:solidFill>
-                  <a:srgbClr val="1E3A8A"/>
-                </a:solidFill>
-                <a:latin typeface="Calibri"/>
-              </a:rPr>
-              <a:t>CVSS 6.5 (Med) · Confirmed PoC</a:t>
-            </a:r>
-            <a:endParaRPr lang="en-US" sz="850" dirty="0"/>
-          </a:p>
-        </p:txBody>
-      </p:sp>
-      <p:sp>
-        <p:nvSpPr>
-          <p:cNvPr id="60" name="Text 53"/>
-          <p:cNvSpPr txBox="1"/>
-          <p:nvPr/>
-        </p:nvSpPr>
-        <p:spPr>
-          <a:xfrm>
-            <a:off x="457200" y="6231636"/>
-            <a:ext cx="2148840" cy="169164"/>
-          </a:xfrm>
-          <a:prstGeom prst="rect">
-            <a:avLst/>
-          </a:prstGeom>
-          <a:noFill/>
-          <a:ln/>
-        </p:spPr>
-        <p:txBody>
-          <a:bodyPr wrap="square" lIns="36576" tIns="18288" rIns="36576" bIns="18288" rtlCol="0" anchor="ctr"/>
-          <a:lstStyle/>
-          <a:p>
-            <a:pPr indent="0" marL="0">
-              <a:buNone/>
-            </a:pPr>
-            <a:r>
-              <a:rPr sz="1000" b="1">
-                <a:solidFill>
-                  <a:srgbClr val="0F172A"/>
-                </a:solidFill>
-                <a:latin typeface="Calibri"/>
-              </a:rPr>
-              <a:t>SSRF TOCTOU / DNS Rebinding Window in api/mcp-proxy.ts (Cloud metadata 169.254.169.254)</a:t>
-            </a:r>
-            <a:endParaRPr lang="en-US" sz="900" dirty="0"/>
-          </a:p>
-        </p:txBody>
-      </p:sp>
-      <p:sp>
-        <p:nvSpPr>
-          <p:cNvPr id="61" name="Shape 54"/>
-          <p:cNvSpPr/>
-          <p:nvPr/>
-        </p:nvSpPr>
-        <p:spPr>
-          <a:xfrm>
-            <a:off x="2651760" y="6281928"/>
-            <a:ext cx="5212080" cy="59436"/>
-          </a:xfrm>
-          <a:prstGeom prst="rect">
-            <a:avLst/>
-          </a:prstGeom>
-          <a:solidFill>
-            <a:srgbClr val="E7EAEE"/>
-          </a:solidFill>
-          <a:ln w="12700">
-            <a:solidFill>
-              <a:srgbClr val="E7EAEE"/>
-            </a:solidFill>
-            <a:prstDash val="solid"/>
-          </a:ln>
-        </p:spPr>
-      </p:sp>
-      <p:sp>
-        <p:nvSpPr>
-          <p:cNvPr id="62" name="Shape 55"/>
-          <p:cNvSpPr/>
-          <p:nvPr/>
-        </p:nvSpPr>
-        <p:spPr>
-          <a:xfrm>
-            <a:off x="2651760" y="6281928"/>
-            <a:ext cx="1824228" cy="59436"/>
-          </a:xfrm>
-          <a:prstGeom prst="rect">
-            <a:avLst/>
-          </a:prstGeom>
-          <a:solidFill>
-            <a:srgbClr val="334155"/>
-          </a:solidFill>
-          <a:ln w="12700">
-            <a:solidFill>
-              <a:srgbClr val="2E8B57"/>
-            </a:solidFill>
-            <a:prstDash val="solid"/>
-          </a:ln>
-        </p:spPr>
-      </p:sp>
-      <p:sp>
-        <p:nvSpPr>
-          <p:cNvPr id="63" name="Text 56"/>
-          <p:cNvSpPr txBox="1"/>
-          <p:nvPr/>
-        </p:nvSpPr>
-        <p:spPr>
-          <a:xfrm>
-            <a:off x="7909560" y="6231636"/>
-            <a:ext cx="822960" cy="169164"/>
-          </a:xfrm>
-          <a:prstGeom prst="rect">
-            <a:avLst/>
-          </a:prstGeom>
-          <a:noFill/>
-          <a:ln/>
-        </p:spPr>
-        <p:txBody>
-          <a:bodyPr wrap="square" lIns="36576" tIns="18288" rIns="36576" bIns="18288" rtlCol="0" anchor="ctr"/>
-          <a:lstStyle/>
-          <a:p>
-            <a:pPr indent="0" marL="0">
-              <a:buNone/>
-            </a:pPr>
-            <a:r>
-              <a:rPr sz="1000" b="1">
-                <a:solidFill>
-                  <a:srgbClr val="1E3A8A"/>
-                </a:solidFill>
-                <a:latin typeface="Calibri"/>
-              </a:rPr>
-              <a:t>CVSS 6.3 (Med) · Confirmed PoC</a:t>
-            </a:r>
-            <a:endParaRPr lang="en-US" sz="850" dirty="0"/>
-          </a:p>
-        </p:txBody>
-      </p:sp>
+      <p:graphicFrame>
+        <p:nvGraphicFramePr>
+          <p:cNvPr id="48" name="Table 47"/>
+          <p:cNvGraphicFramePr>
+            <a:graphicFrameLocks noGrp="1"/>
+          </p:cNvGraphicFramePr>
+          <p:nvPr/>
+        </p:nvGraphicFramePr>
+        <p:xfrm>
+          <a:off x="457200" y="4956048"/>
+          <a:ext cx="11274552" cy="1188720"/>
+        </p:xfrm>
+        <a:graphic>
+          <a:graphicData uri="http://schemas.openxmlformats.org/drawingml/2006/table">
+            <a:tbl>
+              <a:tblPr firstRow="1" bandRow="1">
+                <a:tableStyleId>{5C22544A-7EE6-4342-B048-85BDC9FD1C3A}</a:tableStyleId>
+              </a:tblPr>
+              <a:tblGrid>
+                <a:gridCol w="365760"/>
+                <a:gridCol w="6245352"/>
+                <a:gridCol w="2286000"/>
+                <a:gridCol w="2377440"/>
+              </a:tblGrid>
+              <a:tr h="237744">
+                <a:tc>
+                  <a:txBody>
+                    <a:bodyPr/>
+                    <a:lstStyle/>
+                    <a:p>
+                      <a:pPr algn="ctr"/>
+                      <a:r>
+                        <a:rPr sz="950" b="1">
+                          <a:solidFill>
+                            <a:srgbClr val="FFFFFF"/>
+                          </a:solidFill>
+                          <a:latin typeface="Calibri"/>
+                        </a:rPr>
+                        <a:t>#</a:t>
+                      </a:r>
+                    </a:p>
+                  </a:txBody>
+                  <a:tcPr marL="54864" marR="54864" marT="27432" marB="27432">
+                    <a:solidFill>
+                      <a:srgbClr val="1E3A8A"/>
+                    </a:solidFill>
+                  </a:tcPr>
+                </a:tc>
+                <a:tc>
+                  <a:txBody>
+                    <a:bodyPr/>
+                    <a:lstStyle/>
+                    <a:p>
+                      <a:pPr algn="l"/>
+                      <a:r>
+                        <a:rPr sz="950" b="1">
+                          <a:solidFill>
+                            <a:srgbClr val="FFFFFF"/>
+                          </a:solidFill>
+                          <a:latin typeface="Calibri"/>
+                        </a:rPr>
+                        <a:t>Confirmed Vulnerability &amp; Affected Root Cause</a:t>
+                      </a:r>
+                    </a:p>
+                  </a:txBody>
+                  <a:tcPr marL="54864" marR="54864" marT="27432" marB="27432">
+                    <a:solidFill>
+                      <a:srgbClr val="1E3A8A"/>
+                    </a:solidFill>
+                  </a:tcPr>
+                </a:tc>
+                <a:tc>
+                  <a:txBody>
+                    <a:bodyPr/>
+                    <a:lstStyle/>
+                    <a:p>
+                      <a:pPr algn="ctr"/>
+                      <a:r>
+                        <a:rPr sz="950" b="1">
+                          <a:solidFill>
+                            <a:srgbClr val="FFFFFF"/>
+                          </a:solidFill>
+                          <a:latin typeface="Calibri"/>
+                        </a:rPr>
+                        <a:t>OWASP &amp; CWE Taxonomy</a:t>
+                      </a:r>
+                    </a:p>
+                  </a:txBody>
+                  <a:tcPr marL="54864" marR="54864" marT="27432" marB="27432">
+                    <a:solidFill>
+                      <a:srgbClr val="1E3A8A"/>
+                    </a:solidFill>
+                  </a:tcPr>
+                </a:tc>
+                <a:tc>
+                  <a:txBody>
+                    <a:bodyPr/>
+                    <a:lstStyle/>
+                    <a:p>
+                      <a:pPr algn="ctr"/>
+                      <a:r>
+                        <a:rPr sz="950" b="1">
+                          <a:solidFill>
+                            <a:srgbClr val="FFFFFF"/>
+                          </a:solidFill>
+                          <a:latin typeface="Calibri"/>
+                        </a:rPr>
+                        <a:t>CVSS 3.1 &amp; PoC Verification</a:t>
+                      </a:r>
+                    </a:p>
+                  </a:txBody>
+                  <a:tcPr marL="54864" marR="54864" marT="27432" marB="27432">
+                    <a:solidFill>
+                      <a:srgbClr val="1E3A8A"/>
+                    </a:solidFill>
+                  </a:tcPr>
+                </a:tc>
+              </a:tr>
+              <a:tr h="237744">
+                <a:tc>
+                  <a:txBody>
+                    <a:bodyPr/>
+                    <a:lstStyle/>
+                    <a:p>
+                      <a:pPr algn="ctr"/>
+                      <a:r>
+                        <a:rPr sz="950" b="1">
+                          <a:solidFill>
+                            <a:srgbClr val="1E3A8A"/>
+                          </a:solidFill>
+                          <a:latin typeface="Calibri"/>
+                        </a:rPr>
+                        <a:t>1</a:t>
+                      </a:r>
+                    </a:p>
+                  </a:txBody>
+                  <a:tcPr marL="54864" marR="54864" marT="27432" marB="27432">
+                    <a:solidFill>
+                      <a:srgbClr val="FFFFFF"/>
+                    </a:solidFill>
+                  </a:tcPr>
+                </a:tc>
+                <a:tc>
+                  <a:txBody>
+                    <a:bodyPr/>
+                    <a:lstStyle/>
+                    <a:p>
+                      <a:pPr algn="l"/>
+                      <a:r>
+                        <a:rPr sz="950" b="1">
+                          <a:solidFill>
+                            <a:srgbClr val="0F172A"/>
+                          </a:solidFill>
+                          <a:latin typeface="Calibri"/>
+                        </a:rPr>
+                        <a:t>Unmetered Resource DoS via Fail-Open Rate Limiter in api/_rate-limit.js (Redis timeout -&gt; 'degraded' mode)</a:t>
+                      </a:r>
+                    </a:p>
+                  </a:txBody>
+                  <a:tcPr marL="54864" marR="54864" marT="27432" marB="27432">
+                    <a:solidFill>
+                      <a:srgbClr val="FFFFFF"/>
+                    </a:solidFill>
+                  </a:tcPr>
+                </a:tc>
+                <a:tc>
+                  <a:txBody>
+                    <a:bodyPr/>
+                    <a:lstStyle/>
+                    <a:p>
+                      <a:pPr algn="ctr"/>
+                      <a:r>
+                        <a:rPr sz="900" b="0">
+                          <a:solidFill>
+                            <a:srgbClr val="475569"/>
+                          </a:solidFill>
+                          <a:latin typeface="Calibri"/>
+                        </a:rPr>
+                        <a:t>OWASP A04 · CWE-770 (Resource Exhaustion)</a:t>
+                      </a:r>
+                    </a:p>
+                  </a:txBody>
+                  <a:tcPr marL="54864" marR="54864" marT="27432" marB="27432">
+                    <a:solidFill>
+                      <a:srgbClr val="FFFFFF"/>
+                    </a:solidFill>
+                  </a:tcPr>
+                </a:tc>
+                <a:tc>
+                  <a:txBody>
+                    <a:bodyPr/>
+                    <a:lstStyle/>
+                    <a:p>
+                      <a:pPr algn="ctr"/>
+                      <a:r>
+                        <a:rPr sz="950" b="1">
+                          <a:solidFill>
+                            <a:srgbClr val="EA580C"/>
+                          </a:solidFill>
+                          <a:latin typeface="Calibri"/>
+                        </a:rPr>
+                        <a:t>7.5 (High) · Confirmed PoC</a:t>
+                      </a:r>
+                    </a:p>
+                  </a:txBody>
+                  <a:tcPr marL="54864" marR="54864" marT="27432" marB="27432">
+                    <a:solidFill>
+                      <a:srgbClr val="FFFFFF"/>
+                    </a:solidFill>
+                  </a:tcPr>
+                </a:tc>
+              </a:tr>
+              <a:tr h="237744">
+                <a:tc>
+                  <a:txBody>
+                    <a:bodyPr/>
+                    <a:lstStyle/>
+                    <a:p>
+                      <a:pPr algn="ctr"/>
+                      <a:r>
+                        <a:rPr sz="950" b="1">
+                          <a:solidFill>
+                            <a:srgbClr val="1E3A8A"/>
+                          </a:solidFill>
+                          <a:latin typeface="Calibri"/>
+                        </a:rPr>
+                        <a:t>2</a:t>
+                      </a:r>
+                    </a:p>
+                  </a:txBody>
+                  <a:tcPr marL="54864" marR="54864" marT="27432" marB="27432">
+                    <a:solidFill>
+                      <a:srgbClr val="EFF6FF"/>
+                    </a:solidFill>
+                  </a:tcPr>
+                </a:tc>
+                <a:tc>
+                  <a:txBody>
+                    <a:bodyPr/>
+                    <a:lstStyle/>
+                    <a:p>
+                      <a:pPr algn="l"/>
+                      <a:r>
+                        <a:rPr sz="950" b="1">
+                          <a:solidFill>
+                            <a:srgbClr val="0F172A"/>
+                          </a:solidFill>
+                          <a:latin typeface="Calibri"/>
+                        </a:rPr>
+                        <a:t>DOM XSS via 357 Bypassed Trusted Types in src/utils/dom-utils.ts ('legacy migration' string bypass)</a:t>
+                      </a:r>
+                    </a:p>
+                  </a:txBody>
+                  <a:tcPr marL="54864" marR="54864" marT="27432" marB="27432">
+                    <a:solidFill>
+                      <a:srgbClr val="EFF6FF"/>
+                    </a:solidFill>
+                  </a:tcPr>
+                </a:tc>
+                <a:tc>
+                  <a:txBody>
+                    <a:bodyPr/>
+                    <a:lstStyle/>
+                    <a:p>
+                      <a:pPr algn="ctr"/>
+                      <a:r>
+                        <a:rPr sz="900" b="0">
+                          <a:solidFill>
+                            <a:srgbClr val="475569"/>
+                          </a:solidFill>
+                          <a:latin typeface="Calibri"/>
+                        </a:rPr>
+                        <a:t>OWASP A03 · CWE-79 (Cross-Site Scripting)</a:t>
+                      </a:r>
+                    </a:p>
+                  </a:txBody>
+                  <a:tcPr marL="54864" marR="54864" marT="27432" marB="27432">
+                    <a:solidFill>
+                      <a:srgbClr val="EFF6FF"/>
+                    </a:solidFill>
+                  </a:tcPr>
+                </a:tc>
+                <a:tc>
+                  <a:txBody>
+                    <a:bodyPr/>
+                    <a:lstStyle/>
+                    <a:p>
+                      <a:pPr algn="ctr"/>
+                      <a:r>
+                        <a:rPr sz="950" b="1">
+                          <a:solidFill>
+                            <a:srgbClr val="1E3A8A"/>
+                          </a:solidFill>
+                          <a:latin typeface="Calibri"/>
+                        </a:rPr>
+                        <a:t>6.1 (Med) · Confirmed PoC</a:t>
+                      </a:r>
+                    </a:p>
+                  </a:txBody>
+                  <a:tcPr marL="54864" marR="54864" marT="27432" marB="27432">
+                    <a:solidFill>
+                      <a:srgbClr val="EFF6FF"/>
+                    </a:solidFill>
+                  </a:tcPr>
+                </a:tc>
+              </a:tr>
+              <a:tr h="237744">
+                <a:tc>
+                  <a:txBody>
+                    <a:bodyPr/>
+                    <a:lstStyle/>
+                    <a:p>
+                      <a:pPr algn="ctr"/>
+                      <a:r>
+                        <a:rPr sz="950" b="1">
+                          <a:solidFill>
+                            <a:srgbClr val="1E3A8A"/>
+                          </a:solidFill>
+                          <a:latin typeface="Calibri"/>
+                        </a:rPr>
+                        <a:t>3</a:t>
+                      </a:r>
+                    </a:p>
+                  </a:txBody>
+                  <a:tcPr marL="54864" marR="54864" marT="27432" marB="27432">
+                    <a:solidFill>
+                      <a:srgbClr val="FFFFFF"/>
+                    </a:solidFill>
+                  </a:tcPr>
+                </a:tc>
+                <a:tc>
+                  <a:txBody>
+                    <a:bodyPr/>
+                    <a:lstStyle/>
+                    <a:p>
+                      <a:pPr algn="l"/>
+                      <a:r>
+                        <a:rPr sz="950" b="1">
+                          <a:solidFill>
+                            <a:srgbClr val="0F172A"/>
+                          </a:solidFill>
+                          <a:latin typeface="Calibri"/>
+                        </a:rPr>
+                        <a:t>Indirect Prompt Injection Blocklist Bypass in server/_shared/llm-sanitize.js (RSS feed multilingual evasion)</a:t>
+                      </a:r>
+                    </a:p>
+                  </a:txBody>
+                  <a:tcPr marL="54864" marR="54864" marT="27432" marB="27432">
+                    <a:solidFill>
+                      <a:srgbClr val="FFFFFF"/>
+                    </a:solidFill>
+                  </a:tcPr>
+                </a:tc>
+                <a:tc>
+                  <a:txBody>
+                    <a:bodyPr/>
+                    <a:lstStyle/>
+                    <a:p>
+                      <a:pPr algn="ctr"/>
+                      <a:r>
+                        <a:rPr sz="900" b="0">
+                          <a:solidFill>
+                            <a:srgbClr val="475569"/>
+                          </a:solidFill>
+                          <a:latin typeface="Calibri"/>
+                        </a:rPr>
+                        <a:t>OWASP LLM01 · CWE-20 (Improper Input)</a:t>
+                      </a:r>
+                    </a:p>
+                  </a:txBody>
+                  <a:tcPr marL="54864" marR="54864" marT="27432" marB="27432">
+                    <a:solidFill>
+                      <a:srgbClr val="FFFFFF"/>
+                    </a:solidFill>
+                  </a:tcPr>
+                </a:tc>
+                <a:tc>
+                  <a:txBody>
+                    <a:bodyPr/>
+                    <a:lstStyle/>
+                    <a:p>
+                      <a:pPr algn="ctr"/>
+                      <a:r>
+                        <a:rPr sz="950" b="1">
+                          <a:solidFill>
+                            <a:srgbClr val="1E3A8A"/>
+                          </a:solidFill>
+                          <a:latin typeface="Calibri"/>
+                        </a:rPr>
+                        <a:t>6.5 (Med) · Confirmed PoC</a:t>
+                      </a:r>
+                    </a:p>
+                  </a:txBody>
+                  <a:tcPr marL="54864" marR="54864" marT="27432" marB="27432">
+                    <a:solidFill>
+                      <a:srgbClr val="FFFFFF"/>
+                    </a:solidFill>
+                  </a:tcPr>
+                </a:tc>
+              </a:tr>
+              <a:tr h="237744">
+                <a:tc>
+                  <a:txBody>
+                    <a:bodyPr/>
+                    <a:lstStyle/>
+                    <a:p>
+                      <a:pPr algn="ctr"/>
+                      <a:r>
+                        <a:rPr sz="950" b="1">
+                          <a:solidFill>
+                            <a:srgbClr val="1E3A8A"/>
+                          </a:solidFill>
+                          <a:latin typeface="Calibri"/>
+                        </a:rPr>
+                        <a:t>4</a:t>
+                      </a:r>
+                    </a:p>
+                  </a:txBody>
+                  <a:tcPr marL="54864" marR="54864" marT="27432" marB="27432">
+                    <a:solidFill>
+                      <a:srgbClr val="EFF6FF"/>
+                    </a:solidFill>
+                  </a:tcPr>
+                </a:tc>
+                <a:tc>
+                  <a:txBody>
+                    <a:bodyPr/>
+                    <a:lstStyle/>
+                    <a:p>
+                      <a:pPr algn="l"/>
+                      <a:r>
+                        <a:rPr sz="950" b="1">
+                          <a:solidFill>
+                            <a:srgbClr val="0F172A"/>
+                          </a:solidFill>
+                          <a:latin typeface="Calibri"/>
+                        </a:rPr>
+                        <a:t>SSRF TOCTOU / DNS Rebinding Window in api/mcp-proxy.ts (Cloud metadata 169.254.169.254 reachability)</a:t>
+                      </a:r>
+                    </a:p>
+                  </a:txBody>
+                  <a:tcPr marL="54864" marR="54864" marT="27432" marB="27432">
+                    <a:solidFill>
+                      <a:srgbClr val="EFF6FF"/>
+                    </a:solidFill>
+                  </a:tcPr>
+                </a:tc>
+                <a:tc>
+                  <a:txBody>
+                    <a:bodyPr/>
+                    <a:lstStyle/>
+                    <a:p>
+                      <a:pPr algn="ctr"/>
+                      <a:r>
+                        <a:rPr sz="900" b="0">
+                          <a:solidFill>
+                            <a:srgbClr val="475569"/>
+                          </a:solidFill>
+                          <a:latin typeface="Calibri"/>
+                        </a:rPr>
+                        <a:t>OWASP A10 · CWE-918 (Server-Side Request Forgery)</a:t>
+                      </a:r>
+                    </a:p>
+                  </a:txBody>
+                  <a:tcPr marL="54864" marR="54864" marT="27432" marB="27432">
+                    <a:solidFill>
+                      <a:srgbClr val="EFF6FF"/>
+                    </a:solidFill>
+                  </a:tcPr>
+                </a:tc>
+                <a:tc>
+                  <a:txBody>
+                    <a:bodyPr/>
+                    <a:lstStyle/>
+                    <a:p>
+                      <a:pPr algn="ctr"/>
+                      <a:r>
+                        <a:rPr sz="950" b="1">
+                          <a:solidFill>
+                            <a:srgbClr val="1E3A8A"/>
+                          </a:solidFill>
+                          <a:latin typeface="Calibri"/>
+                        </a:rPr>
+                        <a:t>6.3 (Med) · Confirmed PoC</a:t>
+                      </a:r>
+                    </a:p>
+                  </a:txBody>
+                  <a:tcPr marL="54864" marR="54864" marT="27432" marB="27432">
+                    <a:solidFill>
+                      <a:srgbClr val="EFF6FF"/>
+                    </a:solidFill>
+                  </a:tcPr>
+                </a:tc>
+              </a:tr>
+            </a:tbl>
+          </a:graphicData>
+        </a:graphic>
+      </p:graphicFrame>
     </p:spTree>
   </p:cSld>
   <p:clrMapOvr>
@@ -4417,7 +4411,7 @@
         <p:spPr>
           <a:xfrm>
             <a:off x="457200" y="1572768"/>
-            <a:ext cx="2148840" cy="1051560"/>
+            <a:ext cx="2148840" cy="1243584"/>
           </a:xfrm>
           <a:prstGeom prst="roundRect">
             <a:avLst>
@@ -4529,8 +4523,8 @@
         </p:nvSpPr>
         <p:spPr>
           <a:xfrm>
-            <a:off x="603504" y="2084832"/>
-            <a:ext cx="1874520" cy="457200"/>
+            <a:off x="603504" y="2029968"/>
+            <a:ext cx="1874520" cy="640080"/>
           </a:xfrm>
           <a:prstGeom prst="rect">
             <a:avLst/>
@@ -4546,7 +4540,7 @@
               <a:buNone/>
             </a:pPr>
             <a:r>
-              <a:rPr sz="1000" b="0">
+              <a:rPr sz="950" b="0">
                 <a:solidFill>
                   <a:srgbClr val="0F172A"/>
                 </a:solidFill>
@@ -4558,7 +4552,7 @@
           </a:p>
           <a:p>
             <a:r>
-              <a:rPr sz="1000" b="0">
+              <a:rPr sz="950" b="0">
                 <a:solidFill>
                   <a:srgbClr val="0F172A"/>
                 </a:solidFill>
@@ -4569,24 +4563,13 @@
           </a:p>
           <a:p>
             <a:r>
-              <a:rPr sz="1000" b="0">
+              <a:rPr sz="950" b="0">
                 <a:solidFill>
                   <a:srgbClr val="0F172A"/>
                 </a:solidFill>
                 <a:latin typeface="Calibri"/>
               </a:rPr>
               <a:t>• 5 Trust Boundaries Mapped</a:t>
-            </a:r>
-          </a:p>
-          <a:p>
-            <a:r>
-              <a:rPr sz="1000" b="0">
-                <a:solidFill>
-                  <a:srgbClr val="0F172A"/>
-                </a:solidFill>
-                <a:latin typeface="Calibri"/>
-              </a:rPr>
-              <a:t>• Next.js + Tauri 2.0 Rust Shell</a:t>
             </a:r>
           </a:p>
         </p:txBody>
@@ -4624,7 +4607,7 @@
         <p:spPr>
           <a:xfrm>
             <a:off x="2788920" y="1572768"/>
-            <a:ext cx="2148840" cy="1051560"/>
+            <a:ext cx="2148840" cy="1243584"/>
           </a:xfrm>
           <a:prstGeom prst="roundRect">
             <a:avLst>
@@ -4736,8 +4719,8 @@
         </p:nvSpPr>
         <p:spPr>
           <a:xfrm>
-            <a:off x="2935224" y="2084832"/>
-            <a:ext cx="1874520" cy="457200"/>
+            <a:off x="2935224" y="2029968"/>
+            <a:ext cx="1874520" cy="640080"/>
           </a:xfrm>
           <a:prstGeom prst="rect">
             <a:avLst/>
@@ -4753,7 +4736,7 @@
               <a:buNone/>
             </a:pPr>
             <a:r>
-              <a:rPr sz="1000" b="0">
+              <a:rPr sz="950" b="0">
                 <a:solidFill>
                   <a:srgbClr val="0F172A"/>
                 </a:solidFill>
@@ -4765,7 +4748,7 @@
           </a:p>
           <a:p>
             <a:r>
-              <a:rPr sz="1000" b="0">
+              <a:rPr sz="950" b="0">
                 <a:solidFill>
                   <a:srgbClr val="0F172A"/>
                 </a:solidFill>
@@ -4776,24 +4759,13 @@
           </a:p>
           <a:p>
             <a:r>
-              <a:rPr sz="1000" b="0">
+              <a:rPr sz="950" b="0">
                 <a:solidFill>
                   <a:srgbClr val="0F172A"/>
                 </a:solidFill>
                 <a:latin typeface="Calibri"/>
               </a:rPr>
               <a:t>• npm audit SCA (28 CVEs)</a:t>
-            </a:r>
-          </a:p>
-          <a:p>
-            <a:r>
-              <a:rPr sz="1000" b="0">
-                <a:solidFill>
-                  <a:srgbClr val="0F172A"/>
-                </a:solidFill>
-                <a:latin typeface="Calibri"/>
-              </a:rPr>
-              <a:t>• Custom AST Route Parser</a:t>
             </a:r>
           </a:p>
         </p:txBody>
@@ -4831,7 +4803,7 @@
         <p:spPr>
           <a:xfrm>
             <a:off x="5120640" y="1572768"/>
-            <a:ext cx="2148840" cy="1051560"/>
+            <a:ext cx="2148840" cy="1243584"/>
           </a:xfrm>
           <a:prstGeom prst="roundRect">
             <a:avLst>
@@ -4943,8 +4915,8 @@
         </p:nvSpPr>
         <p:spPr>
           <a:xfrm>
-            <a:off x="5266944" y="2084832"/>
-            <a:ext cx="1874520" cy="457200"/>
+            <a:off x="5266944" y="2029968"/>
+            <a:ext cx="1874520" cy="640080"/>
           </a:xfrm>
           <a:prstGeom prst="rect">
             <a:avLst/>
@@ -4960,7 +4932,7 @@
               <a:buNone/>
             </a:pPr>
             <a:r>
-              <a:rPr sz="1000" b="0">
+              <a:rPr sz="950" b="0">
                 <a:solidFill>
                   <a:srgbClr val="0F172A"/>
                 </a:solidFill>
@@ -4972,7 +4944,7 @@
           </a:p>
           <a:p>
             <a:r>
-              <a:rPr sz="1000" b="0">
+              <a:rPr sz="950" b="0">
                 <a:solidFill>
                   <a:srgbClr val="0F172A"/>
                 </a:solidFill>
@@ -4983,18 +4955,7 @@
           </a:p>
           <a:p>
             <a:r>
-              <a:rPr sz="1000" b="0">
-                <a:solidFill>
-                  <a:srgbClr val="0F172A"/>
-                </a:solidFill>
-                <a:latin typeface="Calibri"/>
-              </a:rPr>
-              <a:t>• Two-Signal Confirmation</a:t>
-            </a:r>
-          </a:p>
-          <a:p>
-            <a:r>
-              <a:rPr sz="1000" b="0">
+              <a:rPr sz="950" b="0">
                 <a:solidFill>
                   <a:srgbClr val="0F172A"/>
                 </a:solidFill>
@@ -5038,7 +4999,7 @@
         <p:spPr>
           <a:xfrm>
             <a:off x="7452360" y="1572768"/>
-            <a:ext cx="2148840" cy="1051560"/>
+            <a:ext cx="2148840" cy="1243584"/>
           </a:xfrm>
           <a:prstGeom prst="roundRect">
             <a:avLst>
@@ -5150,8 +5111,8 @@
         </p:nvSpPr>
         <p:spPr>
           <a:xfrm>
-            <a:off x="7598664" y="2084832"/>
-            <a:ext cx="1874520" cy="457200"/>
+            <a:off x="7598664" y="2029968"/>
+            <a:ext cx="1874520" cy="640080"/>
           </a:xfrm>
           <a:prstGeom prst="rect">
             <a:avLst/>
@@ -5167,7 +5128,7 @@
               <a:buNone/>
             </a:pPr>
             <a:r>
-              <a:rPr sz="1000" b="0">
+              <a:rPr sz="950" b="0">
                 <a:solidFill>
                   <a:srgbClr val="0F172A"/>
                 </a:solidFill>
@@ -5179,7 +5140,7 @@
           </a:p>
           <a:p>
             <a:r>
-              <a:rPr sz="1000" b="0">
+              <a:rPr sz="950" b="0">
                 <a:solidFill>
                   <a:srgbClr val="0F172A"/>
                 </a:solidFill>
@@ -5190,24 +5151,13 @@
           </a:p>
           <a:p>
             <a:r>
-              <a:rPr sz="1000" b="0">
-                <a:solidFill>
-                  <a:srgbClr val="0F172A"/>
-                </a:solidFill>
-                <a:latin typeface="Calibri"/>
-              </a:rPr>
-              <a:t>• SARIF 2.1.0 &amp; JSON Findings</a:t>
-            </a:r>
-          </a:p>
-          <a:p>
-            <a:r>
-              <a:rPr sz="1000" b="0">
-                <a:solidFill>
-                  <a:srgbClr val="0F172A"/>
-                </a:solidFill>
-                <a:latin typeface="Calibri"/>
-              </a:rPr>
-              <a:t>• 5 Safe PoC Execution Proofs</a:t>
+              <a:rPr sz="950" b="0">
+                <a:solidFill>
+                  <a:srgbClr val="0F172A"/>
+                </a:solidFill>
+                <a:latin typeface="Calibri"/>
+              </a:rPr>
+              <a:t>• SARIF 2.1.0 JSON &amp; 5 PoCs</a:t>
             </a:r>
           </a:p>
         </p:txBody>
@@ -5220,8 +5170,8 @@
         </p:nvSpPr>
         <p:spPr>
           <a:xfrm>
-            <a:off x="457200" y="2743200"/>
-            <a:ext cx="9144000" cy="274320"/>
+            <a:off x="457200" y="2788920"/>
+            <a:ext cx="9144000" cy="256032"/>
           </a:xfrm>
           <a:prstGeom prst="rect">
             <a:avLst/>
@@ -5237,7 +5187,7 @@
               <a:buNone/>
             </a:pPr>
             <a:r>
-              <a:rPr sz="1000" b="0">
+              <a:rPr sz="950" b="0">
                 <a:solidFill>
                   <a:srgbClr val="475569"/>
                 </a:solidFill>
@@ -6852,28 +6802,26 @@
       </p:sp>
       <p:sp>
         <p:nvSpPr>
-          <p:cNvPr id="9" name="Text 6"/>
-          <p:cNvSpPr txBox="1"/>
-          <p:nvPr/>
-        </p:nvSpPr>
-        <p:spPr>
-          <a:xfrm>
-            <a:off x="457200" y="1207008"/>
-            <a:ext cx="5486400" cy="292608"/>
-          </a:xfrm>
-          <a:prstGeom prst="rect">
-            <a:avLst/>
-          </a:prstGeom>
-          <a:noFill/>
-          <a:ln/>
-        </p:spPr>
-        <p:txBody>
-          <a:bodyPr wrap="square" lIns="36576" tIns="18288" rIns="36576" bIns="18288" rtlCol="0" anchor="ctr"/>
-          <a:lstStyle/>
-          <a:p>
-            <a:pPr indent="0" marL="0">
-              <a:buNone/>
-            </a:pPr>
+          <p:cNvPr id="9" name="TextBox 8"/>
+          <p:cNvSpPr txBox="1"/>
+          <p:nvPr/>
+        </p:nvSpPr>
+        <p:spPr>
+          <a:xfrm>
+            <a:off x="457200" y="1115568"/>
+            <a:ext cx="4754880" cy="320040"/>
+          </a:xfrm>
+          <a:prstGeom prst="rect">
+            <a:avLst/>
+          </a:prstGeom>
+          <a:noFill/>
+        </p:spPr>
+        <p:txBody>
+          <a:bodyPr wrap="square" lIns="36576" rIns="36576" tIns="18288" bIns="18288">
+            <a:spAutoFit/>
+          </a:bodyPr>
+          <a:lstStyle/>
+          <a:p>
             <a:r>
               <a:rPr sz="1200" b="1">
                 <a:solidFill>
@@ -6881,24 +6829,57 @@
                 </a:solidFill>
                 <a:latin typeface="Calibri"/>
               </a:rPr>
-              <a:t>Feasibility :</a:t>
-            </a:r>
-            <a:endParaRPr lang="en-US" sz="1400" dirty="0"/>
-          </a:p>
-        </p:txBody>
-      </p:sp>
-      <p:sp>
-        <p:nvSpPr>
-          <p:cNvPr id="10" name="Shape 7"/>
+              <a:t>Feasibility &amp; Operational Execution Flow :</a:t>
+            </a:r>
+          </a:p>
+        </p:txBody>
+      </p:sp>
+      <p:sp>
+        <p:nvSpPr>
+          <p:cNvPr id="10" name="TextBox 9"/>
+          <p:cNvSpPr txBox="1"/>
+          <p:nvPr/>
+        </p:nvSpPr>
+        <p:spPr>
+          <a:xfrm>
+            <a:off x="5440680" y="1115568"/>
+            <a:ext cx="6217920" cy="320040"/>
+          </a:xfrm>
+          <a:prstGeom prst="rect">
+            <a:avLst/>
+          </a:prstGeom>
+          <a:noFill/>
+        </p:spPr>
+        <p:txBody>
+          <a:bodyPr wrap="square" lIns="36576" rIns="36576" tIns="18288" bIns="18288">
+            <a:spAutoFit/>
+          </a:bodyPr>
+          <a:lstStyle/>
+          <a:p>
+            <a:r>
+              <a:rPr sz="1200" b="1">
+                <a:solidFill>
+                  <a:srgbClr val="0F172A"/>
+                </a:solidFill>
+                <a:latin typeface="Calibri"/>
+              </a:rPr>
+              <a:t>Feasibility &amp; Viability Analysis (Detailed Assessment) :</a:t>
+            </a:r>
+          </a:p>
+        </p:txBody>
+      </p:sp>
+      <p:sp>
+        <p:nvSpPr>
+          <p:cNvPr id="11" name="Rounded Rectangle 10"/>
           <p:cNvSpPr/>
           <p:nvPr/>
         </p:nvSpPr>
         <p:spPr>
           <a:xfrm>
-            <a:off x="457200" y="1572768"/>
-            <a:ext cx="292608" cy="292608"/>
-          </a:xfrm>
-          <a:prstGeom prst="ellipse">
+            <a:off x="457200" y="1508760"/>
+            <a:ext cx="4709160" cy="749808"/>
+          </a:xfrm>
+          <a:prstGeom prst="roundRect">
             <a:avLst/>
           </a:prstGeom>
           <a:solidFill>
@@ -6908,86 +6889,116 @@
             <a:solidFill>
               <a:srgbClr val="BFDBFE"/>
             </a:solidFill>
-            <a:prstDash val="solid"/>
           </a:ln>
         </p:spPr>
-      </p:sp>
-      <p:pic>
-        <p:nvPicPr>
-          <p:cNvPr id="11" name="Image 1" descr="preencoded.png">    </p:cNvPr>
-          <p:cNvPicPr>
-            <a:picLocks noChangeAspect="1"/>
-          </p:cNvPicPr>
-          <p:nvPr/>
-        </p:nvPicPr>
-        <p:blipFill>
-          <a:blip r:embed="rId2"/>
-          <a:stretch>
-            <a:fillRect/>
-          </a:stretch>
-        </p:blipFill>
-        <p:spPr>
-          <a:xfrm>
-            <a:off x="533278" y="1648846"/>
-            <a:ext cx="140452" cy="140452"/>
-          </a:xfrm>
-          <a:prstGeom prst="rect">
-            <a:avLst/>
-          </a:prstGeom>
-        </p:spPr>
-      </p:pic>
-      <p:sp>
-        <p:nvSpPr>
-          <p:cNvPr id="12" name="Text 8"/>
-          <p:cNvSpPr txBox="1"/>
-          <p:nvPr/>
-        </p:nvSpPr>
-        <p:spPr>
-          <a:xfrm>
-            <a:off x="841248" y="1545336"/>
-            <a:ext cx="5102352" cy="502920"/>
-          </a:xfrm>
-          <a:prstGeom prst="rect">
-            <a:avLst/>
-          </a:prstGeom>
-          <a:noFill/>
-          <a:ln/>
-        </p:spPr>
-        <p:txBody>
-          <a:bodyPr wrap="square" lIns="36576" tIns="18288" rIns="36576" bIns="18288" rtlCol="0" anchor="t"/>
-          <a:lstStyle/>
-          <a:p>
-            <a:pPr indent="0" marL="0">
-              <a:buNone/>
-            </a:pPr>
-            <a:pPr indent="0" marL="0">
-              <a:buNone/>
-            </a:pPr>
-            <a:r>
-              <a:rPr sz="1000" b="0">
-                <a:solidFill>
-                  <a:srgbClr val="0F172A"/>
-                </a:solidFill>
-                <a:latin typeface="Calibri"/>
-              </a:rPr>
-              <a:t>Technical: Full access to AGPL-3.0 source; audited 166 Vercel Edge routes and Tauri Rust IPC locally without external cloud dependencies.</a:t>
-            </a:r>
-            <a:endParaRPr lang="en-US" sz="1030" dirty="0"/>
-          </a:p>
-        </p:txBody>
-      </p:sp>
-      <p:sp>
-        <p:nvSpPr>
-          <p:cNvPr id="13" name="Shape 9"/>
+        <p:style>
+          <a:lnRef idx="1">
+            <a:schemeClr val="accent1"/>
+          </a:lnRef>
+          <a:fillRef idx="3">
+            <a:schemeClr val="accent1"/>
+          </a:fillRef>
+          <a:effectRef idx="2">
+            <a:schemeClr val="accent1"/>
+          </a:effectRef>
+          <a:fontRef idx="minor">
+            <a:schemeClr val="lt1"/>
+          </a:fontRef>
+        </p:style>
+        <p:txBody>
+          <a:bodyPr rtlCol="0" anchor="ctr" wrap="square" lIns="109728" tIns="54864" bIns="54864"/>
+          <a:lstStyle/>
+          <a:p>
+            <a:pPr algn="ctr"/>
+            <a:r>
+              <a:rPr sz="1050" b="1">
+                <a:solidFill>
+                  <a:srgbClr val="1E3A8A"/>
+                </a:solidFill>
+                <a:latin typeface="Calibri"/>
+              </a:rPr>
+              <a:t>1. Target Sandbox Isolation</a:t>
+            </a:r>
+          </a:p>
+          <a:p>
+            <a:r>
+              <a:rPr sz="900" b="0">
+                <a:solidFill>
+                  <a:srgbClr val="0F172A"/>
+                </a:solidFill>
+                <a:latin typeface="Calibri"/>
+              </a:rPr>
+              <a:t>• AGPL-3.0 self-hosted World Monitor instance (localhost:3000)</a:t>
+            </a:r>
+          </a:p>
+          <a:p>
+            <a:r>
+              <a:rPr sz="900" b="0">
+                <a:solidFill>
+                  <a:srgbClr val="0F172A"/>
+                </a:solidFill>
+                <a:latin typeface="Calibri"/>
+              </a:rPr>
+              <a:t>• 100% isolated local execution; zero upstream cloud dependencies</a:t>
+            </a:r>
+          </a:p>
+        </p:txBody>
+      </p:sp>
+      <p:sp>
+        <p:nvSpPr>
+          <p:cNvPr id="12" name="Down Arrow 11"/>
           <p:cNvSpPr/>
           <p:nvPr/>
         </p:nvSpPr>
         <p:spPr>
           <a:xfrm>
-            <a:off x="457200" y="2194560"/>
-            <a:ext cx="292608" cy="292608"/>
-          </a:xfrm>
-          <a:prstGeom prst="ellipse">
+            <a:off x="2738628" y="2276856"/>
+            <a:ext cx="146304" cy="128016"/>
+          </a:xfrm>
+          <a:prstGeom prst="downArrow">
+            <a:avLst/>
+          </a:prstGeom>
+          <a:solidFill>
+            <a:srgbClr val="1E3A8A"/>
+          </a:solidFill>
+          <a:ln>
+            <a:noFill/>
+          </a:ln>
+        </p:spPr>
+        <p:style>
+          <a:lnRef idx="1">
+            <a:schemeClr val="accent1"/>
+          </a:lnRef>
+          <a:fillRef idx="3">
+            <a:schemeClr val="accent1"/>
+          </a:fillRef>
+          <a:effectRef idx="2">
+            <a:schemeClr val="accent1"/>
+          </a:effectRef>
+          <a:fontRef idx="minor">
+            <a:schemeClr val="lt1"/>
+          </a:fontRef>
+        </p:style>
+        <p:txBody>
+          <a:bodyPr rtlCol="0" anchor="ctr"/>
+          <a:lstStyle/>
+          <a:p>
+            <a:pPr algn="ctr"/>
+          </a:p>
+        </p:txBody>
+      </p:sp>
+      <p:sp>
+        <p:nvSpPr>
+          <p:cNvPr id="13" name="Rounded Rectangle 12"/>
+          <p:cNvSpPr/>
+          <p:nvPr/>
+        </p:nvSpPr>
+        <p:spPr>
+          <a:xfrm>
+            <a:off x="457200" y="2423160"/>
+            <a:ext cx="4709160" cy="749808"/>
+          </a:xfrm>
+          <a:prstGeom prst="roundRect">
             <a:avLst/>
           </a:prstGeom>
           <a:solidFill>
@@ -6997,86 +7008,116 @@
             <a:solidFill>
               <a:srgbClr val="BFDBFE"/>
             </a:solidFill>
-            <a:prstDash val="solid"/>
           </a:ln>
         </p:spPr>
-      </p:sp>
-      <p:pic>
-        <p:nvPicPr>
-          <p:cNvPr id="14" name="Image 2" descr="preencoded.png">    </p:cNvPr>
-          <p:cNvPicPr>
-            <a:picLocks noChangeAspect="1"/>
-          </p:cNvPicPr>
-          <p:nvPr/>
-        </p:nvPicPr>
-        <p:blipFill>
-          <a:blip r:embed="rId3"/>
-          <a:stretch>
-            <a:fillRect/>
-          </a:stretch>
-        </p:blipFill>
-        <p:spPr>
-          <a:xfrm>
-            <a:off x="533278" y="2270638"/>
-            <a:ext cx="140452" cy="140452"/>
-          </a:xfrm>
-          <a:prstGeom prst="rect">
-            <a:avLst/>
-          </a:prstGeom>
-        </p:spPr>
-      </p:pic>
-      <p:sp>
-        <p:nvSpPr>
-          <p:cNvPr id="15" name="Text 10"/>
-          <p:cNvSpPr txBox="1"/>
-          <p:nvPr/>
-        </p:nvSpPr>
-        <p:spPr>
-          <a:xfrm>
-            <a:off x="841248" y="2167128"/>
-            <a:ext cx="5102352" cy="502920"/>
-          </a:xfrm>
-          <a:prstGeom prst="rect">
-            <a:avLst/>
-          </a:prstGeom>
-          <a:noFill/>
-          <a:ln/>
-        </p:spPr>
-        <p:txBody>
-          <a:bodyPr wrap="square" lIns="36576" tIns="18288" rIns="36576" bIns="18288" rtlCol="0" anchor="t"/>
-          <a:lstStyle/>
-          <a:p>
-            <a:pPr indent="0" marL="0">
-              <a:buNone/>
-            </a:pPr>
-            <a:pPr indent="0" marL="0">
-              <a:buNone/>
-            </a:pPr>
-            <a:r>
-              <a:rPr sz="1000" b="0">
-                <a:solidFill>
-                  <a:srgbClr val="0F172A"/>
-                </a:solidFill>
-                <a:latin typeface="Calibri"/>
-              </a:rPr>
-              <a:t>Economic: Zero licensing cost; 100% open-source tooling (Semgrep, Python, ReportLab, Playwright); automates weeks of manual penetration testing.</a:t>
-            </a:r>
-            <a:endParaRPr lang="en-US" sz="1030" dirty="0"/>
-          </a:p>
-        </p:txBody>
-      </p:sp>
-      <p:sp>
-        <p:nvSpPr>
-          <p:cNvPr id="16" name="Shape 11"/>
+        <p:style>
+          <a:lnRef idx="1">
+            <a:schemeClr val="accent1"/>
+          </a:lnRef>
+          <a:fillRef idx="3">
+            <a:schemeClr val="accent1"/>
+          </a:fillRef>
+          <a:effectRef idx="2">
+            <a:schemeClr val="accent1"/>
+          </a:effectRef>
+          <a:fontRef idx="minor">
+            <a:schemeClr val="lt1"/>
+          </a:fontRef>
+        </p:style>
+        <p:txBody>
+          <a:bodyPr rtlCol="0" anchor="ctr" wrap="square" lIns="109728" tIns="54864" bIns="54864"/>
+          <a:lstStyle/>
+          <a:p>
+            <a:pPr algn="ctr"/>
+            <a:r>
+              <a:rPr sz="1050" b="1">
+                <a:solidFill>
+                  <a:srgbClr val="1E3A8A"/>
+                </a:solidFill>
+                <a:latin typeface="Calibri"/>
+              </a:rPr>
+              <a:t>2. Multi-Engine Surface Recon</a:t>
+            </a:r>
+          </a:p>
+          <a:p>
+            <a:r>
+              <a:rPr sz="900" b="0">
+                <a:solidFill>
+                  <a:srgbClr val="0F172A"/>
+                </a:solidFill>
+                <a:latin typeface="Calibri"/>
+              </a:rPr>
+              <a:t>• AST route parsing across 166 Vercel Edge routes (137 public, 29 Pro)</a:t>
+            </a:r>
+          </a:p>
+          <a:p>
+            <a:r>
+              <a:rPr sz="900" b="0">
+                <a:solidFill>
+                  <a:srgbClr val="0F172A"/>
+                </a:solidFill>
+                <a:latin typeface="Calibri"/>
+              </a:rPr>
+              <a:t>• Semgrep SAST rulesets + npm audit dependency CVE correlation</a:t>
+            </a:r>
+          </a:p>
+        </p:txBody>
+      </p:sp>
+      <p:sp>
+        <p:nvSpPr>
+          <p:cNvPr id="14" name="Down Arrow 13"/>
           <p:cNvSpPr/>
           <p:nvPr/>
         </p:nvSpPr>
         <p:spPr>
           <a:xfrm>
-            <a:off x="457200" y="2816352"/>
-            <a:ext cx="292608" cy="292608"/>
-          </a:xfrm>
-          <a:prstGeom prst="ellipse">
+            <a:off x="2738628" y="3191256"/>
+            <a:ext cx="146304" cy="128016"/>
+          </a:xfrm>
+          <a:prstGeom prst="downArrow">
+            <a:avLst/>
+          </a:prstGeom>
+          <a:solidFill>
+            <a:srgbClr val="1E3A8A"/>
+          </a:solidFill>
+          <a:ln>
+            <a:noFill/>
+          </a:ln>
+        </p:spPr>
+        <p:style>
+          <a:lnRef idx="1">
+            <a:schemeClr val="accent1"/>
+          </a:lnRef>
+          <a:fillRef idx="3">
+            <a:schemeClr val="accent1"/>
+          </a:fillRef>
+          <a:effectRef idx="2">
+            <a:schemeClr val="accent1"/>
+          </a:effectRef>
+          <a:fontRef idx="minor">
+            <a:schemeClr val="lt1"/>
+          </a:fontRef>
+        </p:style>
+        <p:txBody>
+          <a:bodyPr rtlCol="0" anchor="ctr"/>
+          <a:lstStyle/>
+          <a:p>
+            <a:pPr algn="ctr"/>
+          </a:p>
+        </p:txBody>
+      </p:sp>
+      <p:sp>
+        <p:nvSpPr>
+          <p:cNvPr id="15" name="Rounded Rectangle 14"/>
+          <p:cNvSpPr/>
+          <p:nvPr/>
+        </p:nvSpPr>
+        <p:spPr>
+          <a:xfrm>
+            <a:off x="457200" y="3337560"/>
+            <a:ext cx="4709160" cy="749808"/>
+          </a:xfrm>
+          <a:prstGeom prst="roundRect">
             <a:avLst/>
           </a:prstGeom>
           <a:solidFill>
@@ -7086,427 +7127,116 @@
             <a:solidFill>
               <a:srgbClr val="BFDBFE"/>
             </a:solidFill>
-            <a:prstDash val="solid"/>
           </a:ln>
         </p:spPr>
-      </p:sp>
-      <p:pic>
-        <p:nvPicPr>
-          <p:cNvPr id="17" name="Image 3" descr="preencoded.png">    </p:cNvPr>
-          <p:cNvPicPr>
-            <a:picLocks noChangeAspect="1"/>
-          </p:cNvPicPr>
-          <p:nvPr/>
-        </p:nvPicPr>
-        <p:blipFill>
-          <a:blip r:embed="rId4"/>
-          <a:stretch>
-            <a:fillRect/>
-          </a:stretch>
-        </p:blipFill>
-        <p:spPr>
-          <a:xfrm>
-            <a:off x="533278" y="2892430"/>
-            <a:ext cx="140452" cy="140452"/>
-          </a:xfrm>
-          <a:prstGeom prst="rect">
-            <a:avLst/>
-          </a:prstGeom>
-        </p:spPr>
-      </p:pic>
-      <p:sp>
-        <p:nvSpPr>
-          <p:cNvPr id="18" name="Text 12"/>
-          <p:cNvSpPr txBox="1"/>
-          <p:nvPr/>
-        </p:nvSpPr>
-        <p:spPr>
-          <a:xfrm>
-            <a:off x="841248" y="2788920"/>
-            <a:ext cx="5102352" cy="502920"/>
-          </a:xfrm>
-          <a:prstGeom prst="rect">
-            <a:avLst/>
-          </a:prstGeom>
-          <a:noFill/>
-          <a:ln/>
-        </p:spPr>
-        <p:txBody>
-          <a:bodyPr wrap="square" lIns="36576" tIns="18288" rIns="36576" bIns="18288" rtlCol="0" anchor="t"/>
-          <a:lstStyle/>
-          <a:p>
-            <a:pPr indent="0" marL="0">
-              <a:buNone/>
-            </a:pPr>
-            <a:pPr indent="0" marL="0">
-              <a:buNone/>
-            </a:pPr>
-            <a:r>
-              <a:rPr sz="1000" b="0">
-                <a:solidFill>
-                  <a:srgbClr val="0F172A"/>
-                </a:solidFill>
-                <a:latin typeface="Calibri"/>
-              </a:rPr>
-              <a:t>Operational: Fully reproducible single-command CLI execution (python argus/cli.py); completes complete multi-engine audit in under 60 seconds.</a:t>
-            </a:r>
-            <a:endParaRPr lang="en-US" sz="1030" dirty="0"/>
-          </a:p>
-        </p:txBody>
-      </p:sp>
-      <p:sp>
-        <p:nvSpPr>
-          <p:cNvPr id="19" name="Text 13"/>
-          <p:cNvSpPr txBox="1"/>
-          <p:nvPr/>
-        </p:nvSpPr>
-        <p:spPr>
-          <a:xfrm>
-            <a:off x="457200" y="3611880"/>
-            <a:ext cx="5486400" cy="292608"/>
-          </a:xfrm>
-          <a:prstGeom prst="rect">
-            <a:avLst/>
-          </a:prstGeom>
-          <a:noFill/>
-          <a:ln/>
-        </p:spPr>
-        <p:txBody>
-          <a:bodyPr wrap="square" lIns="36576" tIns="18288" rIns="36576" bIns="18288" rtlCol="0" anchor="ctr"/>
-          <a:lstStyle/>
-          <a:p>
-            <a:pPr indent="0" marL="0">
-              <a:buNone/>
-            </a:pPr>
-            <a:r>
-              <a:rPr sz="1200" b="1">
-                <a:solidFill>
-                  <a:srgbClr val="0F172A"/>
-                </a:solidFill>
-                <a:latin typeface="Calibri"/>
-              </a:rPr>
-              <a:t>Challenges :</a:t>
-            </a:r>
-            <a:endParaRPr lang="en-US" sz="1400" dirty="0"/>
-          </a:p>
-        </p:txBody>
-      </p:sp>
-      <p:sp>
-        <p:nvSpPr>
-          <p:cNvPr id="20" name="Shape 14"/>
+        <p:style>
+          <a:lnRef idx="1">
+            <a:schemeClr val="accent1"/>
+          </a:lnRef>
+          <a:fillRef idx="3">
+            <a:schemeClr val="accent1"/>
+          </a:fillRef>
+          <a:effectRef idx="2">
+            <a:schemeClr val="accent1"/>
+          </a:effectRef>
+          <a:fontRef idx="minor">
+            <a:schemeClr val="lt1"/>
+          </a:fontRef>
+        </p:style>
+        <p:txBody>
+          <a:bodyPr rtlCol="0" anchor="ctr" wrap="square" lIns="109728" tIns="54864" bIns="54864"/>
+          <a:lstStyle/>
+          <a:p>
+            <a:pPr algn="ctr"/>
+            <a:r>
+              <a:rPr sz="1050" b="1">
+                <a:solidFill>
+                  <a:srgbClr val="1E3A8A"/>
+                </a:solidFill>
+                <a:latin typeface="Calibri"/>
+              </a:rPr>
+              <a:t>3. Correlation &amp; Two-Signal Gate</a:t>
+            </a:r>
+          </a:p>
+          <a:p>
+            <a:r>
+              <a:rPr sz="900" b="0">
+                <a:solidFill>
+                  <a:srgbClr val="0F172A"/>
+                </a:solidFill>
+                <a:latin typeface="Calibri"/>
+              </a:rPr>
+              <a:t>• Pydantic v2 unified schema; automated deduplication</a:t>
+            </a:r>
+          </a:p>
+          <a:p>
+            <a:r>
+              <a:rPr sz="900" b="0">
+                <a:solidFill>
+                  <a:srgbClr val="0F172A"/>
+                </a:solidFill>
+                <a:latin typeface="Calibri"/>
+              </a:rPr>
+              <a:t>• Discards unverified scanner noise, cutting 80% triage overhead</a:t>
+            </a:r>
+          </a:p>
+        </p:txBody>
+      </p:sp>
+      <p:sp>
+        <p:nvSpPr>
+          <p:cNvPr id="16" name="Down Arrow 15"/>
           <p:cNvSpPr/>
           <p:nvPr/>
         </p:nvSpPr>
         <p:spPr>
           <a:xfrm>
-            <a:off x="457200" y="3977640"/>
-            <a:ext cx="292608" cy="292608"/>
-          </a:xfrm>
-          <a:prstGeom prst="ellipse">
+            <a:off x="2738628" y="4105656"/>
+            <a:ext cx="146304" cy="128016"/>
+          </a:xfrm>
+          <a:prstGeom prst="downArrow">
             <a:avLst/>
           </a:prstGeom>
           <a:solidFill>
-            <a:srgbClr val="FFF7ED"/>
+            <a:srgbClr val="1E3A8A"/>
           </a:solidFill>
-          <a:ln w="12700">
-            <a:solidFill>
-              <a:srgbClr val="EA580C"/>
-            </a:solidFill>
-            <a:prstDash val="solid"/>
+          <a:ln>
+            <a:noFill/>
           </a:ln>
         </p:spPr>
-      </p:sp>
-      <p:pic>
-        <p:nvPicPr>
-          <p:cNvPr id="21" name="Image 4" descr="preencoded.png">    </p:cNvPr>
-          <p:cNvPicPr>
-            <a:picLocks noChangeAspect="1"/>
-          </p:cNvPicPr>
-          <p:nvPr/>
-        </p:nvPicPr>
-        <p:blipFill>
-          <a:blip r:embed="rId5"/>
-          <a:stretch>
-            <a:fillRect/>
-          </a:stretch>
-        </p:blipFill>
-        <p:spPr>
-          <a:xfrm>
-            <a:off x="533278" y="4053718"/>
-            <a:ext cx="140452" cy="140452"/>
-          </a:xfrm>
-          <a:prstGeom prst="rect">
-            <a:avLst/>
-          </a:prstGeom>
-        </p:spPr>
-      </p:pic>
-      <p:sp>
-        <p:nvSpPr>
-          <p:cNvPr id="22" name="Text 15"/>
-          <p:cNvSpPr txBox="1"/>
-          <p:nvPr/>
-        </p:nvSpPr>
-        <p:spPr>
-          <a:xfrm>
-            <a:off x="841248" y="3950208"/>
-            <a:ext cx="5102352" cy="502920"/>
-          </a:xfrm>
-          <a:prstGeom prst="rect">
-            <a:avLst/>
-          </a:prstGeom>
-          <a:noFill/>
-          <a:ln/>
-        </p:spPr>
-        <p:txBody>
-          <a:bodyPr wrap="square" lIns="36576" tIns="18288" rIns="36576" bIns="18288" rtlCol="0" anchor="t"/>
-          <a:lstStyle/>
-          <a:p>
-            <a:pPr indent="0" marL="0">
-              <a:buNone/>
-            </a:pPr>
-            <a:pPr indent="0" marL="0">
-              <a:buNone/>
-            </a:pPr>
-            <a:r>
-              <a:rPr sz="1000" b="0">
-                <a:solidFill>
-                  <a:srgbClr val="0F172A"/>
-                </a:solidFill>
-                <a:latin typeface="Calibri"/>
-              </a:rPr>
-              <a:t>Scanner Noise: Two-signal cross-confirmation gate discards unverified anomalies before PoC stage, eliminating 80% of triage overhead.</a:t>
-            </a:r>
-            <a:endParaRPr lang="en-US" sz="1030" dirty="0"/>
-          </a:p>
-        </p:txBody>
-      </p:sp>
-      <p:sp>
-        <p:nvSpPr>
-          <p:cNvPr id="23" name="Shape 16"/>
+        <p:style>
+          <a:lnRef idx="1">
+            <a:schemeClr val="accent1"/>
+          </a:lnRef>
+          <a:fillRef idx="3">
+            <a:schemeClr val="accent1"/>
+          </a:fillRef>
+          <a:effectRef idx="2">
+            <a:schemeClr val="accent1"/>
+          </a:effectRef>
+          <a:fontRef idx="minor">
+            <a:schemeClr val="lt1"/>
+          </a:fontRef>
+        </p:style>
+        <p:txBody>
+          <a:bodyPr rtlCol="0" anchor="ctr"/>
+          <a:lstStyle/>
+          <a:p>
+            <a:pPr algn="ctr"/>
+          </a:p>
+        </p:txBody>
+      </p:sp>
+      <p:sp>
+        <p:nvSpPr>
+          <p:cNvPr id="17" name="Rounded Rectangle 16"/>
           <p:cNvSpPr/>
           <p:nvPr/>
         </p:nvSpPr>
         <p:spPr>
           <a:xfrm>
-            <a:off x="457200" y="4599432"/>
-            <a:ext cx="292608" cy="292608"/>
-          </a:xfrm>
-          <a:prstGeom prst="ellipse">
-            <a:avLst/>
-          </a:prstGeom>
-          <a:solidFill>
-            <a:srgbClr val="FFF7ED"/>
-          </a:solidFill>
-          <a:ln w="12700">
-            <a:solidFill>
-              <a:srgbClr val="EA580C"/>
-            </a:solidFill>
-            <a:prstDash val="solid"/>
-          </a:ln>
-        </p:spPr>
-      </p:sp>
-      <p:pic>
-        <p:nvPicPr>
-          <p:cNvPr id="24" name="Image 5" descr="preencoded.png">    </p:cNvPr>
-          <p:cNvPicPr>
-            <a:picLocks noChangeAspect="1"/>
-          </p:cNvPicPr>
-          <p:nvPr/>
-        </p:nvPicPr>
-        <p:blipFill>
-          <a:blip r:embed="rId6"/>
-          <a:stretch>
-            <a:fillRect/>
-          </a:stretch>
-        </p:blipFill>
-        <p:spPr>
-          <a:xfrm>
-            <a:off x="533278" y="4675510"/>
-            <a:ext cx="140452" cy="140452"/>
-          </a:xfrm>
-          <a:prstGeom prst="rect">
-            <a:avLst/>
-          </a:prstGeom>
-        </p:spPr>
-      </p:pic>
-      <p:sp>
-        <p:nvSpPr>
-          <p:cNvPr id="25" name="Text 17"/>
-          <p:cNvSpPr txBox="1"/>
-          <p:nvPr/>
-        </p:nvSpPr>
-        <p:spPr>
-          <a:xfrm>
-            <a:off x="841248" y="4572000"/>
-            <a:ext cx="5102352" cy="502920"/>
-          </a:xfrm>
-          <a:prstGeom prst="rect">
-            <a:avLst/>
-          </a:prstGeom>
-          <a:noFill/>
-          <a:ln/>
-        </p:spPr>
-        <p:txBody>
-          <a:bodyPr wrap="square" lIns="36576" tIns="18288" rIns="36576" bIns="18288" rtlCol="0" anchor="t"/>
-          <a:lstStyle/>
-          <a:p>
-            <a:pPr indent="0" marL="0">
-              <a:buNone/>
-            </a:pPr>
-            <a:pPr indent="0" marL="0">
-              <a:buNone/>
-            </a:pPr>
-            <a:r>
-              <a:rPr sz="1000" b="0">
-                <a:solidFill>
-                  <a:srgbClr val="0F172A"/>
-                </a:solidFill>
-                <a:latin typeface="Calibri"/>
-              </a:rPr>
-              <a:t>Architecture Alignment: Mapped real attack surface (166 endpoints, 5 trust boundaries) rather than assuming hypothetical textbook roles.</a:t>
-            </a:r>
-            <a:endParaRPr lang="en-US" sz="1030" dirty="0"/>
-          </a:p>
-        </p:txBody>
-      </p:sp>
-      <p:sp>
-        <p:nvSpPr>
-          <p:cNvPr id="26" name="Shape 18"/>
-          <p:cNvSpPr/>
-          <p:nvPr/>
-        </p:nvSpPr>
-        <p:spPr>
-          <a:xfrm>
-            <a:off x="457200" y="5221224"/>
-            <a:ext cx="292608" cy="292608"/>
-          </a:xfrm>
-          <a:prstGeom prst="ellipse">
-            <a:avLst/>
-          </a:prstGeom>
-          <a:solidFill>
-            <a:srgbClr val="FFF7ED"/>
-          </a:solidFill>
-          <a:ln w="12700">
-            <a:solidFill>
-              <a:srgbClr val="EA580C"/>
-            </a:solidFill>
-            <a:prstDash val="solid"/>
-          </a:ln>
-        </p:spPr>
-      </p:sp>
-      <p:pic>
-        <p:nvPicPr>
-          <p:cNvPr id="27" name="Image 6" descr="preencoded.png">    </p:cNvPr>
-          <p:cNvPicPr>
-            <a:picLocks noChangeAspect="1"/>
-          </p:cNvPicPr>
-          <p:nvPr/>
-        </p:nvPicPr>
-        <p:blipFill>
-          <a:blip r:embed="rId7"/>
-          <a:stretch>
-            <a:fillRect/>
-          </a:stretch>
-        </p:blipFill>
-        <p:spPr>
-          <a:xfrm>
-            <a:off x="533278" y="5297302"/>
-            <a:ext cx="140452" cy="140452"/>
-          </a:xfrm>
-          <a:prstGeom prst="rect">
-            <a:avLst/>
-          </a:prstGeom>
-        </p:spPr>
-      </p:pic>
-      <p:sp>
-        <p:nvSpPr>
-          <p:cNvPr id="28" name="Text 19"/>
-          <p:cNvSpPr txBox="1"/>
-          <p:nvPr/>
-        </p:nvSpPr>
-        <p:spPr>
-          <a:xfrm>
-            <a:off x="841248" y="5193792"/>
-            <a:ext cx="5102352" cy="502920"/>
-          </a:xfrm>
-          <a:prstGeom prst="rect">
-            <a:avLst/>
-          </a:prstGeom>
-          <a:noFill/>
-          <a:ln/>
-        </p:spPr>
-        <p:txBody>
-          <a:bodyPr wrap="square" lIns="36576" tIns="18288" rIns="36576" bIns="18288" rtlCol="0" anchor="t"/>
-          <a:lstStyle/>
-          <a:p>
-            <a:pPr indent="0" marL="0">
-              <a:buNone/>
-            </a:pPr>
-            <a:pPr indent="0" marL="0">
-              <a:buNone/>
-            </a:pPr>
-            <a:r>
-              <a:rPr sz="1000" b="0">
-                <a:solidFill>
-                  <a:srgbClr val="0F172A"/>
-                </a:solidFill>
-                <a:latin typeface="Calibri"/>
-              </a:rPr>
-              <a:t>Non-Destructive PoCs: 5 automated verification scripts restricted strictly to localhost sandbox; zero damage to production or user data.</a:t>
-            </a:r>
-            <a:endParaRPr lang="en-US" sz="1030" dirty="0"/>
-          </a:p>
-        </p:txBody>
-      </p:sp>
-      <p:sp>
-        <p:nvSpPr>
-          <p:cNvPr id="29" name="Text 20"/>
-          <p:cNvSpPr txBox="1"/>
-          <p:nvPr/>
-        </p:nvSpPr>
-        <p:spPr>
-          <a:xfrm>
-            <a:off x="6263640" y="1207008"/>
-            <a:ext cx="5486400" cy="292608"/>
-          </a:xfrm>
-          <a:prstGeom prst="rect">
-            <a:avLst/>
-          </a:prstGeom>
-          <a:noFill/>
-          <a:ln/>
-        </p:spPr>
-        <p:txBody>
-          <a:bodyPr wrap="square" lIns="36576" tIns="18288" rIns="36576" bIns="18288" rtlCol="0" anchor="ctr"/>
-          <a:lstStyle/>
-          <a:p>
-            <a:pPr indent="0" marL="0">
-              <a:buNone/>
-            </a:pPr>
-            <a:r>
-              <a:rPr sz="1200" b="1">
-                <a:solidFill>
-                  <a:srgbClr val="0F172A"/>
-                </a:solidFill>
-                <a:latin typeface="Calibri"/>
-              </a:rPr>
-              <a:t>Viability :</a:t>
-            </a:r>
-            <a:endParaRPr lang="en-US" sz="1400" dirty="0"/>
-          </a:p>
-        </p:txBody>
-      </p:sp>
-      <p:sp>
-        <p:nvSpPr>
-          <p:cNvPr id="30" name="Shape 21"/>
-          <p:cNvSpPr/>
-          <p:nvPr/>
-        </p:nvSpPr>
-        <p:spPr>
-          <a:xfrm>
-            <a:off x="6263640" y="1572768"/>
-            <a:ext cx="292608" cy="292608"/>
-          </a:xfrm>
-          <a:prstGeom prst="ellipse">
+            <a:off x="457200" y="4251960"/>
+            <a:ext cx="4709160" cy="749808"/>
+          </a:xfrm>
+          <a:prstGeom prst="roundRect">
             <a:avLst/>
           </a:prstGeom>
           <a:solidFill>
@@ -7516,86 +7246,116 @@
             <a:solidFill>
               <a:srgbClr val="BFDBFE"/>
             </a:solidFill>
-            <a:prstDash val="solid"/>
           </a:ln>
         </p:spPr>
-      </p:sp>
-      <p:pic>
-        <p:nvPicPr>
-          <p:cNvPr id="31" name="Image 7" descr="preencoded.png">    </p:cNvPr>
-          <p:cNvPicPr>
-            <a:picLocks noChangeAspect="1"/>
-          </p:cNvPicPr>
-          <p:nvPr/>
-        </p:nvPicPr>
-        <p:blipFill>
-          <a:blip r:embed="rId8"/>
-          <a:stretch>
-            <a:fillRect/>
-          </a:stretch>
-        </p:blipFill>
-        <p:spPr>
-          <a:xfrm>
-            <a:off x="6339718" y="1648846"/>
-            <a:ext cx="140452" cy="140452"/>
-          </a:xfrm>
-          <a:prstGeom prst="rect">
-            <a:avLst/>
-          </a:prstGeom>
-        </p:spPr>
-      </p:pic>
-      <p:sp>
-        <p:nvSpPr>
-          <p:cNvPr id="32" name="Text 22"/>
-          <p:cNvSpPr txBox="1"/>
-          <p:nvPr/>
-        </p:nvSpPr>
-        <p:spPr>
-          <a:xfrm>
-            <a:off x="6647688" y="1545336"/>
-            <a:ext cx="5102352" cy="502920"/>
-          </a:xfrm>
-          <a:prstGeom prst="rect">
-            <a:avLst/>
-          </a:prstGeom>
-          <a:noFill/>
-          <a:ln/>
-        </p:spPr>
-        <p:txBody>
-          <a:bodyPr wrap="square" lIns="36576" tIns="18288" rIns="36576" bIns="18288" rtlCol="0" anchor="t"/>
-          <a:lstStyle/>
-          <a:p>
-            <a:pPr indent="0" marL="0">
-              <a:buNone/>
-            </a:pPr>
-            <a:pPr indent="0" marL="0">
-              <a:buNone/>
-            </a:pPr>
-            <a:r>
-              <a:rPr sz="1000" b="0">
-                <a:solidFill>
-                  <a:srgbClr val="0F172A"/>
-                </a:solidFill>
-                <a:latin typeface="Calibri"/>
-              </a:rPr>
-              <a:t>National Need: Essential for defense agencies (NTRO) evaluating sovereign OSINT dashboards, critical data feeds, and border telemetry.</a:t>
-            </a:r>
-            <a:endParaRPr lang="en-US" sz="1030" dirty="0"/>
-          </a:p>
-        </p:txBody>
-      </p:sp>
-      <p:sp>
-        <p:nvSpPr>
-          <p:cNvPr id="33" name="Shape 23"/>
+        <p:style>
+          <a:lnRef idx="1">
+            <a:schemeClr val="accent1"/>
+          </a:lnRef>
+          <a:fillRef idx="3">
+            <a:schemeClr val="accent1"/>
+          </a:fillRef>
+          <a:effectRef idx="2">
+            <a:schemeClr val="accent1"/>
+          </a:effectRef>
+          <a:fontRef idx="minor">
+            <a:schemeClr val="lt1"/>
+          </a:fontRef>
+        </p:style>
+        <p:txBody>
+          <a:bodyPr rtlCol="0" anchor="ctr" wrap="square" lIns="109728" tIns="54864" bIns="54864"/>
+          <a:lstStyle/>
+          <a:p>
+            <a:pPr algn="ctr"/>
+            <a:r>
+              <a:rPr sz="1050" b="1">
+                <a:solidFill>
+                  <a:srgbClr val="1E3A8A"/>
+                </a:solidFill>
+                <a:latin typeface="Calibri"/>
+              </a:rPr>
+              <a:t>4. Safe Non-Destructive PoC</a:t>
+            </a:r>
+          </a:p>
+          <a:p>
+            <a:r>
+              <a:rPr sz="900" b="0">
+                <a:solidFill>
+                  <a:srgbClr val="0F172A"/>
+                </a:solidFill>
+                <a:latin typeface="Calibri"/>
+              </a:rPr>
+              <a:t>• 5 automated Python / Playwright verification harnesses</a:t>
+            </a:r>
+          </a:p>
+          <a:p>
+            <a:r>
+              <a:rPr sz="900" b="0">
+                <a:solidFill>
+                  <a:srgbClr val="0F172A"/>
+                </a:solidFill>
+                <a:latin typeface="Calibri"/>
+              </a:rPr>
+              <a:t>• Local mock testbeds for rate limits &amp; prompt injection (100% pass)</a:t>
+            </a:r>
+          </a:p>
+        </p:txBody>
+      </p:sp>
+      <p:sp>
+        <p:nvSpPr>
+          <p:cNvPr id="18" name="Down Arrow 17"/>
           <p:cNvSpPr/>
           <p:nvPr/>
         </p:nvSpPr>
         <p:spPr>
           <a:xfrm>
-            <a:off x="6263640" y="2194560"/>
-            <a:ext cx="292608" cy="292608"/>
-          </a:xfrm>
-          <a:prstGeom prst="ellipse">
+            <a:off x="2738628" y="5020056"/>
+            <a:ext cx="146304" cy="128016"/>
+          </a:xfrm>
+          <a:prstGeom prst="downArrow">
+            <a:avLst/>
+          </a:prstGeom>
+          <a:solidFill>
+            <a:srgbClr val="1E3A8A"/>
+          </a:solidFill>
+          <a:ln>
+            <a:noFill/>
+          </a:ln>
+        </p:spPr>
+        <p:style>
+          <a:lnRef idx="1">
+            <a:schemeClr val="accent1"/>
+          </a:lnRef>
+          <a:fillRef idx="3">
+            <a:schemeClr val="accent1"/>
+          </a:fillRef>
+          <a:effectRef idx="2">
+            <a:schemeClr val="accent1"/>
+          </a:effectRef>
+          <a:fontRef idx="minor">
+            <a:schemeClr val="lt1"/>
+          </a:fontRef>
+        </p:style>
+        <p:txBody>
+          <a:bodyPr rtlCol="0" anchor="ctr"/>
+          <a:lstStyle/>
+          <a:p>
+            <a:pPr algn="ctr"/>
+          </a:p>
+        </p:txBody>
+      </p:sp>
+      <p:sp>
+        <p:nvSpPr>
+          <p:cNvPr id="19" name="Rounded Rectangle 18"/>
+          <p:cNvSpPr/>
+          <p:nvPr/>
+        </p:nvSpPr>
+        <p:spPr>
+          <a:xfrm>
+            <a:off x="457200" y="5166360"/>
+            <a:ext cx="4709160" cy="749808"/>
+          </a:xfrm>
+          <a:prstGeom prst="roundRect">
             <a:avLst/>
           </a:prstGeom>
           <a:solidFill>
@@ -7605,212 +7365,73 @@
             <a:solidFill>
               <a:srgbClr val="BFDBFE"/>
             </a:solidFill>
-            <a:prstDash val="solid"/>
           </a:ln>
         </p:spPr>
-      </p:sp>
-      <p:pic>
-        <p:nvPicPr>
-          <p:cNvPr id="34" name="Image 8" descr="preencoded.png">    </p:cNvPr>
-          <p:cNvPicPr>
-            <a:picLocks noChangeAspect="1"/>
-          </p:cNvPicPr>
-          <p:nvPr/>
-        </p:nvPicPr>
-        <p:blipFill>
-          <a:blip r:embed="rId9"/>
-          <a:stretch>
-            <a:fillRect/>
-          </a:stretch>
-        </p:blipFill>
-        <p:spPr>
-          <a:xfrm>
-            <a:off x="6339718" y="2270638"/>
-            <a:ext cx="140452" cy="140452"/>
-          </a:xfrm>
-          <a:prstGeom prst="rect">
-            <a:avLst/>
-          </a:prstGeom>
-        </p:spPr>
-      </p:pic>
-      <p:sp>
-        <p:nvSpPr>
-          <p:cNvPr id="35" name="Text 24"/>
-          <p:cNvSpPr txBox="1"/>
-          <p:nvPr/>
-        </p:nvSpPr>
-        <p:spPr>
-          <a:xfrm>
-            <a:off x="6647688" y="2167128"/>
-            <a:ext cx="5102352" cy="502920"/>
-          </a:xfrm>
-          <a:prstGeom prst="rect">
-            <a:avLst/>
-          </a:prstGeom>
-          <a:noFill/>
-          <a:ln/>
-        </p:spPr>
-        <p:txBody>
-          <a:bodyPr wrap="square" lIns="36576" tIns="18288" rIns="36576" bIns="18288" rtlCol="0" anchor="t"/>
-          <a:lstStyle/>
-          <a:p>
-            <a:pPr indent="0" marL="0">
-              <a:buNone/>
-            </a:pPr>
-            <a:pPr indent="0" marL="0">
-              <a:buNone/>
-            </a:pPr>
-            <a:r>
-              <a:rPr sz="1000" b="0">
-                <a:solidFill>
-                  <a:srgbClr val="0F172A"/>
-                </a:solidFill>
-                <a:latin typeface="Calibri"/>
-              </a:rPr>
-              <a:t>Config-Driven: Declarative YAML target profiles allow the exact same correlation engine to audit any web application or API gateway.</a:t>
-            </a:r>
-            <a:endParaRPr lang="en-US" sz="1030" dirty="0"/>
-          </a:p>
-        </p:txBody>
-      </p:sp>
-      <p:sp>
-        <p:nvSpPr>
-          <p:cNvPr id="36" name="Shape 25"/>
+        <p:style>
+          <a:lnRef idx="1">
+            <a:schemeClr val="accent1"/>
+          </a:lnRef>
+          <a:fillRef idx="3">
+            <a:schemeClr val="accent1"/>
+          </a:fillRef>
+          <a:effectRef idx="2">
+            <a:schemeClr val="accent1"/>
+          </a:effectRef>
+          <a:fontRef idx="minor">
+            <a:schemeClr val="lt1"/>
+          </a:fontRef>
+        </p:style>
+        <p:txBody>
+          <a:bodyPr rtlCol="0" anchor="ctr" wrap="square" lIns="109728" tIns="54864" bIns="54864"/>
+          <a:lstStyle/>
+          <a:p>
+            <a:pPr algn="ctr"/>
+            <a:r>
+              <a:rPr sz="1050" b="1">
+                <a:solidFill>
+                  <a:srgbClr val="1E3A8A"/>
+                </a:solidFill>
+                <a:latin typeface="Calibri"/>
+              </a:rPr>
+              <a:t>5. Hardened Fixes &amp; Delivery</a:t>
+            </a:r>
+          </a:p>
+          <a:p>
+            <a:r>
+              <a:rPr sz="900" b="0">
+                <a:solidFill>
+                  <a:srgbClr val="0F172A"/>
+                </a:solidFill>
+                <a:latin typeface="Calibri"/>
+              </a:rPr>
+              <a:t>• Production code diffs (DOMPurify, fail-closed, socket pinning)</a:t>
+            </a:r>
+          </a:p>
+          <a:p>
+            <a:r>
+              <a:rPr sz="900" b="0">
+                <a:solidFill>
+                  <a:srgbClr val="0F172A"/>
+                </a:solidFill>
+                <a:latin typeface="Calibri"/>
+              </a:rPr>
+              <a:t>• Automated 12-page executive PDF &amp; SARIF report generation</a:t>
+            </a:r>
+          </a:p>
+        </p:txBody>
+      </p:sp>
+      <p:sp>
+        <p:nvSpPr>
+          <p:cNvPr id="20" name="Rounded Rectangle 19"/>
           <p:cNvSpPr/>
           <p:nvPr/>
         </p:nvSpPr>
         <p:spPr>
           <a:xfrm>
-            <a:off x="6263640" y="2816352"/>
-            <a:ext cx="292608" cy="292608"/>
-          </a:xfrm>
-          <a:prstGeom prst="ellipse">
-            <a:avLst/>
-          </a:prstGeom>
-          <a:solidFill>
-            <a:srgbClr val="EFF6FF"/>
-          </a:solidFill>
-          <a:ln w="12700">
-            <a:solidFill>
-              <a:srgbClr val="BFDBFE"/>
-            </a:solidFill>
-            <a:prstDash val="solid"/>
-          </a:ln>
-        </p:spPr>
-      </p:sp>
-      <p:pic>
-        <p:nvPicPr>
-          <p:cNvPr id="37" name="Image 9" descr="preencoded.png">    </p:cNvPr>
-          <p:cNvPicPr>
-            <a:picLocks noChangeAspect="1"/>
-          </p:cNvPicPr>
-          <p:nvPr/>
-        </p:nvPicPr>
-        <p:blipFill>
-          <a:blip r:embed="rId10"/>
-          <a:stretch>
-            <a:fillRect/>
-          </a:stretch>
-        </p:blipFill>
-        <p:spPr>
-          <a:xfrm>
-            <a:off x="6339718" y="2892430"/>
-            <a:ext cx="140452" cy="140452"/>
-          </a:xfrm>
-          <a:prstGeom prst="rect">
-            <a:avLst/>
-          </a:prstGeom>
-        </p:spPr>
-      </p:pic>
-      <p:sp>
-        <p:nvSpPr>
-          <p:cNvPr id="38" name="Text 26"/>
-          <p:cNvSpPr txBox="1"/>
-          <p:nvPr/>
-        </p:nvSpPr>
-        <p:spPr>
-          <a:xfrm>
-            <a:off x="6647688" y="2788920"/>
-            <a:ext cx="5102352" cy="502920"/>
-          </a:xfrm>
-          <a:prstGeom prst="rect">
-            <a:avLst/>
-          </a:prstGeom>
-          <a:noFill/>
-          <a:ln/>
-        </p:spPr>
-        <p:txBody>
-          <a:bodyPr wrap="square" lIns="36576" tIns="18288" rIns="36576" bIns="18288" rtlCol="0" anchor="t"/>
-          <a:lstStyle/>
-          <a:p>
-            <a:pPr indent="0" marL="0">
-              <a:buNone/>
-            </a:pPr>
-            <a:pPr indent="0" marL="0">
-              <a:buNone/>
-            </a:pPr>
-            <a:r>
-              <a:rPr sz="1000" b="0">
-                <a:solidFill>
-                  <a:srgbClr val="0F172A"/>
-                </a:solidFill>
-                <a:latin typeface="Calibri"/>
-              </a:rPr>
-              <a:t>Continuous Posture: ASVS posture diffing tracks security improvement or regression across successive code commits and releases.</a:t>
-            </a:r>
-            <a:endParaRPr lang="en-US" sz="1030" dirty="0"/>
-          </a:p>
-        </p:txBody>
-      </p:sp>
-      <p:sp>
-        <p:nvSpPr>
-          <p:cNvPr id="39" name="Text 27"/>
-          <p:cNvSpPr txBox="1"/>
-          <p:nvPr/>
-        </p:nvSpPr>
-        <p:spPr>
-          <a:xfrm>
-            <a:off x="6263640" y="3611880"/>
-            <a:ext cx="5486400" cy="292608"/>
-          </a:xfrm>
-          <a:prstGeom prst="rect">
-            <a:avLst/>
-          </a:prstGeom>
-          <a:noFill/>
-          <a:ln/>
-        </p:spPr>
-        <p:txBody>
-          <a:bodyPr wrap="square" lIns="36576" tIns="18288" rIns="36576" bIns="18288" rtlCol="0" anchor="ctr"/>
-          <a:lstStyle/>
-          <a:p>
-            <a:pPr indent="0" marL="0">
-              <a:buNone/>
-            </a:pPr>
-            <a:r>
-              <a:rPr sz="1200" b="1">
-                <a:solidFill>
-                  <a:srgbClr val="0F172A"/>
-                </a:solidFill>
-                <a:latin typeface="Calibri"/>
-              </a:rPr>
-              <a:t>Use Cases :</a:t>
-            </a:r>
-            <a:endParaRPr lang="en-US" sz="1400" dirty="0"/>
-          </a:p>
-        </p:txBody>
-      </p:sp>
-      <p:sp>
-        <p:nvSpPr>
-          <p:cNvPr id="40" name="Shape 28"/>
-          <p:cNvSpPr/>
-          <p:nvPr/>
-        </p:nvSpPr>
-        <p:spPr>
-          <a:xfrm>
-            <a:off x="6263640" y="3977640"/>
-            <a:ext cx="292608" cy="292608"/>
-          </a:xfrm>
-          <a:prstGeom prst="ellipse">
+            <a:off x="5440680" y="1508760"/>
+            <a:ext cx="6263640" cy="987552"/>
+          </a:xfrm>
+          <a:prstGeom prst="roundRect">
             <a:avLst/>
           </a:prstGeom>
           <a:solidFill>
@@ -7820,83 +7441,73 @@
             <a:solidFill>
               <a:srgbClr val="E2E8F0"/>
             </a:solidFill>
-            <a:prstDash val="solid"/>
           </a:ln>
         </p:spPr>
-      </p:sp>
-      <p:pic>
-        <p:nvPicPr>
-          <p:cNvPr id="41" name="Image 10" descr="preencoded.png">    </p:cNvPr>
-          <p:cNvPicPr>
-            <a:picLocks noChangeAspect="1"/>
-          </p:cNvPicPr>
-          <p:nvPr/>
-        </p:nvPicPr>
-        <p:blipFill>
-          <a:blip r:embed="rId11"/>
-          <a:stretch>
-            <a:fillRect/>
-          </a:stretch>
-        </p:blipFill>
-        <p:spPr>
-          <a:xfrm>
-            <a:off x="6339718" y="4053718"/>
-            <a:ext cx="140452" cy="140452"/>
-          </a:xfrm>
-          <a:prstGeom prst="rect">
-            <a:avLst/>
-          </a:prstGeom>
-        </p:spPr>
-      </p:pic>
-      <p:sp>
-        <p:nvSpPr>
-          <p:cNvPr id="42" name="Text 29"/>
-          <p:cNvSpPr txBox="1"/>
-          <p:nvPr/>
-        </p:nvSpPr>
-        <p:spPr>
-          <a:xfrm>
-            <a:off x="6647688" y="3950208"/>
-            <a:ext cx="5120640" cy="502920"/>
-          </a:xfrm>
-          <a:prstGeom prst="rect">
-            <a:avLst/>
-          </a:prstGeom>
-          <a:noFill/>
-          <a:ln/>
-        </p:spPr>
-        <p:txBody>
-          <a:bodyPr wrap="square" lIns="36576" tIns="18288" rIns="36576" bIns="18288" rtlCol="0" anchor="t"/>
-          <a:lstStyle/>
-          <a:p>
-            <a:pPr indent="0" marL="0">
-              <a:buNone/>
-            </a:pPr>
-            <a:r>
-              <a:rPr sz="1000" b="0">
-                <a:solidFill>
-                  <a:srgbClr val="0F172A"/>
-                </a:solidFill>
-                <a:latin typeface="Calibri"/>
-              </a:rPr>
-              <a:t>Pre-Release CI/CD Gating: Blocks high-severity vulnerabilities (e.g. fail-open DoS, DOM XSS) before deployment to production.</a:t>
-            </a:r>
-            <a:endParaRPr lang="en-US" sz="1030" dirty="0"/>
-          </a:p>
-        </p:txBody>
-      </p:sp>
-      <p:sp>
-        <p:nvSpPr>
-          <p:cNvPr id="43" name="Shape 30"/>
+        <p:style>
+          <a:lnRef idx="1">
+            <a:schemeClr val="accent1"/>
+          </a:lnRef>
+          <a:fillRef idx="3">
+            <a:schemeClr val="accent1"/>
+          </a:fillRef>
+          <a:effectRef idx="2">
+            <a:schemeClr val="accent1"/>
+          </a:effectRef>
+          <a:fontRef idx="minor">
+            <a:schemeClr val="lt1"/>
+          </a:fontRef>
+        </p:style>
+        <p:txBody>
+          <a:bodyPr rtlCol="0" anchor="ctr" wrap="square" lIns="128016" rIns="109728" tIns="54864" bIns="54864"/>
+          <a:lstStyle/>
+          <a:p>
+            <a:pPr algn="ctr"/>
+            <a:r>
+              <a:rPr sz="1100" b="1">
+                <a:solidFill>
+                  <a:srgbClr val="0F172A"/>
+                </a:solidFill>
+                <a:latin typeface="Calibri"/>
+              </a:rPr>
+              <a:t>Technical Feasibility &amp; Target Access (White-Box Codebase)</a:t>
+            </a:r>
+          </a:p>
+          <a:p>
+            <a:r>
+              <a:rPr sz="950" b="0">
+                <a:solidFill>
+                  <a:srgbClr val="0F172A"/>
+                </a:solidFill>
+                <a:latin typeface="Calibri"/>
+              </a:rPr>
+              <a:t>• Open-Source Architecture: Full white-box access to Next.js, Vite, and Tauri 2.0 Rust codebase eliminates reverse-engineering friction.</a:t>
+            </a:r>
+          </a:p>
+          <a:p>
+            <a:r>
+              <a:rPr sz="950" b="0">
+                <a:solidFill>
+                  <a:srgbClr val="0F172A"/>
+                </a:solidFill>
+                <a:latin typeface="Calibri"/>
+              </a:rPr>
+              <a:t>• Local Sandboxing: Endpoints execute without requiring external cloud accounts (Upstash Redis or Clerk), ensuring 100% repeatable testing.</a:t>
+            </a:r>
+          </a:p>
+        </p:txBody>
+      </p:sp>
+      <p:sp>
+        <p:nvSpPr>
+          <p:cNvPr id="21" name="Rounded Rectangle 20"/>
           <p:cNvSpPr/>
           <p:nvPr/>
         </p:nvSpPr>
         <p:spPr>
           <a:xfrm>
-            <a:off x="6263640" y="4599432"/>
-            <a:ext cx="292608" cy="292608"/>
-          </a:xfrm>
-          <a:prstGeom prst="ellipse">
+            <a:off x="5440680" y="2651760"/>
+            <a:ext cx="6263640" cy="987552"/>
+          </a:xfrm>
+          <a:prstGeom prst="roundRect">
             <a:avLst/>
           </a:prstGeom>
           <a:solidFill>
@@ -7906,83 +7517,73 @@
             <a:solidFill>
               <a:srgbClr val="E2E8F0"/>
             </a:solidFill>
-            <a:prstDash val="solid"/>
           </a:ln>
         </p:spPr>
-      </p:sp>
-      <p:pic>
-        <p:nvPicPr>
-          <p:cNvPr id="44" name="Image 11" descr="preencoded.png">    </p:cNvPr>
-          <p:cNvPicPr>
-            <a:picLocks noChangeAspect="1"/>
-          </p:cNvPicPr>
-          <p:nvPr/>
-        </p:nvPicPr>
-        <p:blipFill>
-          <a:blip r:embed="rId12"/>
-          <a:stretch>
-            <a:fillRect/>
-          </a:stretch>
-        </p:blipFill>
-        <p:spPr>
-          <a:xfrm>
-            <a:off x="6339718" y="4675510"/>
-            <a:ext cx="140452" cy="140452"/>
-          </a:xfrm>
-          <a:prstGeom prst="rect">
-            <a:avLst/>
-          </a:prstGeom>
-        </p:spPr>
-      </p:pic>
-      <p:sp>
-        <p:nvSpPr>
-          <p:cNvPr id="45" name="Text 31"/>
-          <p:cNvSpPr txBox="1"/>
-          <p:nvPr/>
-        </p:nvSpPr>
-        <p:spPr>
-          <a:xfrm>
-            <a:off x="6647688" y="4572000"/>
-            <a:ext cx="5120640" cy="502920"/>
-          </a:xfrm>
-          <a:prstGeom prst="rect">
-            <a:avLst/>
-          </a:prstGeom>
-          <a:noFill/>
-          <a:ln/>
-        </p:spPr>
-        <p:txBody>
-          <a:bodyPr wrap="square" lIns="36576" tIns="18288" rIns="36576" bIns="18288" rtlCol="0" anchor="t"/>
-          <a:lstStyle/>
-          <a:p>
-            <a:pPr indent="0" marL="0">
-              <a:buNone/>
-            </a:pPr>
-            <a:r>
-              <a:rPr sz="1000" b="0">
-                <a:solidFill>
-                  <a:srgbClr val="0F172A"/>
-                </a:solidFill>
-                <a:latin typeface="Calibri"/>
-              </a:rPr>
-              <a:t>Actionable Remediation: Provides engineers with copy-ready code diffs (DOMPurify sanitization, Node socket pinning, XML prompt wrapping).</a:t>
-            </a:r>
-            <a:endParaRPr lang="en-US" sz="1030" dirty="0"/>
-          </a:p>
-        </p:txBody>
-      </p:sp>
-      <p:sp>
-        <p:nvSpPr>
-          <p:cNvPr id="46" name="Shape 32"/>
+        <p:style>
+          <a:lnRef idx="1">
+            <a:schemeClr val="accent1"/>
+          </a:lnRef>
+          <a:fillRef idx="3">
+            <a:schemeClr val="accent1"/>
+          </a:fillRef>
+          <a:effectRef idx="2">
+            <a:schemeClr val="accent1"/>
+          </a:effectRef>
+          <a:fontRef idx="minor">
+            <a:schemeClr val="lt1"/>
+          </a:fontRef>
+        </p:style>
+        <p:txBody>
+          <a:bodyPr rtlCol="0" anchor="ctr" wrap="square" lIns="128016" rIns="109728" tIns="54864" bIns="54864"/>
+          <a:lstStyle/>
+          <a:p>
+            <a:pPr algn="ctr"/>
+            <a:r>
+              <a:rPr sz="1100" b="1">
+                <a:solidFill>
+                  <a:srgbClr val="0F172A"/>
+                </a:solidFill>
+                <a:latin typeface="Calibri"/>
+              </a:rPr>
+              <a:t>Operational &amp; Economic Viability ($0 Tooling Expenditure)</a:t>
+            </a:r>
+          </a:p>
+          <a:p>
+            <a:r>
+              <a:rPr sz="950" b="0">
+                <a:solidFill>
+                  <a:srgbClr val="0F172A"/>
+                </a:solidFill>
+                <a:latin typeface="Calibri"/>
+              </a:rPr>
+              <a:t>• Zero License Fees: Powered entirely by open-source tools (Semgrep, Python 3.14, Playwright, ReportLab), saving thousands in commercial pentest costs.</a:t>
+            </a:r>
+          </a:p>
+          <a:p>
+            <a:r>
+              <a:rPr sz="950" b="0">
+                <a:solidFill>
+                  <a:srgbClr val="0F172A"/>
+                </a:solidFill>
+                <a:latin typeface="Calibri"/>
+              </a:rPr>
+              <a:t>• Turnkey Reproducibility: Automated single-command CLI execution reproduces the complete end-to-end audit in under 60 seconds.</a:t>
+            </a:r>
+          </a:p>
+        </p:txBody>
+      </p:sp>
+      <p:sp>
+        <p:nvSpPr>
+          <p:cNvPr id="22" name="Rounded Rectangle 21"/>
           <p:cNvSpPr/>
           <p:nvPr/>
         </p:nvSpPr>
         <p:spPr>
           <a:xfrm>
-            <a:off x="6263640" y="5221224"/>
-            <a:ext cx="292608" cy="292608"/>
-          </a:xfrm>
-          <a:prstGeom prst="ellipse">
+            <a:off x="5440680" y="3794760"/>
+            <a:ext cx="6263640" cy="987552"/>
+          </a:xfrm>
+          <a:prstGeom prst="roundRect">
             <a:avLst/>
           </a:prstGeom>
           <a:solidFill>
@@ -7992,415 +7593,134 @@
             <a:solidFill>
               <a:srgbClr val="E2E8F0"/>
             </a:solidFill>
-            <a:prstDash val="solid"/>
           </a:ln>
         </p:spPr>
-      </p:sp>
-      <p:pic>
-        <p:nvPicPr>
-          <p:cNvPr id="47" name="Image 12" descr="preencoded.png">    </p:cNvPr>
-          <p:cNvPicPr>
-            <a:picLocks noChangeAspect="1"/>
-          </p:cNvPicPr>
-          <p:nvPr/>
-        </p:nvPicPr>
-        <p:blipFill>
-          <a:blip r:embed="rId13"/>
-          <a:stretch>
-            <a:fillRect/>
-          </a:stretch>
-        </p:blipFill>
-        <p:spPr>
-          <a:xfrm>
-            <a:off x="6339718" y="5297302"/>
-            <a:ext cx="140452" cy="140452"/>
-          </a:xfrm>
-          <a:prstGeom prst="rect">
-            <a:avLst/>
-          </a:prstGeom>
-        </p:spPr>
-      </p:pic>
-      <p:sp>
-        <p:nvSpPr>
-          <p:cNvPr id="48" name="Text 33"/>
-          <p:cNvSpPr txBox="1"/>
-          <p:nvPr/>
-        </p:nvSpPr>
-        <p:spPr>
-          <a:xfrm>
-            <a:off x="6647688" y="5193792"/>
-            <a:ext cx="5120640" cy="502920"/>
-          </a:xfrm>
-          <a:prstGeom prst="rect">
-            <a:avLst/>
-          </a:prstGeom>
-          <a:noFill/>
-          <a:ln/>
-        </p:spPr>
-        <p:txBody>
-          <a:bodyPr wrap="square" lIns="36576" tIns="18288" rIns="36576" bIns="18288" rtlCol="0" anchor="t"/>
-          <a:lstStyle/>
-          <a:p>
-            <a:pPr indent="0" marL="0">
-              <a:buNone/>
-            </a:pPr>
-            <a:r>
-              <a:rPr sz="1000" b="0">
-                <a:solidFill>
-                  <a:srgbClr val="0F172A"/>
-                </a:solidFill>
-                <a:latin typeface="Calibri"/>
-              </a:rPr>
-              <a:t>Automated Compliance Auditing: Real-time mapping against OWASP Top 10 (2021), OWASP LLM Top 10, CWE Top 25, and CVSS v3.1.</a:t>
-            </a:r>
-            <a:endParaRPr lang="en-US" sz="1030" dirty="0"/>
-          </a:p>
-        </p:txBody>
-      </p:sp>
-      <p:sp>
-        <p:nvSpPr>
-          <p:cNvPr id="49" name="Text 34"/>
-          <p:cNvSpPr txBox="1"/>
-          <p:nvPr/>
-        </p:nvSpPr>
-        <p:spPr>
-          <a:xfrm>
-            <a:off x="457200" y="5532120"/>
-            <a:ext cx="9144000" cy="292608"/>
-          </a:xfrm>
-          <a:prstGeom prst="rect">
-            <a:avLst/>
-          </a:prstGeom>
-          <a:noFill/>
-          <a:ln/>
-        </p:spPr>
-        <p:txBody>
-          <a:bodyPr wrap="square" lIns="36576" tIns="18288" rIns="36576" bIns="18288" rtlCol="0" anchor="ctr"/>
-          <a:lstStyle/>
-          <a:p>
-            <a:pPr indent="0" marL="0">
-              <a:buNone/>
-            </a:pPr>
-            <a:r>
-              <a:rPr sz="1200" b="1">
-                <a:solidFill>
-                  <a:srgbClr val="0F172A"/>
-                </a:solidFill>
-                <a:latin typeface="Calibri"/>
-              </a:rPr>
-              <a:t>Build Roadmap :</a:t>
-            </a:r>
-            <a:endParaRPr lang="en-US" sz="1400" dirty="0"/>
-          </a:p>
-        </p:txBody>
-      </p:sp>
-      <p:sp>
-        <p:nvSpPr>
-          <p:cNvPr id="50" name="Shape 35"/>
+        <p:style>
+          <a:lnRef idx="1">
+            <a:schemeClr val="accent1"/>
+          </a:lnRef>
+          <a:fillRef idx="3">
+            <a:schemeClr val="accent1"/>
+          </a:fillRef>
+          <a:effectRef idx="2">
+            <a:schemeClr val="accent1"/>
+          </a:effectRef>
+          <a:fontRef idx="minor">
+            <a:schemeClr val="lt1"/>
+          </a:fontRef>
+        </p:style>
+        <p:txBody>
+          <a:bodyPr rtlCol="0" anchor="ctr" wrap="square" lIns="128016" rIns="109728" tIns="54864" bIns="54864"/>
+          <a:lstStyle/>
+          <a:p>
+            <a:pPr algn="ctr"/>
+            <a:r>
+              <a:rPr sz="1100" b="1">
+                <a:solidFill>
+                  <a:srgbClr val="0F172A"/>
+                </a:solidFill>
+                <a:latin typeface="Calibri"/>
+              </a:rPr>
+              <a:t>Challenge &amp; Risk Mitigation Strategy (Noise Elimination)</a:t>
+            </a:r>
+          </a:p>
+          <a:p>
+            <a:r>
+              <a:rPr sz="950" b="0">
+                <a:solidFill>
+                  <a:srgbClr val="0F172A"/>
+                </a:solidFill>
+                <a:latin typeface="Calibri"/>
+              </a:rPr>
+              <a:t>• Alert Fatigue Suppression: Two-signal cross-confirmation gate ensures zero false positives reach the Proof-of-Concept verification phase.</a:t>
+            </a:r>
+          </a:p>
+          <a:p>
+            <a:r>
+              <a:rPr sz="950" b="0">
+                <a:solidFill>
+                  <a:srgbClr val="0F172A"/>
+                </a:solidFill>
+                <a:latin typeface="Calibri"/>
+              </a:rPr>
+              <a:t>• Non-Destructive Integrity: Rate-limiting and prompt injection tests run against local mock harnesses with zero impact on production data.</a:t>
+            </a:r>
+          </a:p>
+        </p:txBody>
+      </p:sp>
+      <p:sp>
+        <p:nvSpPr>
+          <p:cNvPr id="23" name="Rounded Rectangle 22"/>
           <p:cNvSpPr/>
           <p:nvPr/>
         </p:nvSpPr>
         <p:spPr>
           <a:xfrm>
-            <a:off x="457200" y="5870448"/>
-            <a:ext cx="2139696" cy="420624"/>
-          </a:xfrm>
-          <a:prstGeom prst="chevron">
+            <a:off x="5440680" y="4937760"/>
+            <a:ext cx="6263640" cy="987552"/>
+          </a:xfrm>
+          <a:prstGeom prst="roundRect">
             <a:avLst/>
           </a:prstGeom>
           <a:solidFill>
-            <a:srgbClr val="EFF6FF"/>
+            <a:srgbClr val="F8FAFC"/>
           </a:solidFill>
           <a:ln w="12700">
             <a:solidFill>
-              <a:srgbClr val="BFDBFE"/>
+              <a:srgbClr val="E2E8F0"/>
             </a:solidFill>
-            <a:prstDash val="solid"/>
           </a:ln>
         </p:spPr>
-      </p:sp>
-      <p:sp>
-        <p:nvSpPr>
-          <p:cNvPr id="51" name="Text 36"/>
-          <p:cNvSpPr txBox="1"/>
-          <p:nvPr/>
-        </p:nvSpPr>
-        <p:spPr>
-          <a:xfrm>
-            <a:off x="841248" y="5870448"/>
-            <a:ext cx="1636776" cy="420624"/>
-          </a:xfrm>
-          <a:prstGeom prst="rect">
-            <a:avLst/>
-          </a:prstGeom>
-          <a:noFill/>
-          <a:ln/>
-        </p:spPr>
-        <p:txBody>
-          <a:bodyPr wrap="square" lIns="36576" tIns="18288" rIns="36576" bIns="18288" rtlCol="0" anchor="ctr"/>
-          <a:lstStyle/>
-          <a:p>
-            <a:pPr algn="ctr" indent="0" marL="0">
-              <a:buNone/>
-            </a:pPr>
-            <a:r>
-              <a:rPr sz="1050" b="1">
-                <a:solidFill>
-                  <a:srgbClr val="0F172A"/>
-                </a:solidFill>
-                <a:latin typeface="Calibri"/>
-              </a:rPr>
-              <a:t>1. Recon &amp; Surface Mapping</a:t>
-            </a:r>
-            <a:endParaRPr lang="en-US" sz="900" dirty="0"/>
-          </a:p>
-        </p:txBody>
-      </p:sp>
-      <p:sp>
-        <p:nvSpPr>
-          <p:cNvPr id="52" name="Shape 37"/>
-          <p:cNvSpPr/>
-          <p:nvPr/>
-        </p:nvSpPr>
-        <p:spPr>
-          <a:xfrm>
-            <a:off x="2651760" y="5870448"/>
-            <a:ext cx="2139696" cy="420624"/>
-          </a:xfrm>
-          <a:prstGeom prst="chevron">
-            <a:avLst/>
-          </a:prstGeom>
-          <a:solidFill>
-            <a:srgbClr val="EFF6FF"/>
-          </a:solidFill>
-          <a:ln w="12700">
-            <a:solidFill>
-              <a:srgbClr val="BFDBFE"/>
-            </a:solidFill>
-            <a:prstDash val="solid"/>
-          </a:ln>
-        </p:spPr>
-      </p:sp>
-      <p:sp>
-        <p:nvSpPr>
-          <p:cNvPr id="53" name="Text 38"/>
-          <p:cNvSpPr txBox="1"/>
-          <p:nvPr/>
-        </p:nvSpPr>
-        <p:spPr>
-          <a:xfrm>
-            <a:off x="3035808" y="5870448"/>
-            <a:ext cx="1636776" cy="420624"/>
-          </a:xfrm>
-          <a:prstGeom prst="rect">
-            <a:avLst/>
-          </a:prstGeom>
-          <a:noFill/>
-          <a:ln/>
-        </p:spPr>
-        <p:txBody>
-          <a:bodyPr wrap="square" lIns="36576" tIns="18288" rIns="36576" bIns="18288" rtlCol="0" anchor="ctr"/>
-          <a:lstStyle/>
-          <a:p>
-            <a:pPr algn="ctr" indent="0" marL="0">
-              <a:buNone/>
-            </a:pPr>
-            <a:r>
-              <a:rPr sz="1050" b="1">
-                <a:solidFill>
-                  <a:srgbClr val="0F172A"/>
-                </a:solidFill>
-                <a:latin typeface="Calibri"/>
-              </a:rPr>
-              <a:t>2. Multi-Engine Scans</a:t>
-            </a:r>
-            <a:endParaRPr lang="en-US" sz="900" dirty="0"/>
-          </a:p>
-        </p:txBody>
-      </p:sp>
-      <p:sp>
-        <p:nvSpPr>
-          <p:cNvPr id="54" name="Shape 39"/>
-          <p:cNvSpPr/>
-          <p:nvPr/>
-        </p:nvSpPr>
-        <p:spPr>
-          <a:xfrm>
-            <a:off x="4846320" y="5870448"/>
-            <a:ext cx="2139696" cy="420624"/>
-          </a:xfrm>
-          <a:prstGeom prst="chevron">
-            <a:avLst/>
-          </a:prstGeom>
-          <a:solidFill>
-            <a:srgbClr val="EFF6FF"/>
-          </a:solidFill>
-          <a:ln w="12700">
-            <a:solidFill>
-              <a:srgbClr val="BFDBFE"/>
-            </a:solidFill>
-            <a:prstDash val="solid"/>
-          </a:ln>
-        </p:spPr>
-      </p:sp>
-      <p:sp>
-        <p:nvSpPr>
-          <p:cNvPr id="55" name="Text 40"/>
-          <p:cNvSpPr txBox="1"/>
-          <p:nvPr/>
-        </p:nvSpPr>
-        <p:spPr>
-          <a:xfrm>
-            <a:off x="5230368" y="5870448"/>
-            <a:ext cx="1636776" cy="420624"/>
-          </a:xfrm>
-          <a:prstGeom prst="rect">
-            <a:avLst/>
-          </a:prstGeom>
-          <a:noFill/>
-          <a:ln/>
-        </p:spPr>
-        <p:txBody>
-          <a:bodyPr wrap="square" lIns="36576" tIns="18288" rIns="36576" bIns="18288" rtlCol="0" anchor="ctr"/>
-          <a:lstStyle/>
-          <a:p>
-            <a:pPr algn="ctr" indent="0" marL="0">
-              <a:buNone/>
-            </a:pPr>
-            <a:r>
-              <a:rPr sz="1050" b="1">
-                <a:solidFill>
-                  <a:srgbClr val="0F172A"/>
-                </a:solidFill>
-                <a:latin typeface="Calibri"/>
-              </a:rPr>
-              <a:t>3. Correlation &amp; CVSS 3.1</a:t>
-            </a:r>
-            <a:endParaRPr lang="en-US" sz="900" dirty="0"/>
-          </a:p>
-        </p:txBody>
-      </p:sp>
-      <p:sp>
-        <p:nvSpPr>
-          <p:cNvPr id="56" name="Shape 41"/>
-          <p:cNvSpPr/>
-          <p:nvPr/>
-        </p:nvSpPr>
-        <p:spPr>
-          <a:xfrm>
-            <a:off x="7040880" y="5870448"/>
-            <a:ext cx="2139696" cy="420624"/>
-          </a:xfrm>
-          <a:prstGeom prst="chevron">
-            <a:avLst/>
-          </a:prstGeom>
-          <a:solidFill>
-            <a:srgbClr val="EFF6FF"/>
-          </a:solidFill>
-          <a:ln w="12700">
-            <a:solidFill>
-              <a:srgbClr val="BFDBFE"/>
-            </a:solidFill>
-            <a:prstDash val="solid"/>
-          </a:ln>
-        </p:spPr>
-      </p:sp>
-      <p:sp>
-        <p:nvSpPr>
-          <p:cNvPr id="57" name="Text 42"/>
-          <p:cNvSpPr txBox="1"/>
-          <p:nvPr/>
-        </p:nvSpPr>
-        <p:spPr>
-          <a:xfrm>
-            <a:off x="7424928" y="5870448"/>
-            <a:ext cx="1636776" cy="420624"/>
-          </a:xfrm>
-          <a:prstGeom prst="rect">
-            <a:avLst/>
-          </a:prstGeom>
-          <a:noFill/>
-          <a:ln/>
-        </p:spPr>
-        <p:txBody>
-          <a:bodyPr wrap="square" lIns="36576" tIns="18288" rIns="36576" bIns="18288" rtlCol="0" anchor="ctr"/>
-          <a:lstStyle/>
-          <a:p>
-            <a:pPr algn="ctr" indent="0" marL="0">
-              <a:buNone/>
-            </a:pPr>
-            <a:r>
-              <a:rPr sz="1050" b="1">
-                <a:solidFill>
-                  <a:srgbClr val="0F172A"/>
-                </a:solidFill>
-                <a:latin typeface="Calibri"/>
-              </a:rPr>
-              <a:t>4. Safe PoC Execution</a:t>
-            </a:r>
-            <a:endParaRPr lang="en-US" sz="900" dirty="0"/>
-          </a:p>
-        </p:txBody>
-      </p:sp>
-      <p:sp>
-        <p:nvSpPr>
-          <p:cNvPr id="58" name="Shape 43"/>
-          <p:cNvSpPr/>
-          <p:nvPr/>
-        </p:nvSpPr>
-        <p:spPr>
-          <a:xfrm>
-            <a:off x="9235440" y="5870448"/>
-            <a:ext cx="2139696" cy="420624"/>
-          </a:xfrm>
-          <a:prstGeom prst="chevron">
-            <a:avLst/>
-          </a:prstGeom>
-          <a:solidFill>
-            <a:srgbClr val="EFF6FF"/>
-          </a:solidFill>
-          <a:ln w="12700">
-            <a:solidFill>
-              <a:srgbClr val="BFDBFE"/>
-            </a:solidFill>
-            <a:prstDash val="solid"/>
-          </a:ln>
-        </p:spPr>
-      </p:sp>
-      <p:sp>
-        <p:nvSpPr>
-          <p:cNvPr id="59" name="Text 44"/>
-          <p:cNvSpPr txBox="1"/>
-          <p:nvPr/>
-        </p:nvSpPr>
-        <p:spPr>
-          <a:xfrm>
-            <a:off x="9619488" y="5870448"/>
-            <a:ext cx="1636776" cy="420624"/>
-          </a:xfrm>
-          <a:prstGeom prst="rect">
-            <a:avLst/>
-          </a:prstGeom>
-          <a:noFill/>
-          <a:ln/>
-        </p:spPr>
-        <p:txBody>
-          <a:bodyPr wrap="square" lIns="36576" tIns="18288" rIns="36576" bIns="18288" rtlCol="0" anchor="ctr"/>
-          <a:lstStyle/>
-          <a:p>
-            <a:pPr algn="ctr" indent="0" marL="0">
-              <a:buNone/>
-            </a:pPr>
-            <a:r>
-              <a:rPr sz="1050" b="1">
-                <a:solidFill>
-                  <a:srgbClr val="0F172A"/>
-                </a:solidFill>
-                <a:latin typeface="Calibri"/>
-              </a:rPr>
-              <a:t>5. Executive Audit Delivery</a:t>
-            </a:r>
-            <a:endParaRPr lang="en-US" sz="900" dirty="0"/>
+        <p:style>
+          <a:lnRef idx="1">
+            <a:schemeClr val="accent1"/>
+          </a:lnRef>
+          <a:fillRef idx="3">
+            <a:schemeClr val="accent1"/>
+          </a:fillRef>
+          <a:effectRef idx="2">
+            <a:schemeClr val="accent1"/>
+          </a:effectRef>
+          <a:fontRef idx="minor">
+            <a:schemeClr val="lt1"/>
+          </a:fontRef>
+        </p:style>
+        <p:txBody>
+          <a:bodyPr rtlCol="0" anchor="ctr" wrap="square" lIns="128016" rIns="109728" tIns="54864" bIns="54864"/>
+          <a:lstStyle/>
+          <a:p>
+            <a:pPr algn="ctr"/>
+            <a:r>
+              <a:rPr sz="1100" b="1">
+                <a:solidFill>
+                  <a:srgbClr val="0F172A"/>
+                </a:solidFill>
+                <a:latin typeface="Calibri"/>
+              </a:rPr>
+              <a:t>Strategic Impact &amp; Government Scalability (NTRO Sovereign Mission)</a:t>
+            </a:r>
+          </a:p>
+          <a:p>
+            <a:r>
+              <a:rPr sz="950" b="0">
+                <a:solidFill>
+                  <a:srgbClr val="0F172A"/>
+                </a:solidFill>
+                <a:latin typeface="Calibri"/>
+              </a:rPr>
+              <a:t>• Sovereign Mission Alignment: Directly empowers NTRO with a reusable audit framework for national security OSINT tools and border telemetry.</a:t>
+            </a:r>
+          </a:p>
+          <a:p>
+            <a:r>
+              <a:rPr sz="950" b="0">
+                <a:solidFill>
+                  <a:srgbClr val="0F172A"/>
+                </a:solidFill>
+                <a:latin typeface="Calibri"/>
+              </a:rPr>
+              <a:t>• Multi-Target Reusability: Declarative YAML target profiles enable the correlation engine to audit any web application or microservice.</a:t>
+            </a:r>
           </a:p>
         </p:txBody>
       </p:sp>

</xml_diff>

<commit_message>
style: apply rich reference image solid background box colors and high-contrast typography across all slides
</commit_message>
<xml_diff>
--- a/SIH26163_ARGUS_Idea_PPT_Color.pptx
+++ b/SIH26163_ARGUS_Idea_PPT_Color.pptx
@@ -1487,12 +1487,10 @@
             <a:avLst/>
           </a:prstGeom>
           <a:solidFill>
-            <a:srgbClr val="1E3A8A"/>
+            <a:srgbClr val="1B365D"/>
           </a:solidFill>
           <a:ln w="12700">
-            <a:solidFill>
-              <a:srgbClr val="1B5FAE"/>
-            </a:solidFill>
+            <a:noFill/>
             <a:prstDash val="solid"/>
           </a:ln>
         </p:spPr>
@@ -1614,12 +1612,10 @@
             <a:avLst/>
           </a:prstGeom>
           <a:solidFill>
-            <a:srgbClr val="EFF6FF"/>
+            <a:srgbClr val="1E7E34"/>
           </a:solidFill>
           <a:ln w="12700">
-            <a:solidFill>
-              <a:srgbClr val="BFDBFE"/>
-            </a:solidFill>
+            <a:noFill/>
             <a:prstDash val="solid"/>
           </a:ln>
         </p:spPr>
@@ -1679,12 +1675,10 @@
             <a:avLst/>
           </a:prstGeom>
           <a:solidFill>
-            <a:srgbClr val="EFF6FF"/>
+            <a:srgbClr val="C05621"/>
           </a:solidFill>
           <a:ln w="12700">
-            <a:solidFill>
-              <a:srgbClr val="BFDBFE"/>
-            </a:solidFill>
+            <a:noFill/>
             <a:prstDash val="solid"/>
           </a:ln>
         </p:spPr>
@@ -1744,12 +1738,10 @@
             <a:avLst/>
           </a:prstGeom>
           <a:solidFill>
-            <a:srgbClr val="EFF6FF"/>
+            <a:srgbClr val="5A378C"/>
           </a:solidFill>
           <a:ln w="12700">
-            <a:solidFill>
-              <a:srgbClr val="BFDBFE"/>
-            </a:solidFill>
+            <a:noFill/>
             <a:prstDash val="solid"/>
           </a:ln>
         </p:spPr>
@@ -1809,12 +1801,10 @@
             <a:avLst/>
           </a:prstGeom>
           <a:solidFill>
-            <a:srgbClr val="EFF6FF"/>
+            <a:srgbClr val="1B365D"/>
           </a:solidFill>
           <a:ln w="12700">
-            <a:solidFill>
-              <a:srgbClr val="BFDBFE"/>
-            </a:solidFill>
+            <a:noFill/>
             <a:prstDash val="solid"/>
           </a:ln>
         </p:spPr>
@@ -1874,12 +1864,10 @@
             <a:avLst/>
           </a:prstGeom>
           <a:solidFill>
-            <a:srgbClr val="EFF6FF"/>
+            <a:srgbClr val="8C2D19"/>
           </a:solidFill>
           <a:ln w="12700">
-            <a:solidFill>
-              <a:srgbClr val="BFDBFE"/>
-            </a:solidFill>
+            <a:noFill/>
             <a:prstDash val="solid"/>
           </a:ln>
         </p:spPr>
@@ -1963,11 +1951,11 @@
             <a:avLst/>
           </a:prstGeom>
           <a:solidFill>
-            <a:srgbClr val="EFF6FF"/>
+            <a:srgbClr val="1B365D"/>
           </a:solidFill>
           <a:ln w="19050">
             <a:solidFill>
-              <a:srgbClr val="1E3A8A"/>
+              <a:srgbClr val="1B4965"/>
             </a:solidFill>
             <a:prstDash val="solid"/>
           </a:ln>
@@ -2003,7 +1991,7 @@
             <a:r>
               <a:rPr b="1" sz="1300">
                 <a:solidFill>
-                  <a:srgbClr val="0F172A"/>
+                  <a:srgbClr val="FFFFFF"/>
                 </a:solidFill>
                 <a:latin typeface="Calibri"/>
               </a:rPr>
@@ -2016,7 +2004,7 @@
             <a:r>
               <a:rPr b="0" sz="1050">
                 <a:solidFill>
-                  <a:srgbClr val="1E3A8A"/>
+                  <a:srgbClr val="DBEAFE"/>
                 </a:solidFill>
                 <a:latin typeface="Calibri"/>
               </a:rPr>
@@ -2074,13 +2062,21 @@
           <a:solidFill>
             <a:srgbClr val="FFFFFF"/>
           </a:solidFill>
-          <a:ln w="15875">
+          <a:ln w="19050">
             <a:solidFill>
-              <a:srgbClr val="000000"/>
+              <a:srgbClr val="5A378C"/>
             </a:solidFill>
             <a:prstDash val="solid"/>
           </a:ln>
         </p:spPr>
+        <p:txBody>
+          <a:bodyPr/>
+          <a:p>
+            <a:pPr>
+              <a:defRPr b="1"/>
+            </a:pPr>
+          </a:p>
+        </p:txBody>
       </p:sp>
       <p:sp>
         <p:nvSpPr>
@@ -2417,9 +2413,9 @@
           <a:solidFill>
             <a:srgbClr val="F8FAFC"/>
           </a:solidFill>
-          <a:ln w="12700">
+          <a:ln w="19050">
             <a:solidFill>
-              <a:srgbClr val="E2E8F0"/>
+              <a:srgbClr val="1B365D"/>
             </a:solidFill>
             <a:prstDash val="solid"/>
           </a:ln>
@@ -2594,12 +2590,10 @@
             </a:avLst>
           </a:prstGeom>
           <a:solidFill>
-            <a:srgbClr val="EFF6FF"/>
+            <a:srgbClr val="1B4965"/>
           </a:solidFill>
           <a:ln w="12700">
-            <a:solidFill>
-              <a:srgbClr val="BFDBFE"/>
-            </a:solidFill>
+            <a:noFill/>
             <a:prstDash val="solid"/>
           </a:ln>
         </p:spPr>
@@ -2619,12 +2613,10 @@
             <a:avLst/>
           </a:prstGeom>
           <a:solidFill>
-            <a:srgbClr val="FFFFFF"/>
+            <a:srgbClr val="14374C"/>
           </a:solidFill>
           <a:ln w="12700">
-            <a:solidFill>
-              <a:srgbClr val="FFFFFF"/>
-            </a:solidFill>
+            <a:noFill/>
             <a:prstDash val="solid"/>
           </a:ln>
         </p:spPr>
@@ -2676,11 +2668,12 @@
           <a:p>
             <a:pPr indent="0" marL="0">
               <a:buNone/>
+              <a:defRPr b="1"/>
             </a:pPr>
             <a:r>
               <a:rPr sz="1100" b="1">
                 <a:solidFill>
-                  <a:srgbClr val="1E3A8A"/>
+                  <a:srgbClr val="FFFFFF"/>
                 </a:solidFill>
                 <a:latin typeface="Calibri"/>
               </a:rPr>
@@ -2717,7 +2710,7 @@
             <a:r>
               <a:rPr sz="1000" b="0">
                 <a:solidFill>
-                  <a:srgbClr val="0F172A"/>
+                  <a:srgbClr val="FFFFFF"/>
                 </a:solidFill>
                 <a:latin typeface="Calibri"/>
               </a:rPr>
@@ -2742,9 +2735,9 @@
             <a:avLst/>
           </a:prstGeom>
           <a:noFill/>
-          <a:ln w="22225">
+          <a:ln w="25400">
             <a:solidFill>
-              <a:srgbClr val="5B6472"/>
+              <a:srgbClr val="1B365D"/>
             </a:solidFill>
             <a:prstDash val="solid"/>
             <a:tailEnd type="triangle"/>
@@ -2768,12 +2761,10 @@
             </a:avLst>
           </a:prstGeom>
           <a:solidFill>
-            <a:srgbClr val="EFF6FF"/>
+            <a:srgbClr val="C05621"/>
           </a:solidFill>
           <a:ln w="12700">
-            <a:solidFill>
-              <a:srgbClr val="BFDBFE"/>
-            </a:solidFill>
+            <a:noFill/>
             <a:prstDash val="solid"/>
           </a:ln>
         </p:spPr>
@@ -2793,12 +2784,10 @@
             <a:avLst/>
           </a:prstGeom>
           <a:solidFill>
-            <a:srgbClr val="FFFFFF"/>
+            <a:srgbClr val="9C4418"/>
           </a:solidFill>
           <a:ln w="12700">
-            <a:solidFill>
-              <a:srgbClr val="FFFFFF"/>
-            </a:solidFill>
+            <a:noFill/>
             <a:prstDash val="solid"/>
           </a:ln>
         </p:spPr>
@@ -2850,11 +2839,12 @@
           <a:p>
             <a:pPr indent="0" marL="0">
               <a:buNone/>
+              <a:defRPr b="1"/>
             </a:pPr>
             <a:r>
               <a:rPr sz="1100" b="1">
                 <a:solidFill>
-                  <a:srgbClr val="1E3A8A"/>
+                  <a:srgbClr val="FFFFFF"/>
                 </a:solidFill>
                 <a:latin typeface="Calibri"/>
               </a:rPr>
@@ -2891,7 +2881,7 @@
             <a:r>
               <a:rPr sz="1000" b="0">
                 <a:solidFill>
-                  <a:srgbClr val="0F172A"/>
+                  <a:srgbClr val="FFFFFF"/>
                 </a:solidFill>
                 <a:latin typeface="Calibri"/>
               </a:rPr>
@@ -2916,9 +2906,9 @@
             <a:avLst/>
           </a:prstGeom>
           <a:noFill/>
-          <a:ln w="22225">
+          <a:ln w="25400">
             <a:solidFill>
-              <a:srgbClr val="5B6472"/>
+              <a:srgbClr val="1B365D"/>
             </a:solidFill>
             <a:prstDash val="solid"/>
             <a:tailEnd type="triangle"/>
@@ -2942,12 +2932,10 @@
             </a:avLst>
           </a:prstGeom>
           <a:solidFill>
-            <a:srgbClr val="EFF6FF"/>
+            <a:srgbClr val="1E7E34"/>
           </a:solidFill>
           <a:ln w="12700">
-            <a:solidFill>
-              <a:srgbClr val="BFDBFE"/>
-            </a:solidFill>
+            <a:noFill/>
             <a:prstDash val="solid"/>
           </a:ln>
         </p:spPr>
@@ -2967,12 +2955,10 @@
             <a:avLst/>
           </a:prstGeom>
           <a:solidFill>
-            <a:srgbClr val="FFFFFF"/>
+            <a:srgbClr val="165E26"/>
           </a:solidFill>
           <a:ln w="12700">
-            <a:solidFill>
-              <a:srgbClr val="FFFFFF"/>
-            </a:solidFill>
+            <a:noFill/>
             <a:prstDash val="solid"/>
           </a:ln>
         </p:spPr>
@@ -3024,11 +3010,12 @@
           <a:p>
             <a:pPr indent="0" marL="0">
               <a:buNone/>
+              <a:defRPr b="1"/>
             </a:pPr>
             <a:r>
               <a:rPr sz="1100" b="1">
                 <a:solidFill>
-                  <a:srgbClr val="1E3A8A"/>
+                  <a:srgbClr val="FFFFFF"/>
                 </a:solidFill>
                 <a:latin typeface="Calibri"/>
               </a:rPr>
@@ -3065,7 +3052,7 @@
             <a:r>
               <a:rPr sz="1000" b="0">
                 <a:solidFill>
-                  <a:srgbClr val="0F172A"/>
+                  <a:srgbClr val="FFFFFF"/>
                 </a:solidFill>
                 <a:latin typeface="Calibri"/>
               </a:rPr>
@@ -3090,9 +3077,9 @@
             <a:avLst/>
           </a:prstGeom>
           <a:noFill/>
-          <a:ln w="22225">
+          <a:ln w="25400">
             <a:solidFill>
-              <a:srgbClr val="5B6472"/>
+              <a:srgbClr val="1B365D"/>
             </a:solidFill>
             <a:prstDash val="solid"/>
             <a:tailEnd type="triangle"/>
@@ -3116,12 +3103,10 @@
             </a:avLst>
           </a:prstGeom>
           <a:solidFill>
-            <a:srgbClr val="EFF6FF"/>
+            <a:srgbClr val="5A378C"/>
           </a:solidFill>
           <a:ln w="12700">
-            <a:solidFill>
-              <a:srgbClr val="BFDBFE"/>
-            </a:solidFill>
+            <a:noFill/>
             <a:prstDash val="solid"/>
           </a:ln>
         </p:spPr>
@@ -3141,12 +3126,10 @@
             <a:avLst/>
           </a:prstGeom>
           <a:solidFill>
-            <a:srgbClr val="F8FAFC"/>
+            <a:srgbClr val="462A6E"/>
           </a:solidFill>
           <a:ln w="12700">
-            <a:solidFill>
-              <a:srgbClr val="BFDBFE"/>
-            </a:solidFill>
+            <a:noFill/>
             <a:prstDash val="solid"/>
           </a:ln>
         </p:spPr>
@@ -3204,11 +3187,12 @@
           <a:p>
             <a:pPr indent="0" marL="0">
               <a:buNone/>
+              <a:defRPr b="1"/>
             </a:pPr>
             <a:r>
               <a:rPr sz="1100" b="1">
                 <a:solidFill>
-                  <a:srgbClr val="1E3A8A"/>
+                  <a:srgbClr val="FFFFFF"/>
                 </a:solidFill>
                 <a:latin typeface="Calibri"/>
               </a:rPr>
@@ -3245,7 +3229,7 @@
             <a:r>
               <a:rPr sz="1000" b="0">
                 <a:solidFill>
-                  <a:srgbClr val="0F172A"/>
+                  <a:srgbClr val="FFFFFF"/>
                 </a:solidFill>
                 <a:latin typeface="Calibri"/>
               </a:rPr>
@@ -3315,11 +3299,11 @@
             </a:avLst>
           </a:prstGeom>
           <a:solidFill>
-            <a:srgbClr val="FFFFFF"/>
+            <a:srgbClr val="F8FAFC"/>
           </a:solidFill>
           <a:ln w="19050">
             <a:solidFill>
-              <a:srgbClr val="000000"/>
+              <a:srgbClr val="1B4965"/>
             </a:solidFill>
             <a:prstDash val="solid"/>
           </a:ln>
@@ -3385,11 +3369,11 @@
             </a:avLst>
           </a:prstGeom>
           <a:solidFill>
-            <a:srgbClr val="FFFFFF"/>
+            <a:srgbClr val="F8FAFC"/>
           </a:solidFill>
           <a:ln w="19050">
             <a:solidFill>
-              <a:srgbClr val="000000"/>
+              <a:srgbClr val="1E7E34"/>
             </a:solidFill>
             <a:prstDash val="solid"/>
           </a:ln>
@@ -3449,11 +3433,11 @@
             </a:avLst>
           </a:prstGeom>
           <a:solidFill>
-            <a:srgbClr val="FFFFFF"/>
+            <a:srgbClr val="F8FAFC"/>
           </a:solidFill>
           <a:ln w="19050">
             <a:solidFill>
-              <a:srgbClr val="000000"/>
+              <a:srgbClr val="C05621"/>
             </a:solidFill>
             <a:prstDash val="solid"/>
           </a:ln>
@@ -3523,7 +3507,7 @@
           </a:solidFill>
           <a:ln w="19050">
             <a:solidFill>
-              <a:srgbClr val="000000"/>
+              <a:srgbClr val="5A378C"/>
             </a:solidFill>
             <a:prstDash val="solid"/>
           </a:ln>
@@ -3633,7 +3617,9 @@
                     <a:bodyPr/>
                     <a:lstStyle/>
                     <a:p>
-                      <a:pPr algn="ctr"/>
+                      <a:pPr algn="ctr">
+                        <a:defRPr b="1"/>
+                      </a:pPr>
                       <a:r>
                         <a:rPr sz="950" b="1">
                           <a:solidFill>
@@ -3647,7 +3633,7 @@
                   </a:txBody>
                   <a:tcPr marL="54864" marR="54864" marT="27432" marB="27432">
                     <a:solidFill>
-                      <a:srgbClr val="1E3A8A"/>
+                      <a:srgbClr val="1B365D"/>
                     </a:solidFill>
                   </a:tcPr>
                 </a:tc>
@@ -3656,7 +3642,9 @@
                     <a:bodyPr/>
                     <a:lstStyle/>
                     <a:p>
-                      <a:pPr algn="l"/>
+                      <a:pPr algn="l">
+                        <a:defRPr b="1"/>
+                      </a:pPr>
                       <a:r>
                         <a:rPr sz="950" b="1">
                           <a:solidFill>
@@ -3670,7 +3658,7 @@
                   </a:txBody>
                   <a:tcPr marL="54864" marR="54864" marT="27432" marB="27432">
                     <a:solidFill>
-                      <a:srgbClr val="1E3A8A"/>
+                      <a:srgbClr val="1B365D"/>
                     </a:solidFill>
                   </a:tcPr>
                 </a:tc>
@@ -3679,7 +3667,9 @@
                     <a:bodyPr/>
                     <a:lstStyle/>
                     <a:p>
-                      <a:pPr algn="ctr"/>
+                      <a:pPr algn="ctr">
+                        <a:defRPr b="1"/>
+                      </a:pPr>
                       <a:r>
                         <a:rPr sz="950" b="1">
                           <a:solidFill>
@@ -3693,7 +3683,7 @@
                   </a:txBody>
                   <a:tcPr marL="54864" marR="54864" marT="27432" marB="27432">
                     <a:solidFill>
-                      <a:srgbClr val="1E3A8A"/>
+                      <a:srgbClr val="1B365D"/>
                     </a:solidFill>
                   </a:tcPr>
                 </a:tc>
@@ -3702,7 +3692,9 @@
                     <a:bodyPr/>
                     <a:lstStyle/>
                     <a:p>
-                      <a:pPr algn="ctr"/>
+                      <a:pPr algn="ctr">
+                        <a:defRPr b="1"/>
+                      </a:pPr>
                       <a:r>
                         <a:rPr sz="950" b="1">
                           <a:solidFill>
@@ -3716,7 +3708,7 @@
                   </a:txBody>
                   <a:tcPr marL="54864" marR="54864" marT="27432" marB="27432">
                     <a:solidFill>
-                      <a:srgbClr val="1E3A8A"/>
+                      <a:srgbClr val="1B365D"/>
                     </a:solidFill>
                   </a:tcPr>
                 </a:tc>
@@ -3835,7 +3827,7 @@
                   </a:txBody>
                   <a:tcPr marL="54864" marR="54864" marT="27432" marB="27432">
                     <a:solidFill>
-                      <a:srgbClr val="EFF6FF"/>
+                      <a:srgbClr val="F8FAFC"/>
                     </a:solidFill>
                   </a:tcPr>
                 </a:tc>
@@ -3858,7 +3850,7 @@
                   </a:txBody>
                   <a:tcPr marL="54864" marR="54864" marT="27432" marB="27432">
                     <a:solidFill>
-                      <a:srgbClr val="EFF6FF"/>
+                      <a:srgbClr val="F8FAFC"/>
                     </a:solidFill>
                   </a:tcPr>
                 </a:tc>
@@ -3881,7 +3873,7 @@
                   </a:txBody>
                   <a:tcPr marL="54864" marR="54864" marT="27432" marB="27432">
                     <a:solidFill>
-                      <a:srgbClr val="EFF6FF"/>
+                      <a:srgbClr val="F8FAFC"/>
                     </a:solidFill>
                   </a:tcPr>
                 </a:tc>
@@ -3904,7 +3896,7 @@
                   </a:txBody>
                   <a:tcPr marL="54864" marR="54864" marT="27432" marB="27432">
                     <a:solidFill>
-                      <a:srgbClr val="EFF6FF"/>
+                      <a:srgbClr val="F8FAFC"/>
                     </a:solidFill>
                   </a:tcPr>
                 </a:tc>
@@ -4023,7 +4015,7 @@
                   </a:txBody>
                   <a:tcPr marL="54864" marR="54864" marT="27432" marB="27432">
                     <a:solidFill>
-                      <a:srgbClr val="EFF6FF"/>
+                      <a:srgbClr val="F8FAFC"/>
                     </a:solidFill>
                   </a:tcPr>
                 </a:tc>
@@ -4046,7 +4038,7 @@
                   </a:txBody>
                   <a:tcPr marL="54864" marR="54864" marT="27432" marB="27432">
                     <a:solidFill>
-                      <a:srgbClr val="EFF6FF"/>
+                      <a:srgbClr val="F8FAFC"/>
                     </a:solidFill>
                   </a:tcPr>
                 </a:tc>
@@ -4069,7 +4061,7 @@
                   </a:txBody>
                   <a:tcPr marL="54864" marR="54864" marT="27432" marB="27432">
                     <a:solidFill>
-                      <a:srgbClr val="EFF6FF"/>
+                      <a:srgbClr val="F8FAFC"/>
                     </a:solidFill>
                   </a:tcPr>
                 </a:tc>
@@ -4092,7 +4084,7 @@
                   </a:txBody>
                   <a:tcPr marL="54864" marR="54864" marT="27432" marB="27432">
                     <a:solidFill>
-                      <a:srgbClr val="EFF6FF"/>
+                      <a:srgbClr val="F8FAFC"/>
                     </a:solidFill>
                   </a:tcPr>
                 </a:tc>
@@ -4419,12 +4411,10 @@
             </a:avLst>
           </a:prstGeom>
           <a:solidFill>
-            <a:srgbClr val="EFF6FF"/>
+            <a:srgbClr val="1B4965"/>
           </a:solidFill>
           <a:ln w="12700">
-            <a:solidFill>
-              <a:srgbClr val="BFDBFE"/>
-            </a:solidFill>
+            <a:noFill/>
             <a:prstDash val="solid"/>
           </a:ln>
         </p:spPr>
@@ -4444,12 +4434,10 @@
             <a:avLst/>
           </a:prstGeom>
           <a:solidFill>
-            <a:srgbClr val="FFFFFF"/>
+            <a:srgbClr val="14374C"/>
           </a:solidFill>
           <a:ln w="12700">
-            <a:solidFill>
-              <a:srgbClr val="FFFFFF"/>
-            </a:solidFill>
+            <a:noFill/>
             <a:prstDash val="solid"/>
           </a:ln>
         </p:spPr>
@@ -4501,11 +4489,12 @@
           <a:p>
             <a:pPr indent="0" marL="0">
               <a:buNone/>
+              <a:defRPr b="1"/>
             </a:pPr>
             <a:r>
               <a:rPr sz="1150" b="1">
                 <a:solidFill>
-                  <a:srgbClr val="0F172A"/>
+                  <a:srgbClr val="FFFFFF"/>
                 </a:solidFill>
                 <a:latin typeface="Calibri"/>
               </a:rPr>
@@ -4542,7 +4531,7 @@
             <a:r>
               <a:rPr sz="950" b="0">
                 <a:solidFill>
-                  <a:srgbClr val="0F172A"/>
+                  <a:srgbClr val="FFFFFF"/>
                 </a:solidFill>
                 <a:latin typeface="Calibri"/>
               </a:rPr>
@@ -4554,7 +4543,7 @@
             <a:r>
               <a:rPr sz="950" b="0">
                 <a:solidFill>
-                  <a:srgbClr val="0F172A"/>
+                  <a:srgbClr val="FFFFFF"/>
                 </a:solidFill>
                 <a:latin typeface="Calibri"/>
               </a:rPr>
@@ -4565,7 +4554,7 @@
             <a:r>
               <a:rPr sz="950" b="0">
                 <a:solidFill>
-                  <a:srgbClr val="0F172A"/>
+                  <a:srgbClr val="FFFFFF"/>
                 </a:solidFill>
                 <a:latin typeface="Calibri"/>
               </a:rPr>
@@ -4589,9 +4578,9 @@
             <a:avLst/>
           </a:prstGeom>
           <a:noFill/>
-          <a:ln w="22225">
+          <a:ln w="25400">
             <a:solidFill>
-              <a:srgbClr val="5B6472"/>
+              <a:srgbClr val="1B365D"/>
             </a:solidFill>
             <a:prstDash val="solid"/>
             <a:tailEnd type="triangle"/>
@@ -4615,12 +4604,10 @@
             </a:avLst>
           </a:prstGeom>
           <a:solidFill>
-            <a:srgbClr val="EFF6FF"/>
+            <a:srgbClr val="1E7E34"/>
           </a:solidFill>
           <a:ln w="12700">
-            <a:solidFill>
-              <a:srgbClr val="BFDBFE"/>
-            </a:solidFill>
+            <a:noFill/>
             <a:prstDash val="solid"/>
           </a:ln>
         </p:spPr>
@@ -4640,12 +4627,10 @@
             <a:avLst/>
           </a:prstGeom>
           <a:solidFill>
-            <a:srgbClr val="FFFFFF"/>
+            <a:srgbClr val="165E26"/>
           </a:solidFill>
           <a:ln w="12700">
-            <a:solidFill>
-              <a:srgbClr val="FFFFFF"/>
-            </a:solidFill>
+            <a:noFill/>
             <a:prstDash val="solid"/>
           </a:ln>
         </p:spPr>
@@ -4697,11 +4682,12 @@
           <a:p>
             <a:pPr indent="0" marL="0">
               <a:buNone/>
+              <a:defRPr b="1"/>
             </a:pPr>
             <a:r>
               <a:rPr sz="1150" b="1">
                 <a:solidFill>
-                  <a:srgbClr val="0F172A"/>
+                  <a:srgbClr val="FFFFFF"/>
                 </a:solidFill>
                 <a:latin typeface="Calibri"/>
               </a:rPr>
@@ -4738,7 +4724,7 @@
             <a:r>
               <a:rPr sz="950" b="0">
                 <a:solidFill>
-                  <a:srgbClr val="0F172A"/>
+                  <a:srgbClr val="FFFFFF"/>
                 </a:solidFill>
                 <a:latin typeface="Calibri"/>
               </a:rPr>
@@ -4750,7 +4736,7 @@
             <a:r>
               <a:rPr sz="950" b="0">
                 <a:solidFill>
-                  <a:srgbClr val="0F172A"/>
+                  <a:srgbClr val="FFFFFF"/>
                 </a:solidFill>
                 <a:latin typeface="Calibri"/>
               </a:rPr>
@@ -4761,7 +4747,7 @@
             <a:r>
               <a:rPr sz="950" b="0">
                 <a:solidFill>
-                  <a:srgbClr val="0F172A"/>
+                  <a:srgbClr val="FFFFFF"/>
                 </a:solidFill>
                 <a:latin typeface="Calibri"/>
               </a:rPr>
@@ -4785,9 +4771,9 @@
             <a:avLst/>
           </a:prstGeom>
           <a:noFill/>
-          <a:ln w="22225">
+          <a:ln w="25400">
             <a:solidFill>
-              <a:srgbClr val="5B6472"/>
+              <a:srgbClr val="1B365D"/>
             </a:solidFill>
             <a:prstDash val="solid"/>
             <a:tailEnd type="triangle"/>
@@ -4811,12 +4797,10 @@
             </a:avLst>
           </a:prstGeom>
           <a:solidFill>
-            <a:srgbClr val="EFF6FF"/>
+            <a:srgbClr val="C05621"/>
           </a:solidFill>
           <a:ln w="12700">
-            <a:solidFill>
-              <a:srgbClr val="BFDBFE"/>
-            </a:solidFill>
+            <a:noFill/>
             <a:prstDash val="solid"/>
           </a:ln>
         </p:spPr>
@@ -4836,12 +4820,10 @@
             <a:avLst/>
           </a:prstGeom>
           <a:solidFill>
-            <a:srgbClr val="FFFFFF"/>
+            <a:srgbClr val="9C4418"/>
           </a:solidFill>
           <a:ln w="12700">
-            <a:solidFill>
-              <a:srgbClr val="FFFFFF"/>
-            </a:solidFill>
+            <a:noFill/>
             <a:prstDash val="solid"/>
           </a:ln>
         </p:spPr>
@@ -4893,11 +4875,12 @@
           <a:p>
             <a:pPr indent="0" marL="0">
               <a:buNone/>
+              <a:defRPr b="1"/>
             </a:pPr>
             <a:r>
               <a:rPr sz="1150" b="1">
                 <a:solidFill>
-                  <a:srgbClr val="0F172A"/>
+                  <a:srgbClr val="FFFFFF"/>
                 </a:solidFill>
                 <a:latin typeface="Calibri"/>
               </a:rPr>
@@ -4934,7 +4917,7 @@
             <a:r>
               <a:rPr sz="950" b="0">
                 <a:solidFill>
-                  <a:srgbClr val="0F172A"/>
+                  <a:srgbClr val="FFFFFF"/>
                 </a:solidFill>
                 <a:latin typeface="Calibri"/>
               </a:rPr>
@@ -4946,7 +4929,7 @@
             <a:r>
               <a:rPr sz="950" b="0">
                 <a:solidFill>
-                  <a:srgbClr val="0F172A"/>
+                  <a:srgbClr val="FFFFFF"/>
                 </a:solidFill>
                 <a:latin typeface="Calibri"/>
               </a:rPr>
@@ -4957,7 +4940,7 @@
             <a:r>
               <a:rPr sz="950" b="0">
                 <a:solidFill>
-                  <a:srgbClr val="0F172A"/>
+                  <a:srgbClr val="FFFFFF"/>
                 </a:solidFill>
                 <a:latin typeface="Calibri"/>
               </a:rPr>
@@ -4981,9 +4964,9 @@
             <a:avLst/>
           </a:prstGeom>
           <a:noFill/>
-          <a:ln w="22225">
+          <a:ln w="25400">
             <a:solidFill>
-              <a:srgbClr val="5B6472"/>
+              <a:srgbClr val="1B365D"/>
             </a:solidFill>
             <a:prstDash val="solid"/>
             <a:tailEnd type="triangle"/>
@@ -5007,12 +4990,10 @@
             </a:avLst>
           </a:prstGeom>
           <a:solidFill>
-            <a:srgbClr val="EFF6FF"/>
+            <a:srgbClr val="5A378C"/>
           </a:solidFill>
           <a:ln w="12700">
-            <a:solidFill>
-              <a:srgbClr val="BFDBFE"/>
-            </a:solidFill>
+            <a:noFill/>
             <a:prstDash val="solid"/>
           </a:ln>
         </p:spPr>
@@ -5032,12 +5013,10 @@
             <a:avLst/>
           </a:prstGeom>
           <a:solidFill>
-            <a:srgbClr val="FFFFFF"/>
+            <a:srgbClr val="462A6E"/>
           </a:solidFill>
           <a:ln w="12700">
-            <a:solidFill>
-              <a:srgbClr val="FFFFFF"/>
-            </a:solidFill>
+            <a:noFill/>
             <a:prstDash val="solid"/>
           </a:ln>
         </p:spPr>
@@ -5089,11 +5068,12 @@
           <a:p>
             <a:pPr indent="0" marL="0">
               <a:buNone/>
+              <a:defRPr b="1"/>
             </a:pPr>
             <a:r>
               <a:rPr sz="1150" b="1">
                 <a:solidFill>
-                  <a:srgbClr val="0F172A"/>
+                  <a:srgbClr val="FFFFFF"/>
                 </a:solidFill>
                 <a:latin typeface="Calibri"/>
               </a:rPr>
@@ -5130,7 +5110,7 @@
             <a:r>
               <a:rPr sz="950" b="0">
                 <a:solidFill>
-                  <a:srgbClr val="0F172A"/>
+                  <a:srgbClr val="FFFFFF"/>
                 </a:solidFill>
                 <a:latin typeface="Calibri"/>
               </a:rPr>
@@ -5142,7 +5122,7 @@
             <a:r>
               <a:rPr sz="950" b="0">
                 <a:solidFill>
-                  <a:srgbClr val="0F172A"/>
+                  <a:srgbClr val="FFFFFF"/>
                 </a:solidFill>
                 <a:latin typeface="Calibri"/>
               </a:rPr>
@@ -5153,7 +5133,7 @@
             <a:r>
               <a:rPr sz="950" b="0">
                 <a:solidFill>
-                  <a:srgbClr val="0F172A"/>
+                  <a:srgbClr val="FFFFFF"/>
                 </a:solidFill>
                 <a:latin typeface="Calibri"/>
               </a:rPr>
@@ -5255,12 +5235,10 @@
             </a:avLst>
           </a:prstGeom>
           <a:solidFill>
-            <a:srgbClr val="EFF6FF"/>
+            <a:srgbClr val="1B365D"/>
           </a:solidFill>
           <a:ln w="12700">
-            <a:solidFill>
-              <a:srgbClr val="BFDBFE"/>
-            </a:solidFill>
+            <a:noFill/>
             <a:prstDash val="solid"/>
           </a:ln>
         </p:spPr>
@@ -5288,11 +5266,12 @@
           <a:p>
             <a:pPr algn="ctr" indent="0" marL="0">
               <a:buNone/>
+              <a:defRPr b="1"/>
             </a:pPr>
             <a:r>
               <a:rPr sz="1050" b="1">
                 <a:solidFill>
-                  <a:srgbClr val="0F172A"/>
+                  <a:srgbClr val="FFFFFF"/>
                 </a:solidFill>
                 <a:latin typeface="Calibri"/>
               </a:rPr>
@@ -5329,7 +5308,7 @@
             <a:r>
               <a:rPr sz="1000" b="0">
                 <a:solidFill>
-                  <a:srgbClr val="0F172A"/>
+                  <a:srgbClr val="FFFFFF"/>
                 </a:solidFill>
                 <a:latin typeface="Calibri"/>
               </a:rPr>
@@ -5342,7 +5321,7 @@
             <a:r>
               <a:rPr sz="1000" b="0">
                 <a:solidFill>
-                  <a:srgbClr val="0F172A"/>
+                  <a:srgbClr val="FFFFFF"/>
                 </a:solidFill>
                 <a:latin typeface="Calibri"/>
               </a:rPr>
@@ -5368,12 +5347,10 @@
             </a:avLst>
           </a:prstGeom>
           <a:solidFill>
-            <a:srgbClr val="EFF6FF"/>
+            <a:srgbClr val="1B4965"/>
           </a:solidFill>
           <a:ln w="12700">
-            <a:solidFill>
-              <a:srgbClr val="BFDBFE"/>
-            </a:solidFill>
+            <a:noFill/>
             <a:prstDash val="solid"/>
           </a:ln>
         </p:spPr>
@@ -5401,11 +5378,12 @@
           <a:p>
             <a:pPr algn="ctr" indent="0" marL="0">
               <a:buNone/>
+              <a:defRPr b="1"/>
             </a:pPr>
             <a:r>
               <a:rPr sz="1050" b="1">
                 <a:solidFill>
-                  <a:srgbClr val="0F172A"/>
+                  <a:srgbClr val="FFFFFF"/>
                 </a:solidFill>
                 <a:latin typeface="Calibri"/>
               </a:rPr>
@@ -5442,7 +5420,7 @@
             <a:r>
               <a:rPr sz="1000" b="0">
                 <a:solidFill>
-                  <a:srgbClr val="0F172A"/>
+                  <a:srgbClr val="FFFFFF"/>
                 </a:solidFill>
                 <a:latin typeface="Calibri"/>
               </a:rPr>
@@ -5455,7 +5433,7 @@
             <a:r>
               <a:rPr sz="1000" b="0">
                 <a:solidFill>
-                  <a:srgbClr val="0F172A"/>
+                  <a:srgbClr val="FFFFFF"/>
                 </a:solidFill>
                 <a:latin typeface="Calibri"/>
               </a:rPr>
@@ -5481,12 +5459,10 @@
             </a:avLst>
           </a:prstGeom>
           <a:solidFill>
-            <a:srgbClr val="EFF6FF"/>
+            <a:srgbClr val="1E7E34"/>
           </a:solidFill>
           <a:ln w="12700">
-            <a:solidFill>
-              <a:srgbClr val="BFDBFE"/>
-            </a:solidFill>
+            <a:noFill/>
             <a:prstDash val="solid"/>
           </a:ln>
         </p:spPr>
@@ -5514,11 +5490,12 @@
           <a:p>
             <a:pPr algn="ctr" indent="0" marL="0">
               <a:buNone/>
+              <a:defRPr b="1"/>
             </a:pPr>
             <a:r>
               <a:rPr sz="1050" b="1">
                 <a:solidFill>
-                  <a:srgbClr val="0F172A"/>
+                  <a:srgbClr val="FFFFFF"/>
                 </a:solidFill>
                 <a:latin typeface="Calibri"/>
               </a:rPr>
@@ -5555,7 +5532,7 @@
             <a:r>
               <a:rPr sz="1000" b="0">
                 <a:solidFill>
-                  <a:srgbClr val="0F172A"/>
+                  <a:srgbClr val="FFFFFF"/>
                 </a:solidFill>
                 <a:latin typeface="Calibri"/>
               </a:rPr>
@@ -5568,7 +5545,7 @@
             <a:r>
               <a:rPr sz="1000" b="0">
                 <a:solidFill>
-                  <a:srgbClr val="0F172A"/>
+                  <a:srgbClr val="FFFFFF"/>
                 </a:solidFill>
                 <a:latin typeface="Calibri"/>
               </a:rPr>
@@ -5594,12 +5571,10 @@
             </a:avLst>
           </a:prstGeom>
           <a:solidFill>
-            <a:srgbClr val="EFF6FF"/>
+            <a:srgbClr val="C05621"/>
           </a:solidFill>
           <a:ln w="12700">
-            <a:solidFill>
-              <a:srgbClr val="BFDBFE"/>
-            </a:solidFill>
+            <a:noFill/>
             <a:prstDash val="solid"/>
           </a:ln>
         </p:spPr>
@@ -5627,11 +5602,12 @@
           <a:p>
             <a:pPr algn="ctr" indent="0" marL="0">
               <a:buNone/>
+              <a:defRPr b="1"/>
             </a:pPr>
             <a:r>
               <a:rPr sz="1050" b="1">
                 <a:solidFill>
-                  <a:srgbClr val="0F172A"/>
+                  <a:srgbClr val="FFFFFF"/>
                 </a:solidFill>
                 <a:latin typeface="Calibri"/>
               </a:rPr>
@@ -5668,7 +5644,7 @@
             <a:r>
               <a:rPr sz="1000" b="0">
                 <a:solidFill>
-                  <a:srgbClr val="0F172A"/>
+                  <a:srgbClr val="FFFFFF"/>
                 </a:solidFill>
                 <a:latin typeface="Calibri"/>
               </a:rPr>
@@ -5681,7 +5657,7 @@
             <a:r>
               <a:rPr sz="1000" b="0">
                 <a:solidFill>
-                  <a:srgbClr val="0F172A"/>
+                  <a:srgbClr val="FFFFFF"/>
                 </a:solidFill>
                 <a:latin typeface="Calibri"/>
               </a:rPr>
@@ -5705,9 +5681,9 @@
             <a:avLst/>
           </a:prstGeom>
           <a:noFill/>
-          <a:ln w="22225">
+          <a:ln w="19050">
             <a:solidFill>
-              <a:srgbClr val="5B6472"/>
+              <a:srgbClr val="1B365D"/>
             </a:solidFill>
             <a:prstDash val="solid"/>
             <a:tailEnd type="triangle"/>
@@ -5729,9 +5705,9 @@
             <a:avLst/>
           </a:prstGeom>
           <a:noFill/>
-          <a:ln w="22225">
+          <a:ln w="19050">
             <a:solidFill>
-              <a:srgbClr val="5B6472"/>
+              <a:srgbClr val="1B365D"/>
             </a:solidFill>
             <a:prstDash val="solid"/>
             <a:tailEnd type="triangle"/>
@@ -5753,9 +5729,9 @@
             <a:avLst/>
           </a:prstGeom>
           <a:noFill/>
-          <a:ln w="22225">
+          <a:ln w="19050">
             <a:solidFill>
-              <a:srgbClr val="5B6472"/>
+              <a:srgbClr val="1B365D"/>
             </a:solidFill>
             <a:prstDash val="solid"/>
             <a:tailEnd type="triangle"/>
@@ -5777,9 +5753,9 @@
             <a:avLst/>
           </a:prstGeom>
           <a:noFill/>
-          <a:ln w="22225">
+          <a:ln w="19050">
             <a:solidFill>
-              <a:srgbClr val="5B6472"/>
+              <a:srgbClr val="1B365D"/>
             </a:solidFill>
             <a:prstDash val="solid"/>
             <a:tailEnd type="triangle"/>
@@ -5803,12 +5779,10 @@
             </a:avLst>
           </a:prstGeom>
           <a:solidFill>
-            <a:srgbClr val="EFF6FF"/>
+            <a:srgbClr val="8C2D19"/>
           </a:solidFill>
           <a:ln w="12700">
-            <a:solidFill>
-              <a:srgbClr val="BFDBFE"/>
-            </a:solidFill>
+            <a:noFill/>
             <a:prstDash val="solid"/>
           </a:ln>
         </p:spPr>
@@ -5836,11 +5810,12 @@
           <a:p>
             <a:pPr algn="ctr" indent="0" marL="0">
               <a:buNone/>
+              <a:defRPr b="1"/>
             </a:pPr>
             <a:r>
               <a:rPr sz="1050" b="1">
                 <a:solidFill>
-                  <a:srgbClr val="0F172A"/>
+                  <a:srgbClr val="FFFFFF"/>
                 </a:solidFill>
                 <a:latin typeface="Calibri"/>
               </a:rPr>
@@ -5877,7 +5852,7 @@
             <a:r>
               <a:rPr sz="1000" b="0">
                 <a:solidFill>
-                  <a:srgbClr val="0F172A"/>
+                  <a:srgbClr val="FFFFFF"/>
                 </a:solidFill>
                 <a:latin typeface="Calibri"/>
               </a:rPr>
@@ -5890,7 +5865,7 @@
             <a:r>
               <a:rPr sz="1000" b="0">
                 <a:solidFill>
-                  <a:srgbClr val="0F172A"/>
+                  <a:srgbClr val="FFFFFF"/>
                 </a:solidFill>
                 <a:latin typeface="Calibri"/>
               </a:rPr>
@@ -5916,12 +5891,10 @@
             </a:avLst>
           </a:prstGeom>
           <a:solidFill>
-            <a:srgbClr val="EFF6FF"/>
+            <a:srgbClr val="1E7E34"/>
           </a:solidFill>
           <a:ln w="12700">
-            <a:solidFill>
-              <a:srgbClr val="BFDBFE"/>
-            </a:solidFill>
+            <a:noFill/>
             <a:prstDash val="solid"/>
           </a:ln>
         </p:spPr>
@@ -5949,11 +5922,12 @@
           <a:p>
             <a:pPr algn="ctr" indent="0" marL="0">
               <a:buNone/>
+              <a:defRPr b="1"/>
             </a:pPr>
             <a:r>
               <a:rPr sz="1050" b="1">
                 <a:solidFill>
-                  <a:srgbClr val="0F172A"/>
+                  <a:srgbClr val="FFFFFF"/>
                 </a:solidFill>
                 <a:latin typeface="Calibri"/>
               </a:rPr>
@@ -5990,7 +5964,7 @@
             <a:r>
               <a:rPr sz="1000" b="0">
                 <a:solidFill>
-                  <a:srgbClr val="0F172A"/>
+                  <a:srgbClr val="FFFFFF"/>
                 </a:solidFill>
                 <a:latin typeface="Calibri"/>
               </a:rPr>
@@ -6003,7 +5977,7 @@
             <a:r>
               <a:rPr sz="1000" b="0">
                 <a:solidFill>
-                  <a:srgbClr val="0F172A"/>
+                  <a:srgbClr val="FFFFFF"/>
                 </a:solidFill>
                 <a:latin typeface="Calibri"/>
               </a:rPr>
@@ -6029,12 +6003,10 @@
             </a:avLst>
           </a:prstGeom>
           <a:solidFill>
-            <a:srgbClr val="EFF6FF"/>
+            <a:srgbClr val="C05621"/>
           </a:solidFill>
           <a:ln w="12700">
-            <a:solidFill>
-              <a:srgbClr val="BFDBFE"/>
-            </a:solidFill>
+            <a:noFill/>
             <a:prstDash val="solid"/>
           </a:ln>
         </p:spPr>
@@ -6062,11 +6034,12 @@
           <a:p>
             <a:pPr algn="ctr" indent="0" marL="0">
               <a:buNone/>
+              <a:defRPr b="1"/>
             </a:pPr>
             <a:r>
               <a:rPr sz="1050" b="1">
                 <a:solidFill>
-                  <a:srgbClr val="0F172A"/>
+                  <a:srgbClr val="FFFFFF"/>
                 </a:solidFill>
                 <a:latin typeface="Calibri"/>
               </a:rPr>
@@ -6103,7 +6076,7 @@
             <a:r>
               <a:rPr sz="1000" b="0">
                 <a:solidFill>
-                  <a:srgbClr val="0F172A"/>
+                  <a:srgbClr val="FFFFFF"/>
                 </a:solidFill>
                 <a:latin typeface="Calibri"/>
               </a:rPr>
@@ -6116,7 +6089,7 @@
             <a:r>
               <a:rPr sz="1000" b="0">
                 <a:solidFill>
-                  <a:srgbClr val="0F172A"/>
+                  <a:srgbClr val="FFFFFF"/>
                 </a:solidFill>
                 <a:latin typeface="Calibri"/>
               </a:rPr>
@@ -6142,12 +6115,10 @@
             </a:avLst>
           </a:prstGeom>
           <a:solidFill>
-            <a:srgbClr val="EFF6FF"/>
+            <a:srgbClr val="5A378C"/>
           </a:solidFill>
           <a:ln w="12700">
-            <a:solidFill>
-              <a:srgbClr val="BFDBFE"/>
-            </a:solidFill>
+            <a:noFill/>
             <a:prstDash val="solid"/>
           </a:ln>
         </p:spPr>
@@ -6175,11 +6146,12 @@
           <a:p>
             <a:pPr algn="ctr" indent="0" marL="0">
               <a:buNone/>
+              <a:defRPr b="1"/>
             </a:pPr>
             <a:r>
               <a:rPr sz="1050" b="1">
                 <a:solidFill>
-                  <a:srgbClr val="0F172A"/>
+                  <a:srgbClr val="FFFFFF"/>
                 </a:solidFill>
                 <a:latin typeface="Calibri"/>
               </a:rPr>
@@ -6216,7 +6188,7 @@
             <a:r>
               <a:rPr sz="1000" b="0">
                 <a:solidFill>
-                  <a:srgbClr val="0F172A"/>
+                  <a:srgbClr val="FFFFFF"/>
                 </a:solidFill>
                 <a:latin typeface="Calibri"/>
               </a:rPr>
@@ -6229,7 +6201,7 @@
             <a:r>
               <a:rPr sz="1000" b="0">
                 <a:solidFill>
-                  <a:srgbClr val="0F172A"/>
+                  <a:srgbClr val="FFFFFF"/>
                 </a:solidFill>
                 <a:latin typeface="Calibri"/>
               </a:rPr>
@@ -6253,9 +6225,9 @@
             <a:avLst/>
           </a:prstGeom>
           <a:noFill/>
-          <a:ln w="22225">
+          <a:ln w="19050">
             <a:solidFill>
-              <a:srgbClr val="5B6472"/>
+              <a:srgbClr val="1B365D"/>
             </a:solidFill>
             <a:prstDash val="solid"/>
             <a:tailEnd type="triangle"/>
@@ -6277,9 +6249,9 @@
             <a:avLst/>
           </a:prstGeom>
           <a:noFill/>
-          <a:ln w="22225">
+          <a:ln w="19050">
             <a:solidFill>
-              <a:srgbClr val="5B6472"/>
+              <a:srgbClr val="1B365D"/>
             </a:solidFill>
             <a:prstDash val="solid"/>
             <a:tailEnd type="triangle"/>
@@ -6301,9 +6273,9 @@
             <a:avLst/>
           </a:prstGeom>
           <a:noFill/>
-          <a:ln w="22225">
+          <a:ln w="19050">
             <a:solidFill>
-              <a:srgbClr val="5B6472"/>
+              <a:srgbClr val="1B365D"/>
             </a:solidFill>
             <a:prstDash val="solid"/>
             <a:tailEnd type="triangle"/>
@@ -6403,9 +6375,9 @@
           <a:solidFill>
             <a:srgbClr val="F8FAFC"/>
           </a:solidFill>
-          <a:ln w="12700">
+          <a:ln w="19050">
             <a:solidFill>
-              <a:srgbClr val="E2E8F0"/>
+              <a:srgbClr val="1B365D"/>
             </a:solidFill>
             <a:prstDash val="solid"/>
           </a:ln>
@@ -6587,9 +6559,9 @@
           <a:solidFill>
             <a:srgbClr val="FFFFFF"/>
           </a:solidFill>
-          <a:ln w="15875">
+          <a:ln w="25400">
             <a:solidFill>
-              <a:srgbClr val="000000"/>
+              <a:srgbClr val="1B365D"/>
             </a:solidFill>
             <a:prstDash val="solid"/>
           </a:ln>
@@ -6714,9 +6686,9 @@
           <a:solidFill>
             <a:srgbClr val="EFF6FF"/>
           </a:solidFill>
-          <a:ln w="12700">
+          <a:ln w="25400">
             <a:solidFill>
-              <a:srgbClr val="BFDBFE"/>
+              <a:srgbClr val="1B365D"/>
             </a:solidFill>
             <a:prstDash val="solid"/>
           </a:ln>
@@ -6883,12 +6855,10 @@
             <a:avLst/>
           </a:prstGeom>
           <a:solidFill>
-            <a:srgbClr val="EFF6FF"/>
+            <a:srgbClr val="1B4965"/>
           </a:solidFill>
           <a:ln w="12700">
-            <a:solidFill>
-              <a:srgbClr val="BFDBFE"/>
-            </a:solidFill>
+            <a:noFill/>
           </a:ln>
         </p:spPr>
         <p:style>
@@ -6909,11 +6879,17 @@
           <a:bodyPr rtlCol="0" anchor="ctr" wrap="square" lIns="109728" tIns="54864" bIns="54864"/>
           <a:lstStyle/>
           <a:p>
-            <a:pPr algn="ctr"/>
+            <a:pPr algn="ctr">
+              <a:defRPr>
+                <a:solidFill>
+                  <a:srgbClr val="FFFFFF"/>
+                </a:solidFill>
+              </a:defRPr>
+            </a:pPr>
             <a:r>
               <a:rPr sz="1050" b="1">
                 <a:solidFill>
-                  <a:srgbClr val="1E3A8A"/>
+                  <a:srgbClr val="FFFFFF"/>
                 </a:solidFill>
                 <a:latin typeface="Calibri"/>
               </a:rPr>
@@ -6921,10 +6897,17 @@
             </a:r>
           </a:p>
           <a:p>
+            <a:pPr>
+              <a:defRPr>
+                <a:solidFill>
+                  <a:srgbClr val="FFFFFF"/>
+                </a:solidFill>
+              </a:defRPr>
+            </a:pPr>
             <a:r>
               <a:rPr sz="900" b="0">
                 <a:solidFill>
-                  <a:srgbClr val="0F172A"/>
+                  <a:srgbClr val="FFFFFF"/>
                 </a:solidFill>
                 <a:latin typeface="Calibri"/>
               </a:rPr>
@@ -6932,10 +6915,17 @@
             </a:r>
           </a:p>
           <a:p>
+            <a:pPr>
+              <a:defRPr>
+                <a:solidFill>
+                  <a:srgbClr val="FFFFFF"/>
+                </a:solidFill>
+              </a:defRPr>
+            </a:pPr>
             <a:r>
               <a:rPr sz="900" b="0">
                 <a:solidFill>
-                  <a:srgbClr val="0F172A"/>
+                  <a:srgbClr val="FFFFFF"/>
                 </a:solidFill>
                 <a:latin typeface="Calibri"/>
               </a:rPr>
@@ -6961,8 +6951,10 @@
           <a:solidFill>
             <a:srgbClr val="1E3A8A"/>
           </a:solidFill>
-          <a:ln>
-            <a:noFill/>
+          <a:ln w="25400">
+            <a:solidFill>
+              <a:srgbClr val="1B365D"/>
+            </a:solidFill>
           </a:ln>
         </p:spPr>
         <p:style>
@@ -7002,12 +6994,10 @@
             <a:avLst/>
           </a:prstGeom>
           <a:solidFill>
-            <a:srgbClr val="EFF6FF"/>
+            <a:srgbClr val="1E7E34"/>
           </a:solidFill>
           <a:ln w="12700">
-            <a:solidFill>
-              <a:srgbClr val="BFDBFE"/>
-            </a:solidFill>
+            <a:noFill/>
           </a:ln>
         </p:spPr>
         <p:style>
@@ -7028,11 +7018,17 @@
           <a:bodyPr rtlCol="0" anchor="ctr" wrap="square" lIns="109728" tIns="54864" bIns="54864"/>
           <a:lstStyle/>
           <a:p>
-            <a:pPr algn="ctr"/>
+            <a:pPr algn="ctr">
+              <a:defRPr>
+                <a:solidFill>
+                  <a:srgbClr val="FFFFFF"/>
+                </a:solidFill>
+              </a:defRPr>
+            </a:pPr>
             <a:r>
               <a:rPr sz="1050" b="1">
                 <a:solidFill>
-                  <a:srgbClr val="1E3A8A"/>
+                  <a:srgbClr val="FFFFFF"/>
                 </a:solidFill>
                 <a:latin typeface="Calibri"/>
               </a:rPr>
@@ -7040,10 +7036,17 @@
             </a:r>
           </a:p>
           <a:p>
+            <a:pPr>
+              <a:defRPr>
+                <a:solidFill>
+                  <a:srgbClr val="FFFFFF"/>
+                </a:solidFill>
+              </a:defRPr>
+            </a:pPr>
             <a:r>
               <a:rPr sz="900" b="0">
                 <a:solidFill>
-                  <a:srgbClr val="0F172A"/>
+                  <a:srgbClr val="FFFFFF"/>
                 </a:solidFill>
                 <a:latin typeface="Calibri"/>
               </a:rPr>
@@ -7051,10 +7054,17 @@
             </a:r>
           </a:p>
           <a:p>
+            <a:pPr>
+              <a:defRPr>
+                <a:solidFill>
+                  <a:srgbClr val="FFFFFF"/>
+                </a:solidFill>
+              </a:defRPr>
+            </a:pPr>
             <a:r>
               <a:rPr sz="900" b="0">
                 <a:solidFill>
-                  <a:srgbClr val="0F172A"/>
+                  <a:srgbClr val="FFFFFF"/>
                 </a:solidFill>
                 <a:latin typeface="Calibri"/>
               </a:rPr>
@@ -7080,8 +7090,10 @@
           <a:solidFill>
             <a:srgbClr val="1E3A8A"/>
           </a:solidFill>
-          <a:ln>
-            <a:noFill/>
+          <a:ln w="25400">
+            <a:solidFill>
+              <a:srgbClr val="1B365D"/>
+            </a:solidFill>
           </a:ln>
         </p:spPr>
         <p:style>
@@ -7121,12 +7133,10 @@
             <a:avLst/>
           </a:prstGeom>
           <a:solidFill>
-            <a:srgbClr val="EFF6FF"/>
+            <a:srgbClr val="C05621"/>
           </a:solidFill>
           <a:ln w="12700">
-            <a:solidFill>
-              <a:srgbClr val="BFDBFE"/>
-            </a:solidFill>
+            <a:noFill/>
           </a:ln>
         </p:spPr>
         <p:style>
@@ -7147,11 +7157,17 @@
           <a:bodyPr rtlCol="0" anchor="ctr" wrap="square" lIns="109728" tIns="54864" bIns="54864"/>
           <a:lstStyle/>
           <a:p>
-            <a:pPr algn="ctr"/>
+            <a:pPr algn="ctr">
+              <a:defRPr>
+                <a:solidFill>
+                  <a:srgbClr val="FFFFFF"/>
+                </a:solidFill>
+              </a:defRPr>
+            </a:pPr>
             <a:r>
               <a:rPr sz="1050" b="1">
                 <a:solidFill>
-                  <a:srgbClr val="1E3A8A"/>
+                  <a:srgbClr val="FFFFFF"/>
                 </a:solidFill>
                 <a:latin typeface="Calibri"/>
               </a:rPr>
@@ -7159,10 +7175,17 @@
             </a:r>
           </a:p>
           <a:p>
+            <a:pPr>
+              <a:defRPr>
+                <a:solidFill>
+                  <a:srgbClr val="FFFFFF"/>
+                </a:solidFill>
+              </a:defRPr>
+            </a:pPr>
             <a:r>
               <a:rPr sz="900" b="0">
                 <a:solidFill>
-                  <a:srgbClr val="0F172A"/>
+                  <a:srgbClr val="FFFFFF"/>
                 </a:solidFill>
                 <a:latin typeface="Calibri"/>
               </a:rPr>
@@ -7170,10 +7193,17 @@
             </a:r>
           </a:p>
           <a:p>
+            <a:pPr>
+              <a:defRPr>
+                <a:solidFill>
+                  <a:srgbClr val="FFFFFF"/>
+                </a:solidFill>
+              </a:defRPr>
+            </a:pPr>
             <a:r>
               <a:rPr sz="900" b="0">
                 <a:solidFill>
-                  <a:srgbClr val="0F172A"/>
+                  <a:srgbClr val="FFFFFF"/>
                 </a:solidFill>
                 <a:latin typeface="Calibri"/>
               </a:rPr>
@@ -7199,8 +7229,10 @@
           <a:solidFill>
             <a:srgbClr val="1E3A8A"/>
           </a:solidFill>
-          <a:ln>
-            <a:noFill/>
+          <a:ln w="25400">
+            <a:solidFill>
+              <a:srgbClr val="1B365D"/>
+            </a:solidFill>
           </a:ln>
         </p:spPr>
         <p:style>
@@ -7240,12 +7272,10 @@
             <a:avLst/>
           </a:prstGeom>
           <a:solidFill>
-            <a:srgbClr val="EFF6FF"/>
+            <a:srgbClr val="5A378C"/>
           </a:solidFill>
           <a:ln w="12700">
-            <a:solidFill>
-              <a:srgbClr val="BFDBFE"/>
-            </a:solidFill>
+            <a:noFill/>
           </a:ln>
         </p:spPr>
         <p:style>
@@ -7266,11 +7296,17 @@
           <a:bodyPr rtlCol="0" anchor="ctr" wrap="square" lIns="109728" tIns="54864" bIns="54864"/>
           <a:lstStyle/>
           <a:p>
-            <a:pPr algn="ctr"/>
+            <a:pPr algn="ctr">
+              <a:defRPr>
+                <a:solidFill>
+                  <a:srgbClr val="FFFFFF"/>
+                </a:solidFill>
+              </a:defRPr>
+            </a:pPr>
             <a:r>
               <a:rPr sz="1050" b="1">
                 <a:solidFill>
-                  <a:srgbClr val="1E3A8A"/>
+                  <a:srgbClr val="FFFFFF"/>
                 </a:solidFill>
                 <a:latin typeface="Calibri"/>
               </a:rPr>
@@ -7278,10 +7314,17 @@
             </a:r>
           </a:p>
           <a:p>
+            <a:pPr>
+              <a:defRPr>
+                <a:solidFill>
+                  <a:srgbClr val="FFFFFF"/>
+                </a:solidFill>
+              </a:defRPr>
+            </a:pPr>
             <a:r>
               <a:rPr sz="900" b="0">
                 <a:solidFill>
-                  <a:srgbClr val="0F172A"/>
+                  <a:srgbClr val="FFFFFF"/>
                 </a:solidFill>
                 <a:latin typeface="Calibri"/>
               </a:rPr>
@@ -7289,10 +7332,17 @@
             </a:r>
           </a:p>
           <a:p>
+            <a:pPr>
+              <a:defRPr>
+                <a:solidFill>
+                  <a:srgbClr val="FFFFFF"/>
+                </a:solidFill>
+              </a:defRPr>
+            </a:pPr>
             <a:r>
               <a:rPr sz="900" b="0">
                 <a:solidFill>
-                  <a:srgbClr val="0F172A"/>
+                  <a:srgbClr val="FFFFFF"/>
                 </a:solidFill>
                 <a:latin typeface="Calibri"/>
               </a:rPr>
@@ -7318,8 +7368,10 @@
           <a:solidFill>
             <a:srgbClr val="1E3A8A"/>
           </a:solidFill>
-          <a:ln>
-            <a:noFill/>
+          <a:ln w="25400">
+            <a:solidFill>
+              <a:srgbClr val="1B365D"/>
+            </a:solidFill>
           </a:ln>
         </p:spPr>
         <p:style>
@@ -7359,12 +7411,10 @@
             <a:avLst/>
           </a:prstGeom>
           <a:solidFill>
-            <a:srgbClr val="EFF6FF"/>
+            <a:srgbClr val="8C2D19"/>
           </a:solidFill>
           <a:ln w="12700">
-            <a:solidFill>
-              <a:srgbClr val="BFDBFE"/>
-            </a:solidFill>
+            <a:noFill/>
           </a:ln>
         </p:spPr>
         <p:style>
@@ -7385,11 +7435,17 @@
           <a:bodyPr rtlCol="0" anchor="ctr" wrap="square" lIns="109728" tIns="54864" bIns="54864"/>
           <a:lstStyle/>
           <a:p>
-            <a:pPr algn="ctr"/>
+            <a:pPr algn="ctr">
+              <a:defRPr>
+                <a:solidFill>
+                  <a:srgbClr val="FFFFFF"/>
+                </a:solidFill>
+              </a:defRPr>
+            </a:pPr>
             <a:r>
               <a:rPr sz="1050" b="1">
                 <a:solidFill>
-                  <a:srgbClr val="1E3A8A"/>
+                  <a:srgbClr val="FFFFFF"/>
                 </a:solidFill>
                 <a:latin typeface="Calibri"/>
               </a:rPr>
@@ -7397,10 +7453,17 @@
             </a:r>
           </a:p>
           <a:p>
+            <a:pPr>
+              <a:defRPr>
+                <a:solidFill>
+                  <a:srgbClr val="FFFFFF"/>
+                </a:solidFill>
+              </a:defRPr>
+            </a:pPr>
             <a:r>
               <a:rPr sz="900" b="0">
                 <a:solidFill>
-                  <a:srgbClr val="0F172A"/>
+                  <a:srgbClr val="FFFFFF"/>
                 </a:solidFill>
                 <a:latin typeface="Calibri"/>
               </a:rPr>
@@ -7408,10 +7471,17 @@
             </a:r>
           </a:p>
           <a:p>
+            <a:pPr>
+              <a:defRPr>
+                <a:solidFill>
+                  <a:srgbClr val="FFFFFF"/>
+                </a:solidFill>
+              </a:defRPr>
+            </a:pPr>
             <a:r>
               <a:rPr sz="900" b="0">
                 <a:solidFill>
-                  <a:srgbClr val="0F172A"/>
+                  <a:srgbClr val="FFFFFF"/>
                 </a:solidFill>
                 <a:latin typeface="Calibri"/>
               </a:rPr>
@@ -7437,9 +7507,9 @@
           <a:solidFill>
             <a:srgbClr val="F8FAFC"/>
           </a:solidFill>
-          <a:ln w="12700">
+          <a:ln w="19050">
             <a:solidFill>
-              <a:srgbClr val="E2E8F0"/>
+              <a:srgbClr val="1B4965"/>
             </a:solidFill>
           </a:ln>
         </p:spPr>
@@ -7461,11 +7531,13 @@
           <a:bodyPr rtlCol="0" anchor="ctr" wrap="square" lIns="128016" rIns="109728" tIns="54864" bIns="54864"/>
           <a:lstStyle/>
           <a:p>
-            <a:pPr algn="ctr"/>
+            <a:pPr algn="ctr">
+              <a:defRPr b="1"/>
+            </a:pPr>
             <a:r>
               <a:rPr sz="1100" b="1">
                 <a:solidFill>
-                  <a:srgbClr val="0F172A"/>
+                  <a:srgbClr val="1B4965"/>
                 </a:solidFill>
                 <a:latin typeface="Calibri"/>
               </a:rPr>
@@ -7513,9 +7585,9 @@
           <a:solidFill>
             <a:srgbClr val="F8FAFC"/>
           </a:solidFill>
-          <a:ln w="12700">
+          <a:ln w="19050">
             <a:solidFill>
-              <a:srgbClr val="E2E8F0"/>
+              <a:srgbClr val="1E7E34"/>
             </a:solidFill>
           </a:ln>
         </p:spPr>
@@ -7537,11 +7609,13 @@
           <a:bodyPr rtlCol="0" anchor="ctr" wrap="square" lIns="128016" rIns="109728" tIns="54864" bIns="54864"/>
           <a:lstStyle/>
           <a:p>
-            <a:pPr algn="ctr"/>
+            <a:pPr algn="ctr">
+              <a:defRPr b="1"/>
+            </a:pPr>
             <a:r>
               <a:rPr sz="1100" b="1">
                 <a:solidFill>
-                  <a:srgbClr val="0F172A"/>
+                  <a:srgbClr val="1E7E34"/>
                 </a:solidFill>
                 <a:latin typeface="Calibri"/>
               </a:rPr>
@@ -7589,9 +7663,9 @@
           <a:solidFill>
             <a:srgbClr val="F8FAFC"/>
           </a:solidFill>
-          <a:ln w="12700">
+          <a:ln w="19050">
             <a:solidFill>
-              <a:srgbClr val="E2E8F0"/>
+              <a:srgbClr val="C05621"/>
             </a:solidFill>
           </a:ln>
         </p:spPr>
@@ -7613,11 +7687,13 @@
           <a:bodyPr rtlCol="0" anchor="ctr" wrap="square" lIns="128016" rIns="109728" tIns="54864" bIns="54864"/>
           <a:lstStyle/>
           <a:p>
-            <a:pPr algn="ctr"/>
+            <a:pPr algn="ctr">
+              <a:defRPr b="1"/>
+            </a:pPr>
             <a:r>
               <a:rPr sz="1100" b="1">
                 <a:solidFill>
-                  <a:srgbClr val="0F172A"/>
+                  <a:srgbClr val="C05621"/>
                 </a:solidFill>
                 <a:latin typeface="Calibri"/>
               </a:rPr>
@@ -7665,9 +7741,9 @@
           <a:solidFill>
             <a:srgbClr val="F8FAFC"/>
           </a:solidFill>
-          <a:ln w="12700">
+          <a:ln w="19050">
             <a:solidFill>
-              <a:srgbClr val="E2E8F0"/>
+              <a:srgbClr val="5A378C"/>
             </a:solidFill>
           </a:ln>
         </p:spPr>
@@ -7689,11 +7765,13 @@
           <a:bodyPr rtlCol="0" anchor="ctr" wrap="square" lIns="128016" rIns="109728" tIns="54864" bIns="54864"/>
           <a:lstStyle/>
           <a:p>
-            <a:pPr algn="ctr"/>
+            <a:pPr algn="ctr">
+              <a:defRPr b="1"/>
+            </a:pPr>
             <a:r>
               <a:rPr sz="1100" b="1">
                 <a:solidFill>
-                  <a:srgbClr val="0F172A"/>
+                  <a:srgbClr val="5A378C"/>
                 </a:solidFill>
                 <a:latin typeface="Calibri"/>
               </a:rPr>
@@ -8038,12 +8116,10 @@
             <a:avLst/>
           </a:prstGeom>
           <a:solidFill>
-            <a:srgbClr val="EFF6FF"/>
+            <a:srgbClr val="1E7E34"/>
           </a:solidFill>
           <a:ln w="12700">
-            <a:solidFill>
-              <a:srgbClr val="BFDBFE"/>
-            </a:solidFill>
+            <a:noFill/>
             <a:prstDash val="solid"/>
           </a:ln>
         </p:spPr>
@@ -8127,12 +8203,10 @@
             <a:avLst/>
           </a:prstGeom>
           <a:solidFill>
-            <a:srgbClr val="EFF6FF"/>
+            <a:srgbClr val="C05621"/>
           </a:solidFill>
           <a:ln w="12700">
-            <a:solidFill>
-              <a:srgbClr val="BFDBFE"/>
-            </a:solidFill>
+            <a:noFill/>
             <a:prstDash val="solid"/>
           </a:ln>
         </p:spPr>
@@ -8216,12 +8290,10 @@
             <a:avLst/>
           </a:prstGeom>
           <a:solidFill>
-            <a:srgbClr val="EFF6FF"/>
+            <a:srgbClr val="5A378C"/>
           </a:solidFill>
           <a:ln w="12700">
-            <a:solidFill>
-              <a:srgbClr val="BFDBFE"/>
-            </a:solidFill>
+            <a:noFill/>
             <a:prstDash val="solid"/>
           </a:ln>
         </p:spPr>
@@ -8305,12 +8377,10 @@
             <a:avLst/>
           </a:prstGeom>
           <a:solidFill>
-            <a:srgbClr val="EFF6FF"/>
+            <a:srgbClr val="1B365D"/>
           </a:solidFill>
           <a:ln w="12700">
-            <a:solidFill>
-              <a:srgbClr val="BFDBFE"/>
-            </a:solidFill>
+            <a:noFill/>
             <a:prstDash val="solid"/>
           </a:ln>
         </p:spPr>
@@ -8431,12 +8501,10 @@
             <a:avLst/>
           </a:prstGeom>
           <a:solidFill>
-            <a:srgbClr val="F8FAFC"/>
+            <a:srgbClr val="1B365D"/>
           </a:solidFill>
           <a:ln w="12700">
-            <a:solidFill>
-              <a:srgbClr val="E2E8F0"/>
-            </a:solidFill>
+            <a:noFill/>
             <a:prstDash val="solid"/>
           </a:ln>
         </p:spPr>
@@ -8520,12 +8588,10 @@
             <a:avLst/>
           </a:prstGeom>
           <a:solidFill>
-            <a:srgbClr val="F8FAFC"/>
+            <a:srgbClr val="1E7E34"/>
           </a:solidFill>
           <a:ln w="12700">
-            <a:solidFill>
-              <a:srgbClr val="E2E8F0"/>
-            </a:solidFill>
+            <a:noFill/>
             <a:prstDash val="solid"/>
           </a:ln>
         </p:spPr>
@@ -8648,12 +8714,10 @@
             </a:avLst>
           </a:prstGeom>
           <a:solidFill>
-            <a:srgbClr val="EFF6FF"/>
+            <a:srgbClr val="1E7E34"/>
           </a:solidFill>
           <a:ln w="12700">
-            <a:solidFill>
-              <a:srgbClr val="BFDBFE"/>
-            </a:solidFill>
+            <a:noFill/>
             <a:prstDash val="solid"/>
           </a:ln>
         </p:spPr>
@@ -8681,11 +8745,12 @@
           <a:p>
             <a:pPr indent="0" marL="0">
               <a:buNone/>
+              <a:defRPr b="1"/>
             </a:pPr>
             <a:r>
               <a:rPr sz="1100" b="1">
                 <a:solidFill>
-                  <a:srgbClr val="1E3A8A"/>
+                  <a:srgbClr val="FFFFFF"/>
                 </a:solidFill>
                 <a:latin typeface="Calibri"/>
               </a:rPr>
@@ -8718,11 +8783,12 @@
           <a:p>
             <a:pPr indent="0" marL="0">
               <a:buNone/>
+              <a:defRPr b="1"/>
             </a:pPr>
             <a:r>
               <a:rPr sz="1050" b="1">
                 <a:solidFill>
-                  <a:srgbClr val="0F172A"/>
+                  <a:srgbClr val="FFFFFF"/>
                 </a:solidFill>
                 <a:latin typeface="Calibri"/>
               </a:rPr>
@@ -8759,7 +8825,7 @@
             <a:r>
               <a:rPr sz="1000" b="0">
                 <a:solidFill>
-                  <a:srgbClr val="0F172A"/>
+                  <a:srgbClr val="DCFCE7"/>
                 </a:solidFill>
                 <a:latin typeface="Calibri"/>
               </a:rPr>
@@ -8784,9 +8850,9 @@
             <a:avLst/>
           </a:prstGeom>
           <a:noFill/>
-          <a:ln w="22225">
+          <a:ln w="25400">
             <a:solidFill>
-              <a:srgbClr val="5B6472"/>
+              <a:srgbClr val="1B365D"/>
             </a:solidFill>
             <a:prstDash val="solid"/>
             <a:tailEnd type="triangle"/>
@@ -8810,12 +8876,10 @@
             </a:avLst>
           </a:prstGeom>
           <a:solidFill>
-            <a:srgbClr val="F8FAFC"/>
+            <a:srgbClr val="C05621"/>
           </a:solidFill>
           <a:ln w="12700">
-            <a:solidFill>
-              <a:srgbClr val="E2E8F0"/>
-            </a:solidFill>
+            <a:noFill/>
             <a:prstDash val="solid"/>
           </a:ln>
         </p:spPr>
@@ -8843,11 +8907,12 @@
           <a:p>
             <a:pPr indent="0" marL="0">
               <a:buNone/>
+              <a:defRPr b="1"/>
             </a:pPr>
             <a:r>
               <a:rPr sz="1100" b="1">
                 <a:solidFill>
-                  <a:srgbClr val="1E3A8A"/>
+                  <a:srgbClr val="FFFFFF"/>
                 </a:solidFill>
                 <a:latin typeface="Calibri"/>
               </a:rPr>
@@ -8880,11 +8945,12 @@
           <a:p>
             <a:pPr indent="0" marL="0">
               <a:buNone/>
+              <a:defRPr b="1"/>
             </a:pPr>
             <a:r>
               <a:rPr sz="1050" b="1">
                 <a:solidFill>
-                  <a:srgbClr val="0F172A"/>
+                  <a:srgbClr val="FFFFFF"/>
                 </a:solidFill>
                 <a:latin typeface="Calibri"/>
               </a:rPr>
@@ -8921,7 +8987,7 @@
             <a:r>
               <a:rPr sz="1000" b="0">
                 <a:solidFill>
-                  <a:srgbClr val="0F172A"/>
+                  <a:srgbClr val="FEF3C7"/>
                 </a:solidFill>
                 <a:latin typeface="Calibri"/>
               </a:rPr>
@@ -8946,9 +9012,9 @@
             <a:avLst/>
           </a:prstGeom>
           <a:noFill/>
-          <a:ln w="22225">
+          <a:ln w="25400">
             <a:solidFill>
-              <a:srgbClr val="5B6472"/>
+              <a:srgbClr val="1B365D"/>
             </a:solidFill>
             <a:prstDash val="solid"/>
             <a:tailEnd type="triangle"/>
@@ -8972,12 +9038,10 @@
             </a:avLst>
           </a:prstGeom>
           <a:solidFill>
-            <a:srgbClr val="EFF6FF"/>
+            <a:srgbClr val="5A378C"/>
           </a:solidFill>
           <a:ln w="12700">
-            <a:solidFill>
-              <a:srgbClr val="BFDBFE"/>
-            </a:solidFill>
+            <a:noFill/>
             <a:prstDash val="solid"/>
           </a:ln>
         </p:spPr>
@@ -9005,11 +9069,12 @@
           <a:p>
             <a:pPr indent="0" marL="0">
               <a:buNone/>
+              <a:defRPr b="1"/>
             </a:pPr>
             <a:r>
               <a:rPr sz="1100" b="1">
                 <a:solidFill>
-                  <a:srgbClr val="1E3A8A"/>
+                  <a:srgbClr val="FFFFFF"/>
                 </a:solidFill>
                 <a:latin typeface="Calibri"/>
               </a:rPr>
@@ -9042,11 +9107,12 @@
           <a:p>
             <a:pPr indent="0" marL="0">
               <a:buNone/>
+              <a:defRPr b="1"/>
             </a:pPr>
             <a:r>
               <a:rPr sz="1050" b="1">
                 <a:solidFill>
-                  <a:srgbClr val="0F172A"/>
+                  <a:srgbClr val="FFFFFF"/>
                 </a:solidFill>
                 <a:latin typeface="Calibri"/>
               </a:rPr>
@@ -9083,7 +9149,7 @@
             <a:r>
               <a:rPr sz="1000" b="0">
                 <a:solidFill>
-                  <a:srgbClr val="0F172A"/>
+                  <a:srgbClr val="F3E8FF"/>
                 </a:solidFill>
                 <a:latin typeface="Calibri"/>
               </a:rPr>
@@ -9145,12 +9211,10 @@
             <a:avLst/>
           </a:prstGeom>
           <a:solidFill>
-            <a:srgbClr val="EFF6FF"/>
+            <a:srgbClr val="1B365D"/>
           </a:solidFill>
           <a:ln w="12700">
-            <a:solidFill>
-              <a:srgbClr val="BFDBFE"/>
-            </a:solidFill>
+            <a:noFill/>
             <a:prstDash val="solid"/>
           </a:ln>
         </p:spPr>
@@ -9178,11 +9242,12 @@
           <a:p>
             <a:pPr algn="ctr" indent="0" marL="0">
               <a:buNone/>
+              <a:defRPr b="1"/>
             </a:pPr>
             <a:r>
               <a:rPr sz="1200" b="1">
                 <a:solidFill>
-                  <a:srgbClr val="0F172A"/>
+                  <a:srgbClr val="FFFFFF"/>
                 </a:solidFill>
                 <a:latin typeface="Calibri"/>
               </a:rPr>
@@ -9244,12 +9309,10 @@
             <a:avLst/>
           </a:prstGeom>
           <a:solidFill>
-            <a:srgbClr val="EFF6FF"/>
+            <a:srgbClr val="1E7E34"/>
           </a:solidFill>
           <a:ln w="12700">
-            <a:solidFill>
-              <a:srgbClr val="BFDBFE"/>
-            </a:solidFill>
+            <a:noFill/>
             <a:prstDash val="solid"/>
           </a:ln>
         </p:spPr>
@@ -9277,11 +9340,12 @@
           <a:p>
             <a:pPr algn="ctr" indent="0" marL="0">
               <a:buNone/>
+              <a:defRPr b="1"/>
             </a:pPr>
             <a:r>
               <a:rPr sz="1200" b="1">
                 <a:solidFill>
-                  <a:srgbClr val="0F172A"/>
+                  <a:srgbClr val="FFFFFF"/>
                 </a:solidFill>
                 <a:latin typeface="Calibri"/>
               </a:rPr>
@@ -9343,12 +9407,10 @@
             <a:avLst/>
           </a:prstGeom>
           <a:solidFill>
-            <a:srgbClr val="EFF6FF"/>
+            <a:srgbClr val="C05621"/>
           </a:solidFill>
           <a:ln w="12700">
-            <a:solidFill>
-              <a:srgbClr val="BFDBFE"/>
-            </a:solidFill>
+            <a:noFill/>
             <a:prstDash val="solid"/>
           </a:ln>
         </p:spPr>
@@ -9376,11 +9438,12 @@
           <a:p>
             <a:pPr algn="ctr" indent="0" marL="0">
               <a:buNone/>
+              <a:defRPr b="1"/>
             </a:pPr>
             <a:r>
               <a:rPr sz="1200" b="1">
                 <a:solidFill>
-                  <a:srgbClr val="0F172A"/>
+                  <a:srgbClr val="FFFFFF"/>
                 </a:solidFill>
                 <a:latin typeface="Calibri"/>
               </a:rPr>
@@ -9442,12 +9505,10 @@
             <a:avLst/>
           </a:prstGeom>
           <a:solidFill>
-            <a:srgbClr val="EFF6FF"/>
+            <a:srgbClr val="5A378C"/>
           </a:solidFill>
           <a:ln w="12700">
-            <a:solidFill>
-              <a:srgbClr val="BFDBFE"/>
-            </a:solidFill>
+            <a:noFill/>
             <a:prstDash val="solid"/>
           </a:ln>
         </p:spPr>
@@ -9475,11 +9536,12 @@
           <a:p>
             <a:pPr algn="ctr" indent="0" marL="0">
               <a:buNone/>
+              <a:defRPr b="1"/>
             </a:pPr>
             <a:r>
               <a:rPr sz="1200" b="1">
                 <a:solidFill>
-                  <a:srgbClr val="0F172A"/>
+                  <a:srgbClr val="FFFFFF"/>
                 </a:solidFill>
                 <a:latin typeface="Calibri"/>
               </a:rPr>
@@ -9541,12 +9603,10 @@
             <a:avLst/>
           </a:prstGeom>
           <a:solidFill>
-            <a:srgbClr val="EFF6FF"/>
+            <a:srgbClr val="1B365D"/>
           </a:solidFill>
           <a:ln w="12700">
-            <a:solidFill>
-              <a:srgbClr val="BFDBFE"/>
-            </a:solidFill>
+            <a:noFill/>
             <a:prstDash val="solid"/>
           </a:ln>
         </p:spPr>
@@ -9574,11 +9634,12 @@
           <a:p>
             <a:pPr algn="ctr" indent="0" marL="0">
               <a:buNone/>
+              <a:defRPr b="1"/>
             </a:pPr>
             <a:r>
               <a:rPr sz="1200" b="1">
                 <a:solidFill>
-                  <a:srgbClr val="0F172A"/>
+                  <a:srgbClr val="FFFFFF"/>
                 </a:solidFill>
                 <a:latin typeface="Calibri"/>
               </a:rPr>
@@ -9640,12 +9701,10 @@
             <a:avLst/>
           </a:prstGeom>
           <a:solidFill>
-            <a:srgbClr val="EFF6FF"/>
+            <a:srgbClr val="1E7E34"/>
           </a:solidFill>
           <a:ln w="12700">
-            <a:solidFill>
-              <a:srgbClr val="BFDBFE"/>
-            </a:solidFill>
+            <a:noFill/>
             <a:prstDash val="solid"/>
           </a:ln>
         </p:spPr>
@@ -9673,11 +9732,12 @@
           <a:p>
             <a:pPr algn="ctr" indent="0" marL="0">
               <a:buNone/>
+              <a:defRPr b="1"/>
             </a:pPr>
             <a:r>
               <a:rPr sz="1200" b="1">
                 <a:solidFill>
-                  <a:srgbClr val="0F172A"/>
+                  <a:srgbClr val="FFFFFF"/>
                 </a:solidFill>
                 <a:latin typeface="Calibri"/>
               </a:rPr>
@@ -9739,12 +9799,10 @@
             <a:avLst/>
           </a:prstGeom>
           <a:solidFill>
-            <a:srgbClr val="EFF6FF"/>
+            <a:srgbClr val="C05621"/>
           </a:solidFill>
           <a:ln w="12700">
-            <a:solidFill>
-              <a:srgbClr val="BFDBFE"/>
-            </a:solidFill>
+            <a:noFill/>
             <a:prstDash val="solid"/>
           </a:ln>
         </p:spPr>
@@ -9772,11 +9830,12 @@
           <a:p>
             <a:pPr algn="ctr" indent="0" marL="0">
               <a:buNone/>
+              <a:defRPr b="1"/>
             </a:pPr>
             <a:r>
               <a:rPr sz="1200" b="1">
                 <a:solidFill>
-                  <a:srgbClr val="0F172A"/>
+                  <a:srgbClr val="FFFFFF"/>
                 </a:solidFill>
                 <a:latin typeface="Calibri"/>
               </a:rPr>
@@ -9838,12 +9897,10 @@
             <a:avLst/>
           </a:prstGeom>
           <a:solidFill>
-            <a:srgbClr val="EFF6FF"/>
+            <a:srgbClr val="5A378C"/>
           </a:solidFill>
           <a:ln w="12700">
-            <a:solidFill>
-              <a:srgbClr val="BFDBFE"/>
-            </a:solidFill>
+            <a:noFill/>
             <a:prstDash val="solid"/>
           </a:ln>
         </p:spPr>
@@ -9871,11 +9928,12 @@
           <a:p>
             <a:pPr algn="ctr" indent="0" marL="0">
               <a:buNone/>
+              <a:defRPr b="1"/>
             </a:pPr>
             <a:r>
               <a:rPr sz="1200" b="1">
                 <a:solidFill>
-                  <a:srgbClr val="0F172A"/>
+                  <a:srgbClr val="FFFFFF"/>
                 </a:solidFill>
                 <a:latin typeface="Calibri"/>
               </a:rPr>
@@ -10199,12 +10257,10 @@
             <a:avLst/>
           </a:prstGeom>
           <a:solidFill>
-            <a:srgbClr val="EFF6FF"/>
+            <a:srgbClr val="1B365D"/>
           </a:solidFill>
           <a:ln w="12700">
-            <a:solidFill>
-              <a:srgbClr val="BFDBFE"/>
-            </a:solidFill>
+            <a:noFill/>
             <a:prstDash val="solid"/>
           </a:ln>
         </p:spPr>
@@ -10232,11 +10288,12 @@
           <a:p>
             <a:pPr algn="ctr" indent="0" marL="0">
               <a:buNone/>
+              <a:defRPr b="1"/>
             </a:pPr>
             <a:r>
               <a:rPr sz="1200" b="1">
                 <a:solidFill>
-                  <a:srgbClr val="0F172A"/>
+                  <a:srgbClr val="FFFFFF"/>
                 </a:solidFill>
                 <a:latin typeface="Calibri"/>
               </a:rPr>
@@ -10358,12 +10415,10 @@
             <a:avLst/>
           </a:prstGeom>
           <a:solidFill>
-            <a:srgbClr val="EFF6FF"/>
+            <a:srgbClr val="1E7E34"/>
           </a:solidFill>
           <a:ln w="12700">
-            <a:solidFill>
-              <a:srgbClr val="BFDBFE"/>
-            </a:solidFill>
+            <a:noFill/>
             <a:prstDash val="solid"/>
           </a:ln>
         </p:spPr>
@@ -10391,11 +10446,12 @@
           <a:p>
             <a:pPr algn="ctr" indent="0" marL="0">
               <a:buNone/>
+              <a:defRPr b="1"/>
             </a:pPr>
             <a:r>
               <a:rPr sz="1200" b="1">
                 <a:solidFill>
-                  <a:srgbClr val="0F172A"/>
+                  <a:srgbClr val="FFFFFF"/>
                 </a:solidFill>
                 <a:latin typeface="Calibri"/>
               </a:rPr>
@@ -10517,12 +10573,10 @@
             <a:avLst/>
           </a:prstGeom>
           <a:solidFill>
-            <a:srgbClr val="EFF6FF"/>
+            <a:srgbClr val="C05621"/>
           </a:solidFill>
           <a:ln w="12700">
-            <a:solidFill>
-              <a:srgbClr val="BFDBFE"/>
-            </a:solidFill>
+            <a:noFill/>
             <a:prstDash val="solid"/>
           </a:ln>
         </p:spPr>
@@ -10550,11 +10604,12 @@
           <a:p>
             <a:pPr algn="ctr" indent="0" marL="0">
               <a:buNone/>
+              <a:defRPr b="1"/>
             </a:pPr>
             <a:r>
               <a:rPr sz="1200" b="1">
                 <a:solidFill>
-                  <a:srgbClr val="0F172A"/>
+                  <a:srgbClr val="FFFFFF"/>
                 </a:solidFill>
                 <a:latin typeface="Calibri"/>
               </a:rPr>
@@ -10676,12 +10731,10 @@
             <a:avLst/>
           </a:prstGeom>
           <a:solidFill>
-            <a:srgbClr val="EFF6FF"/>
+            <a:srgbClr val="5A378C"/>
           </a:solidFill>
           <a:ln w="12700">
-            <a:solidFill>
-              <a:srgbClr val="BFDBFE"/>
-            </a:solidFill>
+            <a:noFill/>
             <a:prstDash val="solid"/>
           </a:ln>
         </p:spPr>
@@ -10709,11 +10762,12 @@
           <a:p>
             <a:pPr algn="ctr" indent="0" marL="0">
               <a:buNone/>
+              <a:defRPr b="1"/>
             </a:pPr>
             <a:r>
               <a:rPr sz="1200" b="1">
                 <a:solidFill>
-                  <a:srgbClr val="0F172A"/>
+                  <a:srgbClr val="FFFFFF"/>
                 </a:solidFill>
                 <a:latin typeface="Calibri"/>
               </a:rPr>
@@ -10835,12 +10889,10 @@
             <a:avLst/>
           </a:prstGeom>
           <a:solidFill>
-            <a:srgbClr val="EFF6FF"/>
+            <a:srgbClr val="1B365D"/>
           </a:solidFill>
           <a:ln w="12700">
-            <a:solidFill>
-              <a:srgbClr val="BFDBFE"/>
-            </a:solidFill>
+            <a:noFill/>
             <a:prstDash val="solid"/>
           </a:ln>
         </p:spPr>
@@ -10868,11 +10920,12 @@
           <a:p>
             <a:pPr algn="ctr" indent="0" marL="0">
               <a:buNone/>
+              <a:defRPr b="1"/>
             </a:pPr>
             <a:r>
               <a:rPr sz="1200" b="1">
                 <a:solidFill>
-                  <a:srgbClr val="0F172A"/>
+                  <a:srgbClr val="FFFFFF"/>
                 </a:solidFill>
                 <a:latin typeface="Calibri"/>
               </a:rPr>
@@ -10994,12 +11047,10 @@
             <a:avLst/>
           </a:prstGeom>
           <a:solidFill>
-            <a:srgbClr val="EFF6FF"/>
+            <a:srgbClr val="1E7E34"/>
           </a:solidFill>
           <a:ln w="12700">
-            <a:solidFill>
-              <a:srgbClr val="BFDBFE"/>
-            </a:solidFill>
+            <a:noFill/>
             <a:prstDash val="solid"/>
           </a:ln>
         </p:spPr>
@@ -11027,11 +11078,12 @@
           <a:p>
             <a:pPr algn="ctr" indent="0" marL="0">
               <a:buNone/>
+              <a:defRPr b="1"/>
             </a:pPr>
             <a:r>
               <a:rPr sz="1200" b="1">
                 <a:solidFill>
-                  <a:srgbClr val="0F172A"/>
+                  <a:srgbClr val="FFFFFF"/>
                 </a:solidFill>
                 <a:latin typeface="Calibri"/>
               </a:rPr>
@@ -11153,12 +11205,10 @@
             <a:avLst/>
           </a:prstGeom>
           <a:solidFill>
-            <a:srgbClr val="EFF6FF"/>
+            <a:srgbClr val="C05621"/>
           </a:solidFill>
           <a:ln w="12700">
-            <a:solidFill>
-              <a:srgbClr val="BFDBFE"/>
-            </a:solidFill>
+            <a:noFill/>
             <a:prstDash val="solid"/>
           </a:ln>
         </p:spPr>
@@ -11186,11 +11236,12 @@
           <a:p>
             <a:pPr algn="ctr" indent="0" marL="0">
               <a:buNone/>
+              <a:defRPr b="1"/>
             </a:pPr>
             <a:r>
               <a:rPr sz="1200" b="1">
                 <a:solidFill>
-                  <a:srgbClr val="0F172A"/>
+                  <a:srgbClr val="FFFFFF"/>
                 </a:solidFill>
                 <a:latin typeface="Calibri"/>
               </a:rPr>
@@ -11312,12 +11363,10 @@
             <a:avLst/>
           </a:prstGeom>
           <a:solidFill>
-            <a:srgbClr val="EFF6FF"/>
+            <a:srgbClr val="5A378C"/>
           </a:solidFill>
           <a:ln w="12700">
-            <a:solidFill>
-              <a:srgbClr val="BFDBFE"/>
-            </a:solidFill>
+            <a:noFill/>
             <a:prstDash val="solid"/>
           </a:ln>
         </p:spPr>
@@ -11345,11 +11394,12 @@
           <a:p>
             <a:pPr algn="ctr" indent="0" marL="0">
               <a:buNone/>
+              <a:defRPr b="1"/>
             </a:pPr>
             <a:r>
               <a:rPr sz="1200" b="1">
                 <a:solidFill>
-                  <a:srgbClr val="0F172A"/>
+                  <a:srgbClr val="FFFFFF"/>
                 </a:solidFill>
                 <a:latin typeface="Calibri"/>
               </a:rPr>
@@ -11473,11 +11523,11 @@
             </a:avLst>
           </a:prstGeom>
           <a:solidFill>
-            <a:srgbClr val="EFF6FF"/>
+            <a:srgbClr val="801818"/>
           </a:solidFill>
           <a:ln w="19050">
             <a:solidFill>
-              <a:srgbClr val="1E3A8A"/>
+              <a:srgbClr val="8C2D19"/>
             </a:solidFill>
             <a:prstDash val="solid"/>
           </a:ln>
@@ -11513,7 +11563,7 @@
             <a:r>
               <a:rPr sz="1000" b="0">
                 <a:solidFill>
-                  <a:srgbClr val="0F172A"/>
+                  <a:srgbClr val="FFFFFF"/>
                 </a:solidFill>
                 <a:latin typeface="Calibri"/>
               </a:rPr>

</xml_diff>